<commit_message>
Drop Ferraz (Brazil); remove About box; compact layouts; trim Sources
- Brazil trade section now shows only Marcio Fernando Elias Rosa
  (full-width, restored richer bio); Ferraz removed from deck and
  workbook notes per preparer direction.
- Methodology slide: "About this document" panel removed.
- Sources slide reduced to Datasets & Vintages (measurement notes,
  imagery & format, and scope sections removed; caveats remain in
  GAPS.md and the research file).
- Profile blocks re-spaced after portrait removal: name/title/ministry
  /bio now sit on a compact rhythm with no leftover portrait gaps;
  full-width profiles use their richer bios (up to ~90 words).
- QA geometry updated; 629 checks pass.

Co-Authored-By: Claude Fable 5 <noreply@anthropic.com>
Claude-Session: https://claude.ai/code/session_01D7VNHN8h6qLVjZi6Tzyhub
</commit_message>
<xml_diff>
--- a/output/g20-ministers-trade-deck.pptx
+++ b/output/g20-ministers-trade-deck.pptx
@@ -4244,8 +4244,8 @@
         </p:nvSpPr>
         <p:spPr>
           <a:xfrm>
-            <a:off x="3611880" y="1426464"/>
-            <a:ext cx="8028431" cy="274320"/>
+            <a:off x="3611880" y="1408176"/>
+            <a:ext cx="8028431" cy="256032"/>
           </a:xfrm>
           <a:prstGeom prst="rect">
             <a:avLst/>
@@ -4278,8 +4278,8 @@
         </p:nvSpPr>
         <p:spPr>
           <a:xfrm>
-            <a:off x="3611880" y="1719072"/>
-            <a:ext cx="8028431" cy="420624"/>
+            <a:off x="3611880" y="1682495"/>
+            <a:ext cx="8028431" cy="347472"/>
           </a:xfrm>
           <a:prstGeom prst="rect">
             <a:avLst/>
@@ -4317,8 +4317,8 @@
         </p:nvSpPr>
         <p:spPr>
           <a:xfrm>
-            <a:off x="3611880" y="2157984"/>
-            <a:ext cx="8028431" cy="347472"/>
+            <a:off x="3611880" y="2048256"/>
+            <a:ext cx="8028431" cy="292608"/>
           </a:xfrm>
           <a:prstGeom prst="rect">
             <a:avLst/>
@@ -4365,8 +4365,8 @@
         </p:nvSpPr>
         <p:spPr>
           <a:xfrm>
-            <a:off x="3611880" y="2578608"/>
-            <a:ext cx="8028431" cy="1152143"/>
+            <a:off x="3611880" y="2377440"/>
+            <a:ext cx="8028431" cy="1353311"/>
           </a:xfrm>
           <a:prstGeom prst="rect">
             <a:avLst/>
@@ -4474,8 +4474,8 @@
         </p:nvSpPr>
         <p:spPr>
           <a:xfrm>
-            <a:off x="3611880" y="4059935"/>
-            <a:ext cx="8028431" cy="274320"/>
+            <a:off x="3611880" y="4041648"/>
+            <a:ext cx="8028431" cy="256032"/>
           </a:xfrm>
           <a:prstGeom prst="rect">
             <a:avLst/>
@@ -4508,8 +4508,8 @@
         </p:nvSpPr>
         <p:spPr>
           <a:xfrm>
-            <a:off x="3611880" y="4352544"/>
-            <a:ext cx="8028431" cy="420624"/>
+            <a:off x="3611880" y="4315968"/>
+            <a:ext cx="8028431" cy="347472"/>
           </a:xfrm>
           <a:prstGeom prst="rect">
             <a:avLst/>
@@ -4547,8 +4547,8 @@
         </p:nvSpPr>
         <p:spPr>
           <a:xfrm>
-            <a:off x="3611880" y="4791456"/>
-            <a:ext cx="8028431" cy="347472"/>
+            <a:off x="3611880" y="4681727"/>
+            <a:ext cx="8028431" cy="292608"/>
           </a:xfrm>
           <a:prstGeom prst="rect">
             <a:avLst/>
@@ -4595,8 +4595,8 @@
         </p:nvSpPr>
         <p:spPr>
           <a:xfrm>
-            <a:off x="3611880" y="5212079"/>
-            <a:ext cx="8028431" cy="1152143"/>
+            <a:off x="3611880" y="5010912"/>
+            <a:ext cx="8028431" cy="1353311"/>
           </a:xfrm>
           <a:prstGeom prst="rect">
             <a:avLst/>
@@ -5414,8 +5414,8 @@
         </p:nvSpPr>
         <p:spPr>
           <a:xfrm>
-            <a:off x="3611880" y="1426464"/>
-            <a:ext cx="8028431" cy="274320"/>
+            <a:off x="3611880" y="1408176"/>
+            <a:ext cx="8028431" cy="256032"/>
           </a:xfrm>
           <a:prstGeom prst="rect">
             <a:avLst/>
@@ -5448,8 +5448,8 @@
         </p:nvSpPr>
         <p:spPr>
           <a:xfrm>
-            <a:off x="3611880" y="1719072"/>
-            <a:ext cx="8028431" cy="420624"/>
+            <a:off x="3611880" y="1682495"/>
+            <a:ext cx="8028431" cy="347472"/>
           </a:xfrm>
           <a:prstGeom prst="rect">
             <a:avLst/>
@@ -5487,8 +5487,8 @@
         </p:nvSpPr>
         <p:spPr>
           <a:xfrm>
-            <a:off x="3611880" y="2157984"/>
-            <a:ext cx="8028431" cy="347472"/>
+            <a:off x="3611880" y="2048256"/>
+            <a:ext cx="8028431" cy="292608"/>
           </a:xfrm>
           <a:prstGeom prst="rect">
             <a:avLst/>
@@ -5535,8 +5535,8 @@
         </p:nvSpPr>
         <p:spPr>
           <a:xfrm>
-            <a:off x="3611880" y="2578608"/>
-            <a:ext cx="8028431" cy="1152143"/>
+            <a:off x="3611880" y="2377440"/>
+            <a:ext cx="8028431" cy="1353311"/>
           </a:xfrm>
           <a:prstGeom prst="rect">
             <a:avLst/>
@@ -5644,8 +5644,8 @@
         </p:nvSpPr>
         <p:spPr>
           <a:xfrm>
-            <a:off x="3611880" y="4059935"/>
-            <a:ext cx="8028431" cy="274320"/>
+            <a:off x="3611880" y="4041648"/>
+            <a:ext cx="8028431" cy="256032"/>
           </a:xfrm>
           <a:prstGeom prst="rect">
             <a:avLst/>
@@ -5678,8 +5678,8 @@
         </p:nvSpPr>
         <p:spPr>
           <a:xfrm>
-            <a:off x="3611880" y="4352544"/>
-            <a:ext cx="8028431" cy="420624"/>
+            <a:off x="3611880" y="4315968"/>
+            <a:ext cx="8028431" cy="347472"/>
           </a:xfrm>
           <a:prstGeom prst="rect">
             <a:avLst/>
@@ -5717,8 +5717,8 @@
         </p:nvSpPr>
         <p:spPr>
           <a:xfrm>
-            <a:off x="3611880" y="4791456"/>
-            <a:ext cx="8028431" cy="347472"/>
+            <a:off x="3611880" y="4681727"/>
+            <a:ext cx="8028431" cy="292608"/>
           </a:xfrm>
           <a:prstGeom prst="rect">
             <a:avLst/>
@@ -5765,8 +5765,8 @@
         </p:nvSpPr>
         <p:spPr>
           <a:xfrm>
-            <a:off x="3611880" y="5212079"/>
-            <a:ext cx="8028431" cy="1152143"/>
+            <a:off x="3611880" y="5010912"/>
+            <a:ext cx="8028431" cy="1353311"/>
           </a:xfrm>
           <a:prstGeom prst="rect">
             <a:avLst/>
@@ -6600,8 +6600,8 @@
         </p:nvSpPr>
         <p:spPr>
           <a:xfrm>
-            <a:off x="3611880" y="1426464"/>
-            <a:ext cx="8028431" cy="274320"/>
+            <a:off x="3611880" y="1408176"/>
+            <a:ext cx="8028431" cy="256032"/>
           </a:xfrm>
           <a:prstGeom prst="rect">
             <a:avLst/>
@@ -6634,8 +6634,8 @@
         </p:nvSpPr>
         <p:spPr>
           <a:xfrm>
-            <a:off x="3611880" y="1719072"/>
-            <a:ext cx="8028431" cy="420624"/>
+            <a:off x="3611880" y="1682495"/>
+            <a:ext cx="8028431" cy="347472"/>
           </a:xfrm>
           <a:prstGeom prst="rect">
             <a:avLst/>
@@ -6673,8 +6673,8 @@
         </p:nvSpPr>
         <p:spPr>
           <a:xfrm>
-            <a:off x="3611880" y="2157984"/>
-            <a:ext cx="8028431" cy="347472"/>
+            <a:off x="3611880" y="2048256"/>
+            <a:ext cx="8028431" cy="292608"/>
           </a:xfrm>
           <a:prstGeom prst="rect">
             <a:avLst/>
@@ -6721,8 +6721,8 @@
         </p:nvSpPr>
         <p:spPr>
           <a:xfrm>
-            <a:off x="3611880" y="2578608"/>
-            <a:ext cx="8028431" cy="1152143"/>
+            <a:off x="3611880" y="2377440"/>
+            <a:ext cx="8028431" cy="1353311"/>
           </a:xfrm>
           <a:prstGeom prst="rect">
             <a:avLst/>
@@ -6846,8 +6846,8 @@
         </p:nvSpPr>
         <p:spPr>
           <a:xfrm>
-            <a:off x="3611880" y="4041648"/>
-            <a:ext cx="3849624" cy="1152144"/>
+            <a:off x="3611880" y="4023359"/>
+            <a:ext cx="3849624" cy="914400"/>
           </a:xfrm>
           <a:prstGeom prst="rect">
             <a:avLst/>
@@ -6915,8 +6915,8 @@
         </p:nvSpPr>
         <p:spPr>
           <a:xfrm>
-            <a:off x="3611880" y="5047488"/>
-            <a:ext cx="3849624" cy="310896"/>
+            <a:off x="3611880" y="4956048"/>
+            <a:ext cx="3849624" cy="292608"/>
           </a:xfrm>
           <a:prstGeom prst="rect">
             <a:avLst/>
@@ -6963,8 +6963,8 @@
         </p:nvSpPr>
         <p:spPr>
           <a:xfrm>
-            <a:off x="3611880" y="5376672"/>
-            <a:ext cx="3849624" cy="987551"/>
+            <a:off x="3611880" y="5266944"/>
+            <a:ext cx="3849624" cy="1097279"/>
           </a:xfrm>
           <a:prstGeom prst="rect">
             <a:avLst/>
@@ -7002,8 +7002,8 @@
         </p:nvSpPr>
         <p:spPr>
           <a:xfrm>
-            <a:off x="7790688" y="4041648"/>
-            <a:ext cx="3849624" cy="1152144"/>
+            <a:off x="7790688" y="4023359"/>
+            <a:ext cx="3849624" cy="914400"/>
           </a:xfrm>
           <a:prstGeom prst="rect">
             <a:avLst/>
@@ -7071,8 +7071,8 @@
         </p:nvSpPr>
         <p:spPr>
           <a:xfrm>
-            <a:off x="7790688" y="5047488"/>
-            <a:ext cx="3849624" cy="310896"/>
+            <a:off x="7790688" y="4956048"/>
+            <a:ext cx="3849624" cy="292608"/>
           </a:xfrm>
           <a:prstGeom prst="rect">
             <a:avLst/>
@@ -7119,8 +7119,8 @@
         </p:nvSpPr>
         <p:spPr>
           <a:xfrm>
-            <a:off x="7790688" y="5376672"/>
-            <a:ext cx="3849624" cy="987551"/>
+            <a:off x="7790688" y="5266944"/>
+            <a:ext cx="3849624" cy="1097279"/>
           </a:xfrm>
           <a:prstGeom prst="rect">
             <a:avLst/>
@@ -7938,8 +7938,8 @@
         </p:nvSpPr>
         <p:spPr>
           <a:xfrm>
-            <a:off x="3611880" y="1426464"/>
-            <a:ext cx="8028431" cy="274320"/>
+            <a:off x="3611880" y="1408176"/>
+            <a:ext cx="8028431" cy="256032"/>
           </a:xfrm>
           <a:prstGeom prst="rect">
             <a:avLst/>
@@ -7972,8 +7972,8 @@
         </p:nvSpPr>
         <p:spPr>
           <a:xfrm>
-            <a:off x="3611880" y="1719072"/>
-            <a:ext cx="8028431" cy="420624"/>
+            <a:off x="3611880" y="1682495"/>
+            <a:ext cx="8028431" cy="347472"/>
           </a:xfrm>
           <a:prstGeom prst="rect">
             <a:avLst/>
@@ -8011,8 +8011,8 @@
         </p:nvSpPr>
         <p:spPr>
           <a:xfrm>
-            <a:off x="3611880" y="2157984"/>
-            <a:ext cx="8028431" cy="347472"/>
+            <a:off x="3611880" y="2048256"/>
+            <a:ext cx="8028431" cy="292608"/>
           </a:xfrm>
           <a:prstGeom prst="rect">
             <a:avLst/>
@@ -8059,8 +8059,8 @@
         </p:nvSpPr>
         <p:spPr>
           <a:xfrm>
-            <a:off x="3611880" y="2578608"/>
-            <a:ext cx="8028431" cy="1152143"/>
+            <a:off x="3611880" y="2377440"/>
+            <a:ext cx="8028431" cy="1353311"/>
           </a:xfrm>
           <a:prstGeom prst="rect">
             <a:avLst/>
@@ -8168,8 +8168,8 @@
         </p:nvSpPr>
         <p:spPr>
           <a:xfrm>
-            <a:off x="3611880" y="4041648"/>
-            <a:ext cx="3849624" cy="1152144"/>
+            <a:off x="3611880" y="4023359"/>
+            <a:ext cx="3849624" cy="914400"/>
           </a:xfrm>
           <a:prstGeom prst="rect">
             <a:avLst/>
@@ -8237,8 +8237,8 @@
         </p:nvSpPr>
         <p:spPr>
           <a:xfrm>
-            <a:off x="3611880" y="5047488"/>
-            <a:ext cx="3849624" cy="310896"/>
+            <a:off x="3611880" y="4956048"/>
+            <a:ext cx="3849624" cy="292608"/>
           </a:xfrm>
           <a:prstGeom prst="rect">
             <a:avLst/>
@@ -8285,8 +8285,8 @@
         </p:nvSpPr>
         <p:spPr>
           <a:xfrm>
-            <a:off x="3611880" y="5376672"/>
-            <a:ext cx="3849624" cy="987551"/>
+            <a:off x="3611880" y="5266944"/>
+            <a:ext cx="3849624" cy="1097279"/>
           </a:xfrm>
           <a:prstGeom prst="rect">
             <a:avLst/>
@@ -8324,8 +8324,8 @@
         </p:nvSpPr>
         <p:spPr>
           <a:xfrm>
-            <a:off x="7790688" y="4041648"/>
-            <a:ext cx="3849624" cy="1152144"/>
+            <a:off x="7790688" y="4023359"/>
+            <a:ext cx="3849624" cy="914400"/>
           </a:xfrm>
           <a:prstGeom prst="rect">
             <a:avLst/>
@@ -8393,8 +8393,8 @@
         </p:nvSpPr>
         <p:spPr>
           <a:xfrm>
-            <a:off x="7790688" y="5047488"/>
-            <a:ext cx="3849624" cy="310896"/>
+            <a:off x="7790688" y="4956048"/>
+            <a:ext cx="3849624" cy="292608"/>
           </a:xfrm>
           <a:prstGeom prst="rect">
             <a:avLst/>
@@ -8441,8 +8441,8 @@
         </p:nvSpPr>
         <p:spPr>
           <a:xfrm>
-            <a:off x="7790688" y="5376672"/>
-            <a:ext cx="3849624" cy="987551"/>
+            <a:off x="7790688" y="5266944"/>
+            <a:ext cx="3849624" cy="1097279"/>
           </a:xfrm>
           <a:prstGeom prst="rect">
             <a:avLst/>
@@ -9260,8 +9260,8 @@
         </p:nvSpPr>
         <p:spPr>
           <a:xfrm>
-            <a:off x="3611880" y="1426464"/>
-            <a:ext cx="8028431" cy="274320"/>
+            <a:off x="3611880" y="1408176"/>
+            <a:ext cx="8028431" cy="256032"/>
           </a:xfrm>
           <a:prstGeom prst="rect">
             <a:avLst/>
@@ -9294,8 +9294,8 @@
         </p:nvSpPr>
         <p:spPr>
           <a:xfrm>
-            <a:off x="3611880" y="1719072"/>
-            <a:ext cx="8028431" cy="420624"/>
+            <a:off x="3611880" y="1682495"/>
+            <a:ext cx="8028431" cy="347472"/>
           </a:xfrm>
           <a:prstGeom prst="rect">
             <a:avLst/>
@@ -9333,8 +9333,8 @@
         </p:nvSpPr>
         <p:spPr>
           <a:xfrm>
-            <a:off x="3611880" y="2157984"/>
-            <a:ext cx="8028431" cy="347472"/>
+            <a:off x="3611880" y="2048256"/>
+            <a:ext cx="8028431" cy="292608"/>
           </a:xfrm>
           <a:prstGeom prst="rect">
             <a:avLst/>
@@ -9381,8 +9381,8 @@
         </p:nvSpPr>
         <p:spPr>
           <a:xfrm>
-            <a:off x="3611880" y="2578608"/>
-            <a:ext cx="8028431" cy="1152143"/>
+            <a:off x="3611880" y="2377440"/>
+            <a:ext cx="8028431" cy="1353311"/>
           </a:xfrm>
           <a:prstGeom prst="rect">
             <a:avLst/>
@@ -9490,8 +9490,8 @@
         </p:nvSpPr>
         <p:spPr>
           <a:xfrm>
-            <a:off x="3611880" y="4041648"/>
-            <a:ext cx="3849624" cy="1152144"/>
+            <a:off x="3611880" y="4023359"/>
+            <a:ext cx="3849624" cy="914400"/>
           </a:xfrm>
           <a:prstGeom prst="rect">
             <a:avLst/>
@@ -9559,8 +9559,8 @@
         </p:nvSpPr>
         <p:spPr>
           <a:xfrm>
-            <a:off x="3611880" y="5047488"/>
-            <a:ext cx="3849624" cy="310896"/>
+            <a:off x="3611880" y="4956048"/>
+            <a:ext cx="3849624" cy="292608"/>
           </a:xfrm>
           <a:prstGeom prst="rect">
             <a:avLst/>
@@ -9607,8 +9607,8 @@
         </p:nvSpPr>
         <p:spPr>
           <a:xfrm>
-            <a:off x="3611880" y="5376672"/>
-            <a:ext cx="3849624" cy="987551"/>
+            <a:off x="3611880" y="5266944"/>
+            <a:ext cx="3849624" cy="1097279"/>
           </a:xfrm>
           <a:prstGeom prst="rect">
             <a:avLst/>
@@ -9646,8 +9646,8 @@
         </p:nvSpPr>
         <p:spPr>
           <a:xfrm>
-            <a:off x="7790688" y="4041648"/>
-            <a:ext cx="3849624" cy="1152144"/>
+            <a:off x="7790688" y="4023359"/>
+            <a:ext cx="3849624" cy="914400"/>
           </a:xfrm>
           <a:prstGeom prst="rect">
             <a:avLst/>
@@ -9715,8 +9715,8 @@
         </p:nvSpPr>
         <p:spPr>
           <a:xfrm>
-            <a:off x="7790688" y="5047488"/>
-            <a:ext cx="3849624" cy="310896"/>
+            <a:off x="7790688" y="4956048"/>
+            <a:ext cx="3849624" cy="292608"/>
           </a:xfrm>
           <a:prstGeom prst="rect">
             <a:avLst/>
@@ -9763,8 +9763,8 @@
         </p:nvSpPr>
         <p:spPr>
           <a:xfrm>
-            <a:off x="7790688" y="5376672"/>
-            <a:ext cx="3849624" cy="987551"/>
+            <a:off x="7790688" y="5266944"/>
+            <a:ext cx="3849624" cy="1097279"/>
           </a:xfrm>
           <a:prstGeom prst="rect">
             <a:avLst/>
@@ -10582,8 +10582,8 @@
         </p:nvSpPr>
         <p:spPr>
           <a:xfrm>
-            <a:off x="3611880" y="1426464"/>
-            <a:ext cx="8028431" cy="274320"/>
+            <a:off x="3611880" y="1408176"/>
+            <a:ext cx="8028431" cy="256032"/>
           </a:xfrm>
           <a:prstGeom prst="rect">
             <a:avLst/>
@@ -10616,8 +10616,8 @@
         </p:nvSpPr>
         <p:spPr>
           <a:xfrm>
-            <a:off x="3611880" y="1719072"/>
-            <a:ext cx="8028431" cy="420624"/>
+            <a:off x="3611880" y="1682495"/>
+            <a:ext cx="8028431" cy="347472"/>
           </a:xfrm>
           <a:prstGeom prst="rect">
             <a:avLst/>
@@ -10655,8 +10655,8 @@
         </p:nvSpPr>
         <p:spPr>
           <a:xfrm>
-            <a:off x="3611880" y="2157984"/>
-            <a:ext cx="8028431" cy="347472"/>
+            <a:off x="3611880" y="2048256"/>
+            <a:ext cx="8028431" cy="292608"/>
           </a:xfrm>
           <a:prstGeom prst="rect">
             <a:avLst/>
@@ -10703,8 +10703,8 @@
         </p:nvSpPr>
         <p:spPr>
           <a:xfrm>
-            <a:off x="3611880" y="2578608"/>
-            <a:ext cx="8028431" cy="1152143"/>
+            <a:off x="3611880" y="2377440"/>
+            <a:ext cx="8028431" cy="1353311"/>
           </a:xfrm>
           <a:prstGeom prst="rect">
             <a:avLst/>
@@ -10812,8 +10812,8 @@
         </p:nvSpPr>
         <p:spPr>
           <a:xfrm>
-            <a:off x="3611880" y="4059935"/>
-            <a:ext cx="8028431" cy="274320"/>
+            <a:off x="3611880" y="4041648"/>
+            <a:ext cx="8028431" cy="256032"/>
           </a:xfrm>
           <a:prstGeom prst="rect">
             <a:avLst/>
@@ -10846,8 +10846,8 @@
         </p:nvSpPr>
         <p:spPr>
           <a:xfrm>
-            <a:off x="3611880" y="4352544"/>
-            <a:ext cx="8028431" cy="420624"/>
+            <a:off x="3611880" y="4315968"/>
+            <a:ext cx="8028431" cy="347472"/>
           </a:xfrm>
           <a:prstGeom prst="rect">
             <a:avLst/>
@@ -10885,8 +10885,8 @@
         </p:nvSpPr>
         <p:spPr>
           <a:xfrm>
-            <a:off x="3611880" y="4791456"/>
-            <a:ext cx="8028431" cy="347472"/>
+            <a:off x="3611880" y="4681727"/>
+            <a:ext cx="8028431" cy="292608"/>
           </a:xfrm>
           <a:prstGeom prst="rect">
             <a:avLst/>
@@ -10933,8 +10933,8 @@
         </p:nvSpPr>
         <p:spPr>
           <a:xfrm>
-            <a:off x="3611880" y="5212079"/>
-            <a:ext cx="8028431" cy="1152143"/>
+            <a:off x="3611880" y="5010912"/>
+            <a:ext cx="8028431" cy="1353311"/>
           </a:xfrm>
           <a:prstGeom prst="rect">
             <a:avLst/>
@@ -10959,7 +10959,7 @@
                 </a:solidFill>
                 <a:latin typeface="Open Sans"/>
               </a:rPr>
-              <a:t>Akazawa Ryosei is a Liberal Democratic Party member of the House of Representatives for Tottori's 2nd district, first elected in 2005. A University of Tokyo Law graduate with a Cornell MBA, he spent about two decades as an MLIT-lineage bureaucrat. Under PM Ishiba he was Minister for Economic Revitalization and Japan's chief negotiator in the 2025 US tariff talks.</a:t>
+              <a:t>Akazawa Ryosei is a Liberal Democratic Party member of the House of Representatives for Tottori's 2nd district, first elected in 2005. A University of Tokyo Law graduate with a Cornell MBA, he spent about two decades as an MLIT-lineage bureaucrat. Under PM Ishiba he was Minister for Economic Revitalization and Japan's chief negotiator in the 2025 US tariff talks. PM Takaichi appointed him METI Minister on October 21, 2025, reappointed February 18, 2026.</a:t>
             </a:r>
           </a:p>
           <a:p>
@@ -11768,8 +11768,8 @@
         </p:nvSpPr>
         <p:spPr>
           <a:xfrm>
-            <a:off x="3611880" y="1426464"/>
-            <a:ext cx="8028431" cy="274320"/>
+            <a:off x="3611880" y="1408176"/>
+            <a:ext cx="8028431" cy="256032"/>
           </a:xfrm>
           <a:prstGeom prst="rect">
             <a:avLst/>
@@ -11802,8 +11802,8 @@
         </p:nvSpPr>
         <p:spPr>
           <a:xfrm>
-            <a:off x="3611880" y="1719072"/>
-            <a:ext cx="8028431" cy="420624"/>
+            <a:off x="3611880" y="1682495"/>
+            <a:ext cx="8028431" cy="347472"/>
           </a:xfrm>
           <a:prstGeom prst="rect">
             <a:avLst/>
@@ -11841,8 +11841,8 @@
         </p:nvSpPr>
         <p:spPr>
           <a:xfrm>
-            <a:off x="3611880" y="2157984"/>
-            <a:ext cx="8028431" cy="347472"/>
+            <a:off x="3611880" y="2048256"/>
+            <a:ext cx="8028431" cy="292608"/>
           </a:xfrm>
           <a:prstGeom prst="rect">
             <a:avLst/>
@@ -11889,8 +11889,8 @@
         </p:nvSpPr>
         <p:spPr>
           <a:xfrm>
-            <a:off x="3611880" y="2578608"/>
-            <a:ext cx="8028431" cy="1152143"/>
+            <a:off x="3611880" y="2377440"/>
+            <a:ext cx="8028431" cy="1353311"/>
           </a:xfrm>
           <a:prstGeom prst="rect">
             <a:avLst/>
@@ -11998,8 +11998,8 @@
         </p:nvSpPr>
         <p:spPr>
           <a:xfrm>
-            <a:off x="3611880" y="4041648"/>
-            <a:ext cx="3849624" cy="1152144"/>
+            <a:off x="3611880" y="4023359"/>
+            <a:ext cx="3849624" cy="914400"/>
           </a:xfrm>
           <a:prstGeom prst="rect">
             <a:avLst/>
@@ -12067,8 +12067,8 @@
         </p:nvSpPr>
         <p:spPr>
           <a:xfrm>
-            <a:off x="3611880" y="5047488"/>
-            <a:ext cx="3849624" cy="310896"/>
+            <a:off x="3611880" y="4956048"/>
+            <a:ext cx="3849624" cy="292608"/>
           </a:xfrm>
           <a:prstGeom prst="rect">
             <a:avLst/>
@@ -12115,8 +12115,8 @@
         </p:nvSpPr>
         <p:spPr>
           <a:xfrm>
-            <a:off x="3611880" y="5376672"/>
-            <a:ext cx="3849624" cy="987551"/>
+            <a:off x="3611880" y="5266944"/>
+            <a:ext cx="3849624" cy="1097279"/>
           </a:xfrm>
           <a:prstGeom prst="rect">
             <a:avLst/>
@@ -12154,8 +12154,8 @@
         </p:nvSpPr>
         <p:spPr>
           <a:xfrm>
-            <a:off x="7790688" y="4041648"/>
-            <a:ext cx="3849624" cy="1152144"/>
+            <a:off x="7790688" y="4023359"/>
+            <a:ext cx="3849624" cy="914400"/>
           </a:xfrm>
           <a:prstGeom prst="rect">
             <a:avLst/>
@@ -12223,8 +12223,8 @@
         </p:nvSpPr>
         <p:spPr>
           <a:xfrm>
-            <a:off x="7790688" y="5047488"/>
-            <a:ext cx="3849624" cy="310896"/>
+            <a:off x="7790688" y="4956048"/>
+            <a:ext cx="3849624" cy="292608"/>
           </a:xfrm>
           <a:prstGeom prst="rect">
             <a:avLst/>
@@ -12271,8 +12271,8 @@
         </p:nvSpPr>
         <p:spPr>
           <a:xfrm>
-            <a:off x="7790688" y="5376672"/>
-            <a:ext cx="3849624" cy="987551"/>
+            <a:off x="7790688" y="5266944"/>
+            <a:ext cx="3849624" cy="1097279"/>
           </a:xfrm>
           <a:prstGeom prst="rect">
             <a:avLst/>
@@ -13090,8 +13090,8 @@
         </p:nvSpPr>
         <p:spPr>
           <a:xfrm>
-            <a:off x="3611880" y="1426464"/>
-            <a:ext cx="8028431" cy="274320"/>
+            <a:off x="3611880" y="1408176"/>
+            <a:ext cx="8028431" cy="256032"/>
           </a:xfrm>
           <a:prstGeom prst="rect">
             <a:avLst/>
@@ -13124,8 +13124,8 @@
         </p:nvSpPr>
         <p:spPr>
           <a:xfrm>
-            <a:off x="3611880" y="1719072"/>
-            <a:ext cx="8028431" cy="420624"/>
+            <a:off x="3611880" y="1682495"/>
+            <a:ext cx="8028431" cy="347472"/>
           </a:xfrm>
           <a:prstGeom prst="rect">
             <a:avLst/>
@@ -13163,8 +13163,8 @@
         </p:nvSpPr>
         <p:spPr>
           <a:xfrm>
-            <a:off x="3611880" y="2157984"/>
-            <a:ext cx="8028431" cy="347472"/>
+            <a:off x="3611880" y="2048256"/>
+            <a:ext cx="8028431" cy="292608"/>
           </a:xfrm>
           <a:prstGeom prst="rect">
             <a:avLst/>
@@ -13211,8 +13211,8 @@
         </p:nvSpPr>
         <p:spPr>
           <a:xfrm>
-            <a:off x="3611880" y="2578608"/>
-            <a:ext cx="8028431" cy="1152143"/>
+            <a:off x="3611880" y="2377440"/>
+            <a:ext cx="8028431" cy="1353311"/>
           </a:xfrm>
           <a:prstGeom prst="rect">
             <a:avLst/>
@@ -13336,8 +13336,8 @@
         </p:nvSpPr>
         <p:spPr>
           <a:xfrm>
-            <a:off x="3611880" y="4041648"/>
-            <a:ext cx="3849624" cy="1152144"/>
+            <a:off x="3611880" y="4023359"/>
+            <a:ext cx="3849624" cy="914400"/>
           </a:xfrm>
           <a:prstGeom prst="rect">
             <a:avLst/>
@@ -13405,8 +13405,8 @@
         </p:nvSpPr>
         <p:spPr>
           <a:xfrm>
-            <a:off x="3611880" y="5047488"/>
-            <a:ext cx="3849624" cy="310896"/>
+            <a:off x="3611880" y="4956048"/>
+            <a:ext cx="3849624" cy="292608"/>
           </a:xfrm>
           <a:prstGeom prst="rect">
             <a:avLst/>
@@ -13453,8 +13453,8 @@
         </p:nvSpPr>
         <p:spPr>
           <a:xfrm>
-            <a:off x="3611880" y="5376672"/>
-            <a:ext cx="3849624" cy="987551"/>
+            <a:off x="3611880" y="5266944"/>
+            <a:ext cx="3849624" cy="1097279"/>
           </a:xfrm>
           <a:prstGeom prst="rect">
             <a:avLst/>
@@ -13492,8 +13492,8 @@
         </p:nvSpPr>
         <p:spPr>
           <a:xfrm>
-            <a:off x="7790688" y="4041648"/>
-            <a:ext cx="3849624" cy="1152144"/>
+            <a:off x="7790688" y="4023359"/>
+            <a:ext cx="3849624" cy="914400"/>
           </a:xfrm>
           <a:prstGeom prst="rect">
             <a:avLst/>
@@ -13561,8 +13561,8 @@
         </p:nvSpPr>
         <p:spPr>
           <a:xfrm>
-            <a:off x="7790688" y="5047488"/>
-            <a:ext cx="3849624" cy="310896"/>
+            <a:off x="7790688" y="4956048"/>
+            <a:ext cx="3849624" cy="292608"/>
           </a:xfrm>
           <a:prstGeom prst="rect">
             <a:avLst/>
@@ -13609,8 +13609,8 @@
         </p:nvSpPr>
         <p:spPr>
           <a:xfrm>
-            <a:off x="7790688" y="5376672"/>
-            <a:ext cx="3849624" cy="987551"/>
+            <a:off x="7790688" y="5266944"/>
+            <a:ext cx="3849624" cy="1097279"/>
           </a:xfrm>
           <a:prstGeom prst="rect">
             <a:avLst/>
@@ -14428,8 +14428,8 @@
         </p:nvSpPr>
         <p:spPr>
           <a:xfrm>
-            <a:off x="3611880" y="1426464"/>
-            <a:ext cx="8028431" cy="274320"/>
+            <a:off x="3611880" y="1408176"/>
+            <a:ext cx="8028431" cy="256032"/>
           </a:xfrm>
           <a:prstGeom prst="rect">
             <a:avLst/>
@@ -14462,8 +14462,8 @@
         </p:nvSpPr>
         <p:spPr>
           <a:xfrm>
-            <a:off x="3611880" y="1719072"/>
-            <a:ext cx="8028431" cy="420624"/>
+            <a:off x="3611880" y="1682495"/>
+            <a:ext cx="8028431" cy="347472"/>
           </a:xfrm>
           <a:prstGeom prst="rect">
             <a:avLst/>
@@ -14501,8 +14501,8 @@
         </p:nvSpPr>
         <p:spPr>
           <a:xfrm>
-            <a:off x="3611880" y="2157984"/>
-            <a:ext cx="8028431" cy="347472"/>
+            <a:off x="3611880" y="2048256"/>
+            <a:ext cx="8028431" cy="292608"/>
           </a:xfrm>
           <a:prstGeom prst="rect">
             <a:avLst/>
@@ -14549,8 +14549,8 @@
         </p:nvSpPr>
         <p:spPr>
           <a:xfrm>
-            <a:off x="3611880" y="2578608"/>
-            <a:ext cx="8028431" cy="1152143"/>
+            <a:off x="3611880" y="2377440"/>
+            <a:ext cx="8028431" cy="1353311"/>
           </a:xfrm>
           <a:prstGeom prst="rect">
             <a:avLst/>
@@ -14674,8 +14674,8 @@
         </p:nvSpPr>
         <p:spPr>
           <a:xfrm>
-            <a:off x="3611880" y="4041648"/>
-            <a:ext cx="3849624" cy="1152144"/>
+            <a:off x="3611880" y="4023359"/>
+            <a:ext cx="3849624" cy="914400"/>
           </a:xfrm>
           <a:prstGeom prst="rect">
             <a:avLst/>
@@ -14743,8 +14743,8 @@
         </p:nvSpPr>
         <p:spPr>
           <a:xfrm>
-            <a:off x="3611880" y="5047488"/>
-            <a:ext cx="3849624" cy="310896"/>
+            <a:off x="3611880" y="4956048"/>
+            <a:ext cx="3849624" cy="292608"/>
           </a:xfrm>
           <a:prstGeom prst="rect">
             <a:avLst/>
@@ -14791,8 +14791,8 @@
         </p:nvSpPr>
         <p:spPr>
           <a:xfrm>
-            <a:off x="3611880" y="5376672"/>
-            <a:ext cx="3849624" cy="987551"/>
+            <a:off x="3611880" y="5266944"/>
+            <a:ext cx="3849624" cy="1097279"/>
           </a:xfrm>
           <a:prstGeom prst="rect">
             <a:avLst/>
@@ -14830,8 +14830,8 @@
         </p:nvSpPr>
         <p:spPr>
           <a:xfrm>
-            <a:off x="7790688" y="4041648"/>
-            <a:ext cx="3849624" cy="1152144"/>
+            <a:off x="7790688" y="4023359"/>
+            <a:ext cx="3849624" cy="914400"/>
           </a:xfrm>
           <a:prstGeom prst="rect">
             <a:avLst/>
@@ -14899,8 +14899,8 @@
         </p:nvSpPr>
         <p:spPr>
           <a:xfrm>
-            <a:off x="7790688" y="5047488"/>
-            <a:ext cx="3849624" cy="310896"/>
+            <a:off x="7790688" y="4956048"/>
+            <a:ext cx="3849624" cy="292608"/>
           </a:xfrm>
           <a:prstGeom prst="rect">
             <a:avLst/>
@@ -14947,8 +14947,8 @@
         </p:nvSpPr>
         <p:spPr>
           <a:xfrm>
-            <a:off x="7790688" y="5376672"/>
-            <a:ext cx="3849624" cy="987551"/>
+            <a:off x="7790688" y="5266944"/>
+            <a:ext cx="3849624" cy="1097279"/>
           </a:xfrm>
           <a:prstGeom prst="rect">
             <a:avLst/>
@@ -15766,8 +15766,8 @@
         </p:nvSpPr>
         <p:spPr>
           <a:xfrm>
-            <a:off x="3611880" y="1426464"/>
-            <a:ext cx="8028431" cy="274320"/>
+            <a:off x="3611880" y="1408176"/>
+            <a:ext cx="8028431" cy="256032"/>
           </a:xfrm>
           <a:prstGeom prst="rect">
             <a:avLst/>
@@ -15800,8 +15800,8 @@
         </p:nvSpPr>
         <p:spPr>
           <a:xfrm>
-            <a:off x="3611880" y="1719072"/>
-            <a:ext cx="8028431" cy="420624"/>
+            <a:off x="3611880" y="1682495"/>
+            <a:ext cx="8028431" cy="347472"/>
           </a:xfrm>
           <a:prstGeom prst="rect">
             <a:avLst/>
@@ -15839,8 +15839,8 @@
         </p:nvSpPr>
         <p:spPr>
           <a:xfrm>
-            <a:off x="3611880" y="2157984"/>
-            <a:ext cx="8028431" cy="347472"/>
+            <a:off x="3611880" y="2048256"/>
+            <a:ext cx="8028431" cy="292608"/>
           </a:xfrm>
           <a:prstGeom prst="rect">
             <a:avLst/>
@@ -15887,8 +15887,8 @@
         </p:nvSpPr>
         <p:spPr>
           <a:xfrm>
-            <a:off x="3611880" y="2578608"/>
-            <a:ext cx="8028431" cy="1152143"/>
+            <a:off x="3611880" y="2377440"/>
+            <a:ext cx="8028431" cy="1353311"/>
           </a:xfrm>
           <a:prstGeom prst="rect">
             <a:avLst/>
@@ -15996,8 +15996,8 @@
         </p:nvSpPr>
         <p:spPr>
           <a:xfrm>
-            <a:off x="3611880" y="4041648"/>
-            <a:ext cx="3849624" cy="1152144"/>
+            <a:off x="3611880" y="4023359"/>
+            <a:ext cx="3849624" cy="914400"/>
           </a:xfrm>
           <a:prstGeom prst="rect">
             <a:avLst/>
@@ -16065,8 +16065,8 @@
         </p:nvSpPr>
         <p:spPr>
           <a:xfrm>
-            <a:off x="3611880" y="5047488"/>
-            <a:ext cx="3849624" cy="310896"/>
+            <a:off x="3611880" y="4956048"/>
+            <a:ext cx="3849624" cy="292608"/>
           </a:xfrm>
           <a:prstGeom prst="rect">
             <a:avLst/>
@@ -16113,8 +16113,8 @@
         </p:nvSpPr>
         <p:spPr>
           <a:xfrm>
-            <a:off x="3611880" y="5376672"/>
-            <a:ext cx="3849624" cy="987551"/>
+            <a:off x="3611880" y="5266944"/>
+            <a:ext cx="3849624" cy="1097279"/>
           </a:xfrm>
           <a:prstGeom prst="rect">
             <a:avLst/>
@@ -16152,8 +16152,8 @@
         </p:nvSpPr>
         <p:spPr>
           <a:xfrm>
-            <a:off x="7790688" y="4041648"/>
-            <a:ext cx="3849624" cy="1152144"/>
+            <a:off x="7790688" y="4023359"/>
+            <a:ext cx="3849624" cy="914400"/>
           </a:xfrm>
           <a:prstGeom prst="rect">
             <a:avLst/>
@@ -16230,8 +16230,8 @@
         </p:nvSpPr>
         <p:spPr>
           <a:xfrm>
-            <a:off x="7790688" y="5047488"/>
-            <a:ext cx="3849624" cy="310896"/>
+            <a:off x="7790688" y="4956048"/>
+            <a:ext cx="3849624" cy="292608"/>
           </a:xfrm>
           <a:prstGeom prst="rect">
             <a:avLst/>
@@ -16269,8 +16269,8 @@
         </p:nvSpPr>
         <p:spPr>
           <a:xfrm>
-            <a:off x="7790688" y="5376672"/>
-            <a:ext cx="3849624" cy="987551"/>
+            <a:off x="7790688" y="5266944"/>
+            <a:ext cx="3849624" cy="1097279"/>
           </a:xfrm>
           <a:prstGeom prst="rect">
             <a:avLst/>
@@ -16631,7 +16631,7 @@
         <p:spPr>
           <a:xfrm>
             <a:off x="548640" y="1298448"/>
-            <a:ext cx="6858000" cy="4846320"/>
+            <a:ext cx="10332720" cy="4846320"/>
           </a:xfrm>
           <a:prstGeom prst="rect">
             <a:avLst/>
@@ -16795,195 +16795,9 @@
           </a:p>
         </p:txBody>
       </p:sp>
-      <p:sp>
-        <p:nvSpPr>
-          <p:cNvPr id="7" name="Rectangle 6"/>
-          <p:cNvSpPr/>
-          <p:nvPr/>
-        </p:nvSpPr>
-        <p:spPr>
-          <a:xfrm>
-            <a:off x="7772400" y="1298448"/>
-            <a:ext cx="3867912" cy="4663440"/>
-          </a:xfrm>
-          <a:prstGeom prst="rect">
-            <a:avLst/>
-          </a:prstGeom>
-          <a:solidFill>
-            <a:srgbClr val="E1DACE"/>
-          </a:solidFill>
-          <a:ln>
-            <a:noFill/>
-          </a:ln>
-          <a:effectLst/>
-        </p:spPr>
-        <p:style>
-          <a:lnRef idx="1">
-            <a:schemeClr val="accent1"/>
-          </a:lnRef>
-          <a:fillRef idx="3">
-            <a:schemeClr val="accent1"/>
-          </a:fillRef>
-          <a:effectRef idx="2">
-            <a:schemeClr val="accent1"/>
-          </a:effectRef>
-          <a:fontRef idx="minor">
-            <a:schemeClr val="lt1"/>
-          </a:fontRef>
-        </p:style>
-        <p:txBody>
-          <a:bodyPr rtlCol="0" anchor="ctr"/>
-          <a:lstStyle/>
-          <a:p>
-            <a:pPr algn="ctr"/>
-          </a:p>
-        </p:txBody>
-      </p:sp>
-      <p:sp>
-        <p:nvSpPr>
-          <p:cNvPr id="8" name="Rectangle 7"/>
-          <p:cNvSpPr/>
-          <p:nvPr/>
-        </p:nvSpPr>
-        <p:spPr>
-          <a:xfrm>
-            <a:off x="7772400" y="1298448"/>
-            <a:ext cx="3867912" cy="41148"/>
-          </a:xfrm>
-          <a:prstGeom prst="rect">
-            <a:avLst/>
-          </a:prstGeom>
-          <a:solidFill>
-            <a:srgbClr val="B4862D"/>
-          </a:solidFill>
-          <a:ln>
-            <a:noFill/>
-          </a:ln>
-          <a:effectLst/>
-        </p:spPr>
-        <p:style>
-          <a:lnRef idx="1">
-            <a:schemeClr val="accent1"/>
-          </a:lnRef>
-          <a:fillRef idx="3">
-            <a:schemeClr val="accent1"/>
-          </a:fillRef>
-          <a:effectRef idx="2">
-            <a:schemeClr val="accent1"/>
-          </a:effectRef>
-          <a:fontRef idx="minor">
-            <a:schemeClr val="lt1"/>
-          </a:fontRef>
-        </p:style>
-        <p:txBody>
-          <a:bodyPr rtlCol="0" anchor="ctr"/>
-          <a:lstStyle/>
-          <a:p>
-            <a:pPr algn="ctr"/>
-          </a:p>
-        </p:txBody>
-      </p:sp>
-      <p:sp>
-        <p:nvSpPr>
-          <p:cNvPr id="9" name="TextBox 8"/>
-          <p:cNvSpPr txBox="1"/>
-          <p:nvPr/>
-        </p:nvSpPr>
-        <p:spPr>
-          <a:xfrm>
-            <a:off x="8046720" y="1536192"/>
-            <a:ext cx="3383280" cy="4297680"/>
-          </a:xfrm>
-          <a:prstGeom prst="rect">
-            <a:avLst/>
-          </a:prstGeom>
-          <a:noFill/>
-        </p:spPr>
-        <p:txBody>
-          <a:bodyPr wrap="square" anchor="t" lIns="0" rIns="0" tIns="0" bIns="0">
-            <a:spAutoFit/>
-          </a:bodyPr>
-          <a:lstStyle/>
-          <a:p>
-            <a:r>
-              <a:rPr sz="1100" b="1" i="0" spc="100">
-                <a:solidFill>
-                  <a:srgbClr val="0A314D"/>
-                </a:solidFill>
-                <a:latin typeface="Open Sans"/>
-              </a:rPr>
-              <a:t>ABOUT THIS DOCUMENT</a:t>
-            </a:r>
-          </a:p>
-          <a:p>
-            <a:pPr>
-              <a:spcBef>
-                <a:spcPts val="900"/>
-              </a:spcBef>
-            </a:pPr>
-            <a:r>
-              <a:rPr sz="1050" b="0" i="0">
-                <a:solidFill>
-                  <a:srgbClr val="54606C"/>
-                </a:solidFill>
-                <a:latin typeface="Open Sans"/>
-              </a:rPr>
-              <a:t>Prepared within the International Trade Administration, U.S. Department of Commerce, as an internal reference.</a:t>
-            </a:r>
-          </a:p>
-          <a:p>
-            <a:pPr>
-              <a:spcBef>
-                <a:spcPts val="900"/>
-              </a:spcBef>
-            </a:pPr>
-            <a:r>
-              <a:rPr sz="1050" b="0" i="0">
-                <a:solidFill>
-                  <a:srgbClr val="54606C"/>
-                </a:solidFill>
-                <a:latin typeface="Open Sans"/>
-              </a:rPr>
-              <a:t>Formatted to the ITA Visual Style Guide (January 2026 edition): Trade Navy/Trade Blue palette, Open Sans typography, official document signatures.</a:t>
-            </a:r>
-          </a:p>
-          <a:p>
-            <a:pPr>
-              <a:spcBef>
-                <a:spcPts val="900"/>
-              </a:spcBef>
-            </a:pPr>
-            <a:r>
-              <a:rPr sz="1050" b="0" i="0">
-                <a:solidFill>
-                  <a:srgbClr val="54606C"/>
-                </a:solidFill>
-                <a:latin typeface="Open Sans"/>
-              </a:rPr>
-              <a:t>One structured dataset generates this deck, the companion workbook, and the PDF, so figures cannot drift between formats.</a:t>
-            </a:r>
-          </a:p>
-          <a:p>
-            <a:pPr>
-              <a:spcBef>
-                <a:spcPts val="900"/>
-              </a:spcBef>
-            </a:pPr>
-            <a:r>
-              <a:rPr sz="1050" b="0" i="0">
-                <a:solidFill>
-                  <a:srgbClr val="54606C"/>
-                </a:solidFill>
-                <a:latin typeface="Open Sans"/>
-              </a:rPr>
-              <a:t>Data caveats, acting officials, and items pending confirmation are tracked in a separate gaps register (GAPS.md) rather than flagged on slides.</a:t>
-            </a:r>
-          </a:p>
-        </p:txBody>
-      </p:sp>
       <p:cxnSp>
         <p:nvCxnSpPr>
-          <p:cNvPr id="10" name="Connector 9"/>
+          <p:cNvPr id="7" name="Connector 6"/>
           <p:cNvCxnSpPr/>
           <p:nvPr/>
         </p:nvCxnSpPr>
@@ -17019,7 +16833,7 @@
       </p:cxnSp>
       <p:sp>
         <p:nvSpPr>
-          <p:cNvPr id="11" name="TextBox 10"/>
+          <p:cNvPr id="8" name="TextBox 7"/>
           <p:cNvSpPr txBox="1"/>
           <p:nvPr/>
         </p:nvSpPr>
@@ -17053,7 +16867,7 @@
       </p:sp>
       <p:sp>
         <p:nvSpPr>
-          <p:cNvPr id="12" name="TextBox 11"/>
+          <p:cNvPr id="9" name="TextBox 8"/>
           <p:cNvSpPr txBox="1"/>
           <p:nvPr/>
         </p:nvSpPr>
@@ -17087,7 +16901,7 @@
       </p:sp>
       <p:sp>
         <p:nvSpPr>
-          <p:cNvPr id="13" name="TextBox 12"/>
+          <p:cNvPr id="10" name="TextBox 9"/>
           <p:cNvSpPr txBox="1"/>
           <p:nvPr/>
         </p:nvSpPr>
@@ -17760,8 +17574,8 @@
         </p:nvSpPr>
         <p:spPr>
           <a:xfrm>
-            <a:off x="3611880" y="1426464"/>
-            <a:ext cx="8028431" cy="274320"/>
+            <a:off x="3611880" y="1408176"/>
+            <a:ext cx="8028431" cy="256032"/>
           </a:xfrm>
           <a:prstGeom prst="rect">
             <a:avLst/>
@@ -17794,8 +17608,8 @@
         </p:nvSpPr>
         <p:spPr>
           <a:xfrm>
-            <a:off x="3611880" y="1719072"/>
-            <a:ext cx="8028431" cy="420624"/>
+            <a:off x="3611880" y="1682495"/>
+            <a:ext cx="8028431" cy="347472"/>
           </a:xfrm>
           <a:prstGeom prst="rect">
             <a:avLst/>
@@ -17833,8 +17647,8 @@
         </p:nvSpPr>
         <p:spPr>
           <a:xfrm>
-            <a:off x="3611880" y="2157984"/>
-            <a:ext cx="8028431" cy="347472"/>
+            <a:off x="3611880" y="2048256"/>
+            <a:ext cx="8028431" cy="292608"/>
           </a:xfrm>
           <a:prstGeom prst="rect">
             <a:avLst/>
@@ -17881,8 +17695,8 @@
         </p:nvSpPr>
         <p:spPr>
           <a:xfrm>
-            <a:off x="3611880" y="2578608"/>
-            <a:ext cx="8028431" cy="1152143"/>
+            <a:off x="3611880" y="2377440"/>
+            <a:ext cx="8028431" cy="1353311"/>
           </a:xfrm>
           <a:prstGeom prst="rect">
             <a:avLst/>
@@ -17990,8 +17804,8 @@
         </p:nvSpPr>
         <p:spPr>
           <a:xfrm>
-            <a:off x="3611880" y="4041648"/>
-            <a:ext cx="3849624" cy="1152144"/>
+            <a:off x="3611880" y="4023359"/>
+            <a:ext cx="3849624" cy="914400"/>
           </a:xfrm>
           <a:prstGeom prst="rect">
             <a:avLst/>
@@ -18059,8 +17873,8 @@
         </p:nvSpPr>
         <p:spPr>
           <a:xfrm>
-            <a:off x="3611880" y="5047488"/>
-            <a:ext cx="3849624" cy="310896"/>
+            <a:off x="3611880" y="4956048"/>
+            <a:ext cx="3849624" cy="292608"/>
           </a:xfrm>
           <a:prstGeom prst="rect">
             <a:avLst/>
@@ -18107,8 +17921,8 @@
         </p:nvSpPr>
         <p:spPr>
           <a:xfrm>
-            <a:off x="3611880" y="5376672"/>
-            <a:ext cx="3849624" cy="987551"/>
+            <a:off x="3611880" y="5266944"/>
+            <a:ext cx="3849624" cy="1097279"/>
           </a:xfrm>
           <a:prstGeom prst="rect">
             <a:avLst/>
@@ -18146,8 +17960,8 @@
         </p:nvSpPr>
         <p:spPr>
           <a:xfrm>
-            <a:off x="7790688" y="4041648"/>
-            <a:ext cx="3849624" cy="1152144"/>
+            <a:off x="7790688" y="4023359"/>
+            <a:ext cx="3849624" cy="914400"/>
           </a:xfrm>
           <a:prstGeom prst="rect">
             <a:avLst/>
@@ -18215,8 +18029,8 @@
         </p:nvSpPr>
         <p:spPr>
           <a:xfrm>
-            <a:off x="7790688" y="5047488"/>
-            <a:ext cx="3849624" cy="310896"/>
+            <a:off x="7790688" y="4956048"/>
+            <a:ext cx="3849624" cy="292608"/>
           </a:xfrm>
           <a:prstGeom prst="rect">
             <a:avLst/>
@@ -18263,8 +18077,8 @@
         </p:nvSpPr>
         <p:spPr>
           <a:xfrm>
-            <a:off x="7790688" y="5376672"/>
-            <a:ext cx="3849624" cy="987551"/>
+            <a:off x="7790688" y="5266944"/>
+            <a:ext cx="3849624" cy="1097279"/>
           </a:xfrm>
           <a:prstGeom prst="rect">
             <a:avLst/>
@@ -19082,8 +18896,8 @@
         </p:nvSpPr>
         <p:spPr>
           <a:xfrm>
-            <a:off x="3611880" y="1426464"/>
-            <a:ext cx="8028431" cy="274320"/>
+            <a:off x="3611880" y="1408176"/>
+            <a:ext cx="8028431" cy="256032"/>
           </a:xfrm>
           <a:prstGeom prst="rect">
             <a:avLst/>
@@ -19116,8 +18930,8 @@
         </p:nvSpPr>
         <p:spPr>
           <a:xfrm>
-            <a:off x="3611880" y="1719072"/>
-            <a:ext cx="8028431" cy="420624"/>
+            <a:off x="3611880" y="1682495"/>
+            <a:ext cx="8028431" cy="347472"/>
           </a:xfrm>
           <a:prstGeom prst="rect">
             <a:avLst/>
@@ -19155,8 +18969,8 @@
         </p:nvSpPr>
         <p:spPr>
           <a:xfrm>
-            <a:off x="3611880" y="2157984"/>
-            <a:ext cx="8028431" cy="347472"/>
+            <a:off x="3611880" y="2048256"/>
+            <a:ext cx="8028431" cy="292608"/>
           </a:xfrm>
           <a:prstGeom prst="rect">
             <a:avLst/>
@@ -19203,8 +19017,8 @@
         </p:nvSpPr>
         <p:spPr>
           <a:xfrm>
-            <a:off x="3611880" y="2578608"/>
-            <a:ext cx="8028431" cy="1152143"/>
+            <a:off x="3611880" y="2377440"/>
+            <a:ext cx="8028431" cy="1353311"/>
           </a:xfrm>
           <a:prstGeom prst="rect">
             <a:avLst/>
@@ -19328,8 +19142,8 @@
         </p:nvSpPr>
         <p:spPr>
           <a:xfrm>
-            <a:off x="3611880" y="4059935"/>
-            <a:ext cx="8028431" cy="274320"/>
+            <a:off x="3611880" y="4041648"/>
+            <a:ext cx="8028431" cy="256032"/>
           </a:xfrm>
           <a:prstGeom prst="rect">
             <a:avLst/>
@@ -19362,8 +19176,8 @@
         </p:nvSpPr>
         <p:spPr>
           <a:xfrm>
-            <a:off x="3611880" y="4352544"/>
-            <a:ext cx="8028431" cy="420624"/>
+            <a:off x="3611880" y="4315968"/>
+            <a:ext cx="8028431" cy="347472"/>
           </a:xfrm>
           <a:prstGeom prst="rect">
             <a:avLst/>
@@ -19401,8 +19215,8 @@
         </p:nvSpPr>
         <p:spPr>
           <a:xfrm>
-            <a:off x="3611880" y="4791456"/>
-            <a:ext cx="8028431" cy="347472"/>
+            <a:off x="3611880" y="4681727"/>
+            <a:ext cx="8028431" cy="292608"/>
           </a:xfrm>
           <a:prstGeom prst="rect">
             <a:avLst/>
@@ -19449,8 +19263,8 @@
         </p:nvSpPr>
         <p:spPr>
           <a:xfrm>
-            <a:off x="3611880" y="5212079"/>
-            <a:ext cx="8028431" cy="1152143"/>
+            <a:off x="3611880" y="5010912"/>
+            <a:ext cx="8028431" cy="1353311"/>
           </a:xfrm>
           <a:prstGeom prst="rect">
             <a:avLst/>
@@ -20268,8 +20082,8 @@
         </p:nvSpPr>
         <p:spPr>
           <a:xfrm>
-            <a:off x="3611880" y="1426464"/>
-            <a:ext cx="8028431" cy="274320"/>
+            <a:off x="3611880" y="1408176"/>
+            <a:ext cx="8028431" cy="256032"/>
           </a:xfrm>
           <a:prstGeom prst="rect">
             <a:avLst/>
@@ -20302,8 +20116,8 @@
         </p:nvSpPr>
         <p:spPr>
           <a:xfrm>
-            <a:off x="3611880" y="1719072"/>
-            <a:ext cx="8028431" cy="420624"/>
+            <a:off x="3611880" y="1682495"/>
+            <a:ext cx="8028431" cy="347472"/>
           </a:xfrm>
           <a:prstGeom prst="rect">
             <a:avLst/>
@@ -20341,8 +20155,8 @@
         </p:nvSpPr>
         <p:spPr>
           <a:xfrm>
-            <a:off x="3611880" y="2157984"/>
-            <a:ext cx="8028431" cy="347472"/>
+            <a:off x="3611880" y="2048256"/>
+            <a:ext cx="8028431" cy="292608"/>
           </a:xfrm>
           <a:prstGeom prst="rect">
             <a:avLst/>
@@ -20389,8 +20203,8 @@
         </p:nvSpPr>
         <p:spPr>
           <a:xfrm>
-            <a:off x="3611880" y="2578608"/>
-            <a:ext cx="8028431" cy="1152143"/>
+            <a:off x="3611880" y="2377440"/>
+            <a:ext cx="8028431" cy="1353311"/>
           </a:xfrm>
           <a:prstGeom prst="rect">
             <a:avLst/>
@@ -20514,8 +20328,8 @@
         </p:nvSpPr>
         <p:spPr>
           <a:xfrm>
-            <a:off x="3611880" y="4041648"/>
-            <a:ext cx="3849624" cy="1152144"/>
+            <a:off x="3611880" y="4023359"/>
+            <a:ext cx="3849624" cy="914400"/>
           </a:xfrm>
           <a:prstGeom prst="rect">
             <a:avLst/>
@@ -20583,8 +20397,8 @@
         </p:nvSpPr>
         <p:spPr>
           <a:xfrm>
-            <a:off x="3611880" y="5047488"/>
-            <a:ext cx="3849624" cy="310896"/>
+            <a:off x="3611880" y="4956048"/>
+            <a:ext cx="3849624" cy="292608"/>
           </a:xfrm>
           <a:prstGeom prst="rect">
             <a:avLst/>
@@ -20631,8 +20445,8 @@
         </p:nvSpPr>
         <p:spPr>
           <a:xfrm>
-            <a:off x="3611880" y="5376672"/>
-            <a:ext cx="3849624" cy="987551"/>
+            <a:off x="3611880" y="5266944"/>
+            <a:ext cx="3849624" cy="1097279"/>
           </a:xfrm>
           <a:prstGeom prst="rect">
             <a:avLst/>
@@ -20670,8 +20484,8 @@
         </p:nvSpPr>
         <p:spPr>
           <a:xfrm>
-            <a:off x="7790688" y="4041648"/>
-            <a:ext cx="3849624" cy="1152144"/>
+            <a:off x="7790688" y="4023359"/>
+            <a:ext cx="3849624" cy="914400"/>
           </a:xfrm>
           <a:prstGeom prst="rect">
             <a:avLst/>
@@ -20739,8 +20553,8 @@
         </p:nvSpPr>
         <p:spPr>
           <a:xfrm>
-            <a:off x="7790688" y="5047488"/>
-            <a:ext cx="3849624" cy="310896"/>
+            <a:off x="7790688" y="4956048"/>
+            <a:ext cx="3849624" cy="292608"/>
           </a:xfrm>
           <a:prstGeom prst="rect">
             <a:avLst/>
@@ -20787,8 +20601,8 @@
         </p:nvSpPr>
         <p:spPr>
           <a:xfrm>
-            <a:off x="7790688" y="5376672"/>
-            <a:ext cx="3849624" cy="987551"/>
+            <a:off x="7790688" y="5266944"/>
+            <a:ext cx="3849624" cy="1097279"/>
           </a:xfrm>
           <a:prstGeom prst="rect">
             <a:avLst/>
@@ -21606,8 +21420,8 @@
         </p:nvSpPr>
         <p:spPr>
           <a:xfrm>
-            <a:off x="3611880" y="1408176"/>
-            <a:ext cx="3849624" cy="1152144"/>
+            <a:off x="3611880" y="1389888"/>
+            <a:ext cx="3849624" cy="914400"/>
           </a:xfrm>
           <a:prstGeom prst="rect">
             <a:avLst/>
@@ -21675,8 +21489,8 @@
         </p:nvSpPr>
         <p:spPr>
           <a:xfrm>
-            <a:off x="3611880" y="2414015"/>
-            <a:ext cx="3849624" cy="310896"/>
+            <a:off x="3611880" y="2322576"/>
+            <a:ext cx="3849624" cy="292608"/>
           </a:xfrm>
           <a:prstGeom prst="rect">
             <a:avLst/>
@@ -21723,8 +21537,8 @@
         </p:nvSpPr>
         <p:spPr>
           <a:xfrm>
-            <a:off x="3611880" y="2743200"/>
-            <a:ext cx="3849624" cy="987551"/>
+            <a:off x="3611880" y="2633472"/>
+            <a:ext cx="3849624" cy="1097279"/>
           </a:xfrm>
           <a:prstGeom prst="rect">
             <a:avLst/>
@@ -21762,8 +21576,8 @@
         </p:nvSpPr>
         <p:spPr>
           <a:xfrm>
-            <a:off x="7790688" y="1408176"/>
-            <a:ext cx="3849624" cy="1152144"/>
+            <a:off x="7790688" y="1389888"/>
+            <a:ext cx="3849624" cy="914400"/>
           </a:xfrm>
           <a:prstGeom prst="rect">
             <a:avLst/>
@@ -21831,8 +21645,8 @@
         </p:nvSpPr>
         <p:spPr>
           <a:xfrm>
-            <a:off x="7790688" y="2414015"/>
-            <a:ext cx="3849624" cy="310896"/>
+            <a:off x="7790688" y="2322576"/>
+            <a:ext cx="3849624" cy="292608"/>
           </a:xfrm>
           <a:prstGeom prst="rect">
             <a:avLst/>
@@ -21879,8 +21693,8 @@
         </p:nvSpPr>
         <p:spPr>
           <a:xfrm>
-            <a:off x="7790688" y="2743200"/>
-            <a:ext cx="3849624" cy="987551"/>
+            <a:off x="7790688" y="2633472"/>
+            <a:ext cx="3849624" cy="1097279"/>
           </a:xfrm>
           <a:prstGeom prst="rect">
             <a:avLst/>
@@ -21988,8 +21802,8 @@
         </p:nvSpPr>
         <p:spPr>
           <a:xfrm>
-            <a:off x="3611880" y="4041648"/>
-            <a:ext cx="3849624" cy="1152144"/>
+            <a:off x="3611880" y="4023359"/>
+            <a:ext cx="3849624" cy="914400"/>
           </a:xfrm>
           <a:prstGeom prst="rect">
             <a:avLst/>
@@ -22057,8 +21871,8 @@
         </p:nvSpPr>
         <p:spPr>
           <a:xfrm>
-            <a:off x="3611880" y="5047488"/>
-            <a:ext cx="3849624" cy="310896"/>
+            <a:off x="3611880" y="4956048"/>
+            <a:ext cx="3849624" cy="292608"/>
           </a:xfrm>
           <a:prstGeom prst="rect">
             <a:avLst/>
@@ -22105,8 +21919,8 @@
         </p:nvSpPr>
         <p:spPr>
           <a:xfrm>
-            <a:off x="3611880" y="5376672"/>
-            <a:ext cx="3849624" cy="987551"/>
+            <a:off x="3611880" y="5266944"/>
+            <a:ext cx="3849624" cy="1097279"/>
           </a:xfrm>
           <a:prstGeom prst="rect">
             <a:avLst/>
@@ -22144,8 +21958,8 @@
         </p:nvSpPr>
         <p:spPr>
           <a:xfrm>
-            <a:off x="7790688" y="4041648"/>
-            <a:ext cx="3849624" cy="1152144"/>
+            <a:off x="7790688" y="4023359"/>
+            <a:ext cx="3849624" cy="914400"/>
           </a:xfrm>
           <a:prstGeom prst="rect">
             <a:avLst/>
@@ -22213,8 +22027,8 @@
         </p:nvSpPr>
         <p:spPr>
           <a:xfrm>
-            <a:off x="7790688" y="5047488"/>
-            <a:ext cx="3849624" cy="310896"/>
+            <a:off x="7790688" y="4956048"/>
+            <a:ext cx="3849624" cy="292608"/>
           </a:xfrm>
           <a:prstGeom prst="rect">
             <a:avLst/>
@@ -22261,8 +22075,8 @@
         </p:nvSpPr>
         <p:spPr>
           <a:xfrm>
-            <a:off x="7790688" y="5376672"/>
-            <a:ext cx="3849624" cy="987551"/>
+            <a:off x="7790688" y="5266944"/>
+            <a:ext cx="3849624" cy="1097279"/>
           </a:xfrm>
           <a:prstGeom prst="rect">
             <a:avLst/>
@@ -23123,8 +22937,8 @@
         </p:nvSpPr>
         <p:spPr>
           <a:xfrm>
-            <a:off x="3611880" y="1426464"/>
-            <a:ext cx="8028431" cy="274320"/>
+            <a:off x="3611880" y="1408176"/>
+            <a:ext cx="8028431" cy="256032"/>
           </a:xfrm>
           <a:prstGeom prst="rect">
             <a:avLst/>
@@ -23157,8 +22971,8 @@
         </p:nvSpPr>
         <p:spPr>
           <a:xfrm>
-            <a:off x="3611880" y="1719072"/>
-            <a:ext cx="8028431" cy="420624"/>
+            <a:off x="3611880" y="1682495"/>
+            <a:ext cx="8028431" cy="347472"/>
           </a:xfrm>
           <a:prstGeom prst="rect">
             <a:avLst/>
@@ -23196,8 +23010,8 @@
         </p:nvSpPr>
         <p:spPr>
           <a:xfrm>
-            <a:off x="3611880" y="2157984"/>
-            <a:ext cx="8028431" cy="347472"/>
+            <a:off x="3611880" y="2048256"/>
+            <a:ext cx="8028431" cy="292608"/>
           </a:xfrm>
           <a:prstGeom prst="rect">
             <a:avLst/>
@@ -23244,8 +23058,8 @@
         </p:nvSpPr>
         <p:spPr>
           <a:xfrm>
-            <a:off x="3611880" y="2578608"/>
-            <a:ext cx="8028431" cy="1152143"/>
+            <a:off x="3611880" y="2377440"/>
+            <a:ext cx="8028431" cy="1353311"/>
           </a:xfrm>
           <a:prstGeom prst="rect">
             <a:avLst/>
@@ -23353,8 +23167,8 @@
         </p:nvSpPr>
         <p:spPr>
           <a:xfrm>
-            <a:off x="3611880" y="4059935"/>
-            <a:ext cx="8028431" cy="274320"/>
+            <a:off x="3611880" y="4041648"/>
+            <a:ext cx="8028431" cy="256032"/>
           </a:xfrm>
           <a:prstGeom prst="rect">
             <a:avLst/>
@@ -23387,8 +23201,8 @@
         </p:nvSpPr>
         <p:spPr>
           <a:xfrm>
-            <a:off x="3611880" y="4352544"/>
-            <a:ext cx="8028431" cy="420624"/>
+            <a:off x="3611880" y="4315968"/>
+            <a:ext cx="8028431" cy="347472"/>
           </a:xfrm>
           <a:prstGeom prst="rect">
             <a:avLst/>
@@ -23426,8 +23240,8 @@
         </p:nvSpPr>
         <p:spPr>
           <a:xfrm>
-            <a:off x="3611880" y="4791456"/>
-            <a:ext cx="8028431" cy="347472"/>
+            <a:off x="3611880" y="4681727"/>
+            <a:ext cx="8028431" cy="292608"/>
           </a:xfrm>
           <a:prstGeom prst="rect">
             <a:avLst/>
@@ -23474,8 +23288,8 @@
         </p:nvSpPr>
         <p:spPr>
           <a:xfrm>
-            <a:off x="3611880" y="5212079"/>
-            <a:ext cx="8028431" cy="1152143"/>
+            <a:off x="3611880" y="5010912"/>
+            <a:ext cx="8028431" cy="1353311"/>
           </a:xfrm>
           <a:prstGeom prst="rect">
             <a:avLst/>
@@ -24366,8 +24180,8 @@
         </p:nvSpPr>
         <p:spPr>
           <a:xfrm>
-            <a:off x="3611880" y="1426464"/>
-            <a:ext cx="8028431" cy="274320"/>
+            <a:off x="3611880" y="1408176"/>
+            <a:ext cx="8028431" cy="256032"/>
           </a:xfrm>
           <a:prstGeom prst="rect">
             <a:avLst/>
@@ -24400,8 +24214,8 @@
         </p:nvSpPr>
         <p:spPr>
           <a:xfrm>
-            <a:off x="3611880" y="1719072"/>
-            <a:ext cx="8028431" cy="420624"/>
+            <a:off x="3611880" y="1682495"/>
+            <a:ext cx="8028431" cy="347472"/>
           </a:xfrm>
           <a:prstGeom prst="rect">
             <a:avLst/>
@@ -24439,8 +24253,8 @@
         </p:nvSpPr>
         <p:spPr>
           <a:xfrm>
-            <a:off x="3611880" y="2157984"/>
-            <a:ext cx="8028431" cy="347472"/>
+            <a:off x="3611880" y="2048256"/>
+            <a:ext cx="8028431" cy="292608"/>
           </a:xfrm>
           <a:prstGeom prst="rect">
             <a:avLst/>
@@ -24487,8 +24301,8 @@
         </p:nvSpPr>
         <p:spPr>
           <a:xfrm>
-            <a:off x="3611880" y="2578608"/>
-            <a:ext cx="8028431" cy="1152143"/>
+            <a:off x="3611880" y="2377440"/>
+            <a:ext cx="8028431" cy="1353311"/>
           </a:xfrm>
           <a:prstGeom prst="rect">
             <a:avLst/>
@@ -24596,8 +24410,8 @@
         </p:nvSpPr>
         <p:spPr>
           <a:xfrm>
-            <a:off x="3611880" y="4059935"/>
-            <a:ext cx="8028431" cy="274320"/>
+            <a:off x="3611880" y="4041648"/>
+            <a:ext cx="8028431" cy="256032"/>
           </a:xfrm>
           <a:prstGeom prst="rect">
             <a:avLst/>
@@ -24630,8 +24444,8 @@
         </p:nvSpPr>
         <p:spPr>
           <a:xfrm>
-            <a:off x="3611880" y="4352544"/>
-            <a:ext cx="8028431" cy="420624"/>
+            <a:off x="3611880" y="4315968"/>
+            <a:ext cx="8028431" cy="347472"/>
           </a:xfrm>
           <a:prstGeom prst="rect">
             <a:avLst/>
@@ -24669,8 +24483,8 @@
         </p:nvSpPr>
         <p:spPr>
           <a:xfrm>
-            <a:off x="3611880" y="4791456"/>
-            <a:ext cx="8028431" cy="347472"/>
+            <a:off x="3611880" y="4681727"/>
+            <a:ext cx="8028431" cy="292608"/>
           </a:xfrm>
           <a:prstGeom prst="rect">
             <a:avLst/>
@@ -24717,8 +24531,8 @@
         </p:nvSpPr>
         <p:spPr>
           <a:xfrm>
-            <a:off x="3611880" y="5212079"/>
-            <a:ext cx="8028431" cy="1152143"/>
+            <a:off x="3611880" y="5010912"/>
+            <a:ext cx="8028431" cy="1353311"/>
           </a:xfrm>
           <a:prstGeom prst="rect">
             <a:avLst/>
@@ -25003,7 +24817,7 @@
                 </a:solidFill>
                 <a:latin typeface="Open Sans"/>
               </a:rPr>
-              <a:t>Sources &amp; Notes</a:t>
+              <a:t>Sources</a:t>
             </a:r>
           </a:p>
         </p:txBody>
@@ -25037,7 +24851,7 @@
                 </a:solidFill>
                 <a:latin typeface="Open Sans"/>
               </a:rPr>
-              <a:t>datasets, vintages, and measurement notes</a:t>
+              <a:t>datasets and vintages</a:t>
             </a:r>
           </a:p>
         </p:txBody>
@@ -25094,8 +24908,8 @@
         </p:nvSpPr>
         <p:spPr>
           <a:xfrm>
-            <a:off x="548640" y="1298448"/>
-            <a:ext cx="5532120" cy="4846320"/>
+            <a:off x="548640" y="1371600"/>
+            <a:ext cx="10881360" cy="4754880"/>
           </a:xfrm>
           <a:prstGeom prst="rect">
             <a:avLst/>
@@ -25113,7 +24927,7 @@
                 <a:spcPts val="0"/>
               </a:spcBef>
               <a:spcAft>
-                <a:spcPts val="300"/>
+                <a:spcPts val="400"/>
               </a:spcAft>
             </a:pPr>
             <a:r>
@@ -25129,11 +24943,11 @@
           <a:p>
             <a:pPr>
               <a:spcAft>
-                <a:spcPts val="200"/>
+                <a:spcPts val="400"/>
               </a:spcAft>
             </a:pPr>
             <a:r>
-              <a:rPr sz="1050" b="1" i="0">
+              <a:rPr sz="1100" b="1" i="0">
                 <a:solidFill>
                   <a:srgbClr val="B4862D"/>
                 </a:solidFill>
@@ -25142,7 +24956,7 @@
               <a:t>•  </a:t>
             </a:r>
             <a:r>
-              <a:rPr sz="1050" b="0" i="0">
+              <a:rPr sz="1100" b="0" i="0">
                 <a:solidFill>
                   <a:srgbClr val="2C2C2C"/>
                 </a:solidFill>
@@ -25154,11 +24968,11 @@
           <a:p>
             <a:pPr>
               <a:spcAft>
-                <a:spcPts val="200"/>
+                <a:spcPts val="400"/>
               </a:spcAft>
             </a:pPr>
             <a:r>
-              <a:rPr sz="1050" b="1" i="0">
+              <a:rPr sz="1100" b="1" i="0">
                 <a:solidFill>
                   <a:srgbClr val="B4862D"/>
                 </a:solidFill>
@@ -25167,7 +24981,7 @@
               <a:t>•  </a:t>
             </a:r>
             <a:r>
-              <a:rPr sz="1050" b="0" i="0">
+              <a:rPr sz="1100" b="0" i="0">
                 <a:solidFill>
                   <a:srgbClr val="2C2C2C"/>
                 </a:solidFill>
@@ -25179,11 +24993,11 @@
           <a:p>
             <a:pPr>
               <a:spcAft>
-                <a:spcPts val="200"/>
+                <a:spcPts val="400"/>
               </a:spcAft>
             </a:pPr>
             <a:r>
-              <a:rPr sz="1050" b="1" i="0">
+              <a:rPr sz="1100" b="1" i="0">
                 <a:solidFill>
                   <a:srgbClr val="B4862D"/>
                 </a:solidFill>
@@ -25192,7 +25006,7 @@
               <a:t>•  </a:t>
             </a:r>
             <a:r>
-              <a:rPr sz="1050" b="0" i="0">
+              <a:rPr sz="1100" b="0" i="0">
                 <a:solidFill>
                   <a:srgbClr val="2C2C2C"/>
                 </a:solidFill>
@@ -25204,11 +25018,11 @@
           <a:p>
             <a:pPr>
               <a:spcAft>
-                <a:spcPts val="200"/>
+                <a:spcPts val="400"/>
               </a:spcAft>
             </a:pPr>
             <a:r>
-              <a:rPr sz="1050" b="1" i="0">
+              <a:rPr sz="1100" b="1" i="0">
                 <a:solidFill>
                   <a:srgbClr val="B4862D"/>
                 </a:solidFill>
@@ -25217,7 +25031,7 @@
               <a:t>•  </a:t>
             </a:r>
             <a:r>
-              <a:rPr sz="1050" b="0" i="0">
+              <a:rPr sz="1100" b="0" i="0">
                 <a:solidFill>
                   <a:srgbClr val="2C2C2C"/>
                 </a:solidFill>
@@ -25229,11 +25043,11 @@
           <a:p>
             <a:pPr>
               <a:spcAft>
-                <a:spcPts val="200"/>
+                <a:spcPts val="400"/>
               </a:spcAft>
             </a:pPr>
             <a:r>
-              <a:rPr sz="1050" b="1" i="0">
+              <a:rPr sz="1100" b="1" i="0">
                 <a:solidFill>
                   <a:srgbClr val="B4862D"/>
                 </a:solidFill>
@@ -25242,65 +25056,23 @@
               <a:t>•  </a:t>
             </a:r>
             <a:r>
-              <a:rPr sz="1050" b="0" i="0">
+              <a:rPr sz="1100" b="0" i="0">
                 <a:solidFill>
                   <a:srgbClr val="2C2C2C"/>
                 </a:solidFill>
                 <a:latin typeface="Open Sans"/>
               </a:rPr>
-              <a:t>Officeholders: official government sources and 2026-dated press, verified 2026-07-16 with an independent second pass.</a:t>
-            </a:r>
-          </a:p>
-        </p:txBody>
-      </p:sp>
-      <p:sp>
-        <p:nvSpPr>
-          <p:cNvPr id="7" name="TextBox 6"/>
-          <p:cNvSpPr txBox="1"/>
-          <p:nvPr/>
-        </p:nvSpPr>
-        <p:spPr>
-          <a:xfrm>
-            <a:off x="6355080" y="1298448"/>
-            <a:ext cx="5303520" cy="4846320"/>
-          </a:xfrm>
-          <a:prstGeom prst="rect">
-            <a:avLst/>
-          </a:prstGeom>
-          <a:noFill/>
-        </p:spPr>
-        <p:txBody>
-          <a:bodyPr wrap="square" anchor="t" lIns="0" rIns="0" tIns="0" bIns="0">
-            <a:spAutoFit/>
-          </a:bodyPr>
-          <a:lstStyle/>
+              <a:t>EU &amp; African Union annex: IMF WEO, Eurostat, USTR, and official EU/AU sources, verified 2026-07-16.</a:t>
+            </a:r>
+          </a:p>
           <a:p>
             <a:pPr>
-              <a:spcBef>
-                <a:spcPts val="0"/>
-              </a:spcBef>
               <a:spcAft>
-                <a:spcPts val="300"/>
+                <a:spcPts val="400"/>
               </a:spcAft>
             </a:pPr>
             <a:r>
-              <a:rPr sz="1150" b="1" i="0" spc="60">
-                <a:solidFill>
-                  <a:srgbClr val="0A314D"/>
-                </a:solidFill>
-                <a:latin typeface="Open Sans"/>
-              </a:rPr>
-              <a:t>MEASUREMENT NOTES</a:t>
-            </a:r>
-          </a:p>
-          <a:p>
-            <a:pPr>
-              <a:spcAft>
-                <a:spcPts val="200"/>
-              </a:spcAft>
-            </a:pPr>
-            <a:r>
-              <a:rPr sz="1050" b="1" i="0">
+              <a:rPr sz="1100" b="1" i="0">
                 <a:solidFill>
                   <a:srgbClr val="B4862D"/>
                 </a:solidFill>
@@ -25309,208 +25081,20 @@
               <a:t>•  </a:t>
             </a:r>
             <a:r>
-              <a:rPr sz="1050" b="0" i="0">
+              <a:rPr sz="1100" b="0" i="0">
                 <a:solidFill>
                   <a:srgbClr val="2C2C2C"/>
                 </a:solidFill>
                 <a:latin typeface="Open Sans"/>
               </a:rPr>
-              <a:t>Australia's overall balance is goods+services; India's is fiscal year 2025-26. All others goods-only, calendar 2025.</a:t>
-            </a:r>
-          </a:p>
-          <a:p>
-            <a:pPr>
-              <a:spcAft>
-                <a:spcPts val="200"/>
-              </a:spcAft>
-            </a:pPr>
-            <a:r>
-              <a:rPr sz="1050" b="1" i="0">
-                <a:solidFill>
-                  <a:srgbClr val="B4862D"/>
-                </a:solidFill>
-                <a:latin typeface="Open Sans"/>
-              </a:rPr>
-              <a:t>•  </a:t>
-            </a:r>
-            <a:r>
-              <a:rPr sz="1050" b="0" i="0">
-                <a:solidFill>
-                  <a:srgbClr val="2C2C2C"/>
-                </a:solidFill>
-                <a:latin typeface="Open Sans"/>
-              </a:rPr>
-              <a:t>Several overall balances are converted from local currency (EUR/GBP/CAD/AUD/JPY/SAR) at ~2025 average rates; USD values carry exchange-rate uncertainty.</a:t>
-            </a:r>
-          </a:p>
-          <a:p>
-            <a:pPr>
-              <a:spcAft>
-                <a:spcPts val="200"/>
-              </a:spcAft>
-            </a:pPr>
-            <a:r>
-              <a:rPr sz="1050" b="1" i="0">
-                <a:solidFill>
-                  <a:srgbClr val="B4862D"/>
-                </a:solidFill>
-                <a:latin typeface="Open Sans"/>
-              </a:rPr>
-              <a:t>•  </a:t>
-            </a:r>
-            <a:r>
-              <a:rPr sz="1050" b="0" i="0">
-                <a:solidFill>
-                  <a:srgbClr val="2C2C2C"/>
-                </a:solidFill>
-                <a:latin typeface="Open Sans"/>
-              </a:rPr>
-              <a:t>census.gov and imf.org were not directly reachable from the build environment; figures come from official-data-derived channels.</a:t>
-            </a:r>
-          </a:p>
-          <a:p>
-            <a:pPr>
-              <a:spcBef>
-                <a:spcPts val="1000"/>
-              </a:spcBef>
-              <a:spcAft>
-                <a:spcPts val="300"/>
-              </a:spcAft>
-            </a:pPr>
-            <a:r>
-              <a:rPr sz="1150" b="1" i="0" spc="60">
-                <a:solidFill>
-                  <a:srgbClr val="0A314D"/>
-                </a:solidFill>
-                <a:latin typeface="Open Sans"/>
-              </a:rPr>
-              <a:t>IMAGERY &amp; FORMAT</a:t>
-            </a:r>
-          </a:p>
-          <a:p>
-            <a:pPr>
-              <a:spcAft>
-                <a:spcPts val="200"/>
-              </a:spcAft>
-            </a:pPr>
-            <a:r>
-              <a:rPr sz="1050" b="1" i="0">
-                <a:solidFill>
-                  <a:srgbClr val="B4862D"/>
-                </a:solidFill>
-                <a:latin typeface="Open Sans"/>
-              </a:rPr>
-              <a:t>•  </a:t>
-            </a:r>
-            <a:r>
-              <a:rPr sz="1050" b="0" i="0">
-                <a:solidFill>
-                  <a:srgbClr val="2C2C2C"/>
-                </a:solidFill>
-                <a:latin typeface="Open Sans"/>
-              </a:rPr>
-              <a:t>Flags: public-domain renderings, uniform height, true aspect ratios.</a:t>
-            </a:r>
-          </a:p>
-          <a:p>
-            <a:pPr>
-              <a:spcAft>
-                <a:spcPts val="200"/>
-              </a:spcAft>
-            </a:pPr>
-            <a:r>
-              <a:rPr sz="1050" b="1" i="0">
-                <a:solidFill>
-                  <a:srgbClr val="B4862D"/>
-                </a:solidFill>
-                <a:latin typeface="Open Sans"/>
-              </a:rPr>
-              <a:t>•  </a:t>
-            </a:r>
-            <a:r>
-              <a:rPr sz="1050" b="0" i="0">
-                <a:solidFill>
-                  <a:srgbClr val="2C2C2C"/>
-                </a:solidFill>
-                <a:latin typeface="Open Sans"/>
-              </a:rPr>
-              <a:t>Design per the ITA Visual Style Guide (Jan 2026): Trade Navy/Blue palette, Open Sans, official signatures.</a:t>
-            </a:r>
-          </a:p>
-          <a:p>
-            <a:pPr>
-              <a:spcBef>
-                <a:spcPts val="1000"/>
-              </a:spcBef>
-              <a:spcAft>
-                <a:spcPts val="300"/>
-              </a:spcAft>
-            </a:pPr>
-            <a:r>
-              <a:rPr sz="1150" b="1" i="0" spc="60">
-                <a:solidFill>
-                  <a:srgbClr val="0A314D"/>
-                </a:solidFill>
-                <a:latin typeface="Open Sans"/>
-              </a:rPr>
-              <a:t>SCOPE</a:t>
-            </a:r>
-          </a:p>
-          <a:p>
-            <a:pPr>
-              <a:spcAft>
-                <a:spcPts val="200"/>
-              </a:spcAft>
-            </a:pPr>
-            <a:r>
-              <a:rPr sz="1050" b="1" i="0">
-                <a:solidFill>
-                  <a:srgbClr val="B4862D"/>
-                </a:solidFill>
-                <a:latin typeface="Open Sans"/>
-              </a:rPr>
-              <a:t>•  </a:t>
-            </a:r>
-            <a:r>
-              <a:rPr sz="1050" b="0" i="0">
-                <a:solidFill>
-                  <a:srgbClr val="2C2C2C"/>
-                </a:solidFill>
-                <a:latin typeface="Open Sans"/>
-              </a:rPr>
-              <a:t>Poland substituted for South Africa. The EU and African Union hold G20 bloc seats and are profiled in the bloc annex.</a:t>
-            </a:r>
-          </a:p>
-          <a:p>
-            <a:pPr>
-              <a:spcAft>
-                <a:spcPts val="200"/>
-              </a:spcAft>
-            </a:pPr>
-            <a:r>
-              <a:rPr sz="1050" b="1" i="0">
-                <a:solidFill>
-                  <a:srgbClr val="B4862D"/>
-                </a:solidFill>
-                <a:latin typeface="Open Sans"/>
-              </a:rPr>
-              <a:t>•  </a:t>
-            </a:r>
-            <a:r>
-              <a:rPr sz="1050" b="0" i="0">
-                <a:solidFill>
-                  <a:srgbClr val="2C2C2C"/>
-                </a:solidFill>
-                <a:latin typeface="Open Sans"/>
-              </a:rPr>
-              <a:t>A detailed uncertainty register (acting officials, figures pending confirmation) accompanies this deck: output/GAPS.md.</a:t>
+              <a:t>Officeholders: official government sources and 2026-dated press, verified 2026-07-16 with an independent second pass.</a:t>
             </a:r>
           </a:p>
         </p:txBody>
       </p:sp>
       <p:cxnSp>
         <p:nvCxnSpPr>
-          <p:cNvPr id="8" name="Connector 7"/>
+          <p:cNvPr id="7" name="Connector 6"/>
           <p:cNvCxnSpPr/>
           <p:nvPr/>
         </p:nvCxnSpPr>
@@ -25546,7 +25130,7 @@
       </p:cxnSp>
       <p:sp>
         <p:nvSpPr>
-          <p:cNvPr id="9" name="TextBox 8"/>
+          <p:cNvPr id="8" name="TextBox 7"/>
           <p:cNvSpPr txBox="1"/>
           <p:nvPr/>
         </p:nvSpPr>
@@ -25580,7 +25164,7 @@
       </p:sp>
       <p:sp>
         <p:nvSpPr>
-          <p:cNvPr id="10" name="TextBox 9"/>
+          <p:cNvPr id="9" name="TextBox 8"/>
           <p:cNvSpPr txBox="1"/>
           <p:nvPr/>
         </p:nvSpPr>
@@ -25614,7 +25198,7 @@
       </p:sp>
       <p:sp>
         <p:nvSpPr>
-          <p:cNvPr id="11" name="TextBox 10"/>
+          <p:cNvPr id="10" name="TextBox 9"/>
           <p:cNvSpPr txBox="1"/>
           <p:nvPr/>
         </p:nvSpPr>
@@ -31184,8 +30768,8 @@
         </p:nvSpPr>
         <p:spPr>
           <a:xfrm>
-            <a:off x="3611880" y="1426464"/>
-            <a:ext cx="8028431" cy="274320"/>
+            <a:off x="3611880" y="1408176"/>
+            <a:ext cx="8028431" cy="256032"/>
           </a:xfrm>
           <a:prstGeom prst="rect">
             <a:avLst/>
@@ -31218,8 +30802,8 @@
         </p:nvSpPr>
         <p:spPr>
           <a:xfrm>
-            <a:off x="3611880" y="1719072"/>
-            <a:ext cx="8028431" cy="420624"/>
+            <a:off x="3611880" y="1682495"/>
+            <a:ext cx="8028431" cy="347472"/>
           </a:xfrm>
           <a:prstGeom prst="rect">
             <a:avLst/>
@@ -31257,8 +30841,8 @@
         </p:nvSpPr>
         <p:spPr>
           <a:xfrm>
-            <a:off x="3611880" y="2157984"/>
-            <a:ext cx="8028431" cy="347472"/>
+            <a:off x="3611880" y="2048256"/>
+            <a:ext cx="8028431" cy="292608"/>
           </a:xfrm>
           <a:prstGeom prst="rect">
             <a:avLst/>
@@ -31305,8 +30889,8 @@
         </p:nvSpPr>
         <p:spPr>
           <a:xfrm>
-            <a:off x="3611880" y="2578608"/>
-            <a:ext cx="8028431" cy="1152143"/>
+            <a:off x="3611880" y="2377440"/>
+            <a:ext cx="8028431" cy="1353311"/>
           </a:xfrm>
           <a:prstGeom prst="rect">
             <a:avLst/>
@@ -31331,7 +30915,7 @@
                 </a:solidFill>
                 <a:latin typeface="Open Sans"/>
               </a:rPr>
-              <a:t>Darío Leandro Genua, a business-administration graduate of the Universidad Catolica Argentina with a postgraduate degree in information systems and administrative processes, became Secretary of Innovation, Science and Technology in June 2024, succeeding Alejandro Cosentino. He previously served as executive coordinator of the intervention of ENACOM, Argentina's telecommunications regulator, working on the repeal of DNU 690 and satellite-internet opening.</a:t>
+              <a:t>Darío Leandro Genua, a business-administration graduate of the Universidad Catolica Argentina with a postgraduate degree in information systems and administrative processes, became Secretary of Innovation, Science and Technology in June 2024, succeeding Alejandro Cosentino. He previously served as executive coordinator of the intervention of ENACOM, Argentina's telecommunications regulator, working on the repeal of DNU 690 and satellite-internet opening. His secretariat leads state digitalization, digital public services, connectivity and telecommunications policy under the Chief of Cabinet.</a:t>
             </a:r>
           </a:p>
           <a:p>
@@ -31430,8 +31014,8 @@
         </p:nvSpPr>
         <p:spPr>
           <a:xfrm>
-            <a:off x="3611880" y="4041648"/>
-            <a:ext cx="3849624" cy="1152144"/>
+            <a:off x="3611880" y="4023359"/>
+            <a:ext cx="3849624" cy="914400"/>
           </a:xfrm>
           <a:prstGeom prst="rect">
             <a:avLst/>
@@ -31499,8 +31083,8 @@
         </p:nvSpPr>
         <p:spPr>
           <a:xfrm>
-            <a:off x="3611880" y="5047488"/>
-            <a:ext cx="3849624" cy="310896"/>
+            <a:off x="3611880" y="4956048"/>
+            <a:ext cx="3849624" cy="292608"/>
           </a:xfrm>
           <a:prstGeom prst="rect">
             <a:avLst/>
@@ -31547,8 +31131,8 @@
         </p:nvSpPr>
         <p:spPr>
           <a:xfrm>
-            <a:off x="3611880" y="5376672"/>
-            <a:ext cx="3849624" cy="987551"/>
+            <a:off x="3611880" y="5266944"/>
+            <a:ext cx="3849624" cy="1097279"/>
           </a:xfrm>
           <a:prstGeom prst="rect">
             <a:avLst/>
@@ -31586,8 +31170,8 @@
         </p:nvSpPr>
         <p:spPr>
           <a:xfrm>
-            <a:off x="7790688" y="4041648"/>
-            <a:ext cx="3849624" cy="1152144"/>
+            <a:off x="7790688" y="4023359"/>
+            <a:ext cx="3849624" cy="914400"/>
           </a:xfrm>
           <a:prstGeom prst="rect">
             <a:avLst/>
@@ -31664,8 +31248,8 @@
         </p:nvSpPr>
         <p:spPr>
           <a:xfrm>
-            <a:off x="7790688" y="5047488"/>
-            <a:ext cx="3849624" cy="310896"/>
+            <a:off x="7790688" y="4956048"/>
+            <a:ext cx="3849624" cy="292608"/>
           </a:xfrm>
           <a:prstGeom prst="rect">
             <a:avLst/>
@@ -31712,8 +31296,8 @@
         </p:nvSpPr>
         <p:spPr>
           <a:xfrm>
-            <a:off x="7790688" y="5376672"/>
-            <a:ext cx="3849624" cy="987551"/>
+            <a:off x="7790688" y="5266944"/>
+            <a:ext cx="3849624" cy="1097279"/>
           </a:xfrm>
           <a:prstGeom prst="rect">
             <a:avLst/>
@@ -32531,8 +32115,8 @@
         </p:nvSpPr>
         <p:spPr>
           <a:xfrm>
-            <a:off x="3611880" y="1408176"/>
-            <a:ext cx="3849624" cy="1152144"/>
+            <a:off x="3611880" y="1389888"/>
+            <a:ext cx="3849624" cy="914400"/>
           </a:xfrm>
           <a:prstGeom prst="rect">
             <a:avLst/>
@@ -32600,8 +32184,8 @@
         </p:nvSpPr>
         <p:spPr>
           <a:xfrm>
-            <a:off x="3611880" y="2414015"/>
-            <a:ext cx="3849624" cy="310896"/>
+            <a:off x="3611880" y="2322576"/>
+            <a:ext cx="3849624" cy="292608"/>
           </a:xfrm>
           <a:prstGeom prst="rect">
             <a:avLst/>
@@ -32648,8 +32232,8 @@
         </p:nvSpPr>
         <p:spPr>
           <a:xfrm>
-            <a:off x="3611880" y="2743200"/>
-            <a:ext cx="3849624" cy="987551"/>
+            <a:off x="3611880" y="2633472"/>
+            <a:ext cx="3849624" cy="1097279"/>
           </a:xfrm>
           <a:prstGeom prst="rect">
             <a:avLst/>
@@ -32687,8 +32271,8 @@
         </p:nvSpPr>
         <p:spPr>
           <a:xfrm>
-            <a:off x="7790688" y="1408176"/>
-            <a:ext cx="3849624" cy="1152144"/>
+            <a:off x="7790688" y="1389888"/>
+            <a:ext cx="3849624" cy="914400"/>
           </a:xfrm>
           <a:prstGeom prst="rect">
             <a:avLst/>
@@ -32756,8 +32340,8 @@
         </p:nvSpPr>
         <p:spPr>
           <a:xfrm>
-            <a:off x="7790688" y="2414015"/>
-            <a:ext cx="3849624" cy="310896"/>
+            <a:off x="7790688" y="2322576"/>
+            <a:ext cx="3849624" cy="292608"/>
           </a:xfrm>
           <a:prstGeom prst="rect">
             <a:avLst/>
@@ -32804,8 +32388,8 @@
         </p:nvSpPr>
         <p:spPr>
           <a:xfrm>
-            <a:off x="7790688" y="2743200"/>
-            <a:ext cx="3849624" cy="987551"/>
+            <a:off x="7790688" y="2633472"/>
+            <a:ext cx="3849624" cy="1097279"/>
           </a:xfrm>
           <a:prstGeom prst="rect">
             <a:avLst/>
@@ -32913,8 +32497,8 @@
         </p:nvSpPr>
         <p:spPr>
           <a:xfrm>
-            <a:off x="3611880" y="4059935"/>
-            <a:ext cx="8028431" cy="274320"/>
+            <a:off x="3611880" y="4041648"/>
+            <a:ext cx="8028431" cy="256032"/>
           </a:xfrm>
           <a:prstGeom prst="rect">
             <a:avLst/>
@@ -32947,8 +32531,8 @@
         </p:nvSpPr>
         <p:spPr>
           <a:xfrm>
-            <a:off x="3611880" y="4352544"/>
-            <a:ext cx="8028431" cy="420624"/>
+            <a:off x="3611880" y="4315968"/>
+            <a:ext cx="8028431" cy="347472"/>
           </a:xfrm>
           <a:prstGeom prst="rect">
             <a:avLst/>
@@ -32986,8 +32570,8 @@
         </p:nvSpPr>
         <p:spPr>
           <a:xfrm>
-            <a:off x="3611880" y="4791456"/>
-            <a:ext cx="8028431" cy="347472"/>
+            <a:off x="3611880" y="4681727"/>
+            <a:ext cx="8028431" cy="292608"/>
           </a:xfrm>
           <a:prstGeom prst="rect">
             <a:avLst/>
@@ -33034,8 +32618,8 @@
         </p:nvSpPr>
         <p:spPr>
           <a:xfrm>
-            <a:off x="3611880" y="5212079"/>
-            <a:ext cx="8028431" cy="1152143"/>
+            <a:off x="3611880" y="5010912"/>
+            <a:ext cx="8028431" cy="1353311"/>
           </a:xfrm>
           <a:prstGeom prst="rect">
             <a:avLst/>
@@ -33869,8 +33453,8 @@
         </p:nvSpPr>
         <p:spPr>
           <a:xfrm>
-            <a:off x="3611880" y="1408176"/>
-            <a:ext cx="3849624" cy="1152144"/>
+            <a:off x="3611880" y="1389888"/>
+            <a:ext cx="3849624" cy="914400"/>
           </a:xfrm>
           <a:prstGeom prst="rect">
             <a:avLst/>
@@ -33938,8 +33522,8 @@
         </p:nvSpPr>
         <p:spPr>
           <a:xfrm>
-            <a:off x="3611880" y="2414015"/>
-            <a:ext cx="3849624" cy="310896"/>
+            <a:off x="3611880" y="2322576"/>
+            <a:ext cx="3849624" cy="292608"/>
           </a:xfrm>
           <a:prstGeom prst="rect">
             <a:avLst/>
@@ -33986,8 +33570,8 @@
         </p:nvSpPr>
         <p:spPr>
           <a:xfrm>
-            <a:off x="3611880" y="2743200"/>
-            <a:ext cx="3849624" cy="987551"/>
+            <a:off x="3611880" y="2633472"/>
+            <a:ext cx="3849624" cy="1097279"/>
           </a:xfrm>
           <a:prstGeom prst="rect">
             <a:avLst/>
@@ -34025,8 +33609,8 @@
         </p:nvSpPr>
         <p:spPr>
           <a:xfrm>
-            <a:off x="7790688" y="1408176"/>
-            <a:ext cx="3849624" cy="1152144"/>
+            <a:off x="7790688" y="1389888"/>
+            <a:ext cx="3849624" cy="914400"/>
           </a:xfrm>
           <a:prstGeom prst="rect">
             <a:avLst/>
@@ -34094,8 +33678,8 @@
         </p:nvSpPr>
         <p:spPr>
           <a:xfrm>
-            <a:off x="7790688" y="2414015"/>
-            <a:ext cx="3849624" cy="310896"/>
+            <a:off x="7790688" y="2322576"/>
+            <a:ext cx="3849624" cy="292608"/>
           </a:xfrm>
           <a:prstGeom prst="rect">
             <a:avLst/>
@@ -34142,8 +33726,8 @@
         </p:nvSpPr>
         <p:spPr>
           <a:xfrm>
-            <a:off x="7790688" y="2743200"/>
-            <a:ext cx="3849624" cy="987551"/>
+            <a:off x="7790688" y="2633472"/>
+            <a:ext cx="3849624" cy="1097279"/>
           </a:xfrm>
           <a:prstGeom prst="rect">
             <a:avLst/>
@@ -34238,7 +33822,7 @@
                 </a:solidFill>
                 <a:latin typeface="Open Sans"/>
               </a:rPr>
-              <a:t>TRADE / COMMERCE  ·  SPLIT PORTFOLIO</a:t>
+              <a:t>TRADE / COMMERCE</a:t>
             </a:r>
           </a:p>
         </p:txBody>
@@ -34252,37 +33836,21 @@
         <p:spPr>
           <a:xfrm>
             <a:off x="3611880" y="4041648"/>
-            <a:ext cx="3849624" cy="1152144"/>
-          </a:xfrm>
-          <a:prstGeom prst="rect">
-            <a:avLst/>
-          </a:prstGeom>
-          <a:noFill/>
-        </p:spPr>
-        <p:txBody>
-          <a:bodyPr wrap="square" anchor="t" lIns="0" rIns="0" tIns="0" bIns="0">
-            <a:spAutoFit/>
-          </a:bodyPr>
-          <a:lstStyle/>
-          <a:p>
-            <a:r>
-              <a:rPr sz="750" b="1" i="0" spc="80">
-                <a:solidFill>
-                  <a:srgbClr val="007582"/>
-                </a:solidFill>
-                <a:latin typeface="Open Sans"/>
-              </a:rPr>
-              <a:t>MDIC MINISTER</a:t>
-            </a:r>
-          </a:p>
-          <a:p>
-            <a:pPr>
-              <a:spcBef>
-                <a:spcPts val="200"/>
-              </a:spcBef>
-            </a:pPr>
-            <a:r>
-              <a:rPr sz="1200" b="1" i="0">
+            <a:ext cx="8028431" cy="256032"/>
+          </a:xfrm>
+          <a:prstGeom prst="rect">
+            <a:avLst/>
+          </a:prstGeom>
+          <a:noFill/>
+        </p:spPr>
+        <p:txBody>
+          <a:bodyPr wrap="square" anchor="t" lIns="0" rIns="0" tIns="0" bIns="0">
+            <a:spAutoFit/>
+          </a:bodyPr>
+          <a:lstStyle/>
+          <a:p>
+            <a:r>
+              <a:rPr sz="1400" b="1" i="0">
                 <a:solidFill>
                   <a:srgbClr val="0A314D"/>
                 </a:solidFill>
@@ -34291,17 +33859,37 @@
               <a:t>Márcio Fernando Elias Rosa</a:t>
             </a:r>
           </a:p>
+        </p:txBody>
+      </p:sp>
+      <p:sp>
+        <p:nvSpPr>
+          <p:cNvPr id="25" name="TextBox 24"/>
+          <p:cNvSpPr txBox="1"/>
+          <p:nvPr/>
+        </p:nvSpPr>
+        <p:spPr>
+          <a:xfrm>
+            <a:off x="3611880" y="4315968"/>
+            <a:ext cx="8028431" cy="347472"/>
+          </a:xfrm>
+          <a:prstGeom prst="rect">
+            <a:avLst/>
+          </a:prstGeom>
+          <a:noFill/>
+        </p:spPr>
+        <p:txBody>
+          <a:bodyPr wrap="square" anchor="t" lIns="0" rIns="0" tIns="0" bIns="0">
+            <a:spAutoFit/>
+          </a:bodyPr>
+          <a:lstStyle/>
           <a:p>
             <a:pPr>
               <a:lnSpc>
-                <a:spcPct val="104000"/>
+                <a:spcPct val="105000"/>
               </a:lnSpc>
-              <a:spcBef>
-                <a:spcPts val="200"/>
-              </a:spcBef>
             </a:pPr>
             <a:r>
-              <a:rPr sz="900" b="0" i="1">
+              <a:rPr sz="1100" b="0" i="1">
                 <a:solidFill>
                   <a:srgbClr val="54606C"/>
                 </a:solidFill>
@@ -34314,14 +33902,14 @@
       </p:sp>
       <p:sp>
         <p:nvSpPr>
-          <p:cNvPr id="25" name="TextBox 24"/>
-          <p:cNvSpPr txBox="1"/>
-          <p:nvPr/>
-        </p:nvSpPr>
-        <p:spPr>
-          <a:xfrm>
-            <a:off x="3611880" y="5047488"/>
-            <a:ext cx="3849624" cy="310896"/>
+          <p:cNvPr id="26" name="TextBox 25"/>
+          <p:cNvSpPr txBox="1"/>
+          <p:nvPr/>
+        </p:nvSpPr>
+        <p:spPr>
+          <a:xfrm>
+            <a:off x="3611880" y="4681727"/>
+            <a:ext cx="8028431" cy="292608"/>
           </a:xfrm>
           <a:prstGeom prst="rect">
             <a:avLst/>
@@ -34336,11 +33924,11 @@
           <a:p>
             <a:pPr>
               <a:lnSpc>
-                <a:spcPct val="104000"/>
+                <a:spcPct val="105000"/>
               </a:lnSpc>
             </a:pPr>
             <a:r>
-              <a:rPr sz="850" b="0" i="0">
+              <a:rPr sz="950" b="0" i="0">
                 <a:solidFill>
                   <a:srgbClr val="2C2C2C"/>
                 </a:solidFill>
@@ -34349,27 +33937,27 @@
               <a:t>Ministry of Development, Industry, Trade and Services (Ministério do Desenvolvimento, Indústria, Comércio e Serviços, MDIC)</a:t>
             </a:r>
             <a:r>
-              <a:rPr sz="850" b="0" i="0">
+              <a:rPr sz="950" b="0" i="0">
                 <a:solidFill>
                   <a:srgbClr val="757D87"/>
                 </a:solidFill>
                 <a:latin typeface="Open Sans"/>
               </a:rPr>
-              <a:t>  ·  2026-04-06</a:t>
-            </a:r>
-          </a:p>
-        </p:txBody>
-      </p:sp>
-      <p:sp>
-        <p:nvSpPr>
-          <p:cNvPr id="26" name="TextBox 25"/>
-          <p:cNvSpPr txBox="1"/>
-          <p:nvPr/>
-        </p:nvSpPr>
-        <p:spPr>
-          <a:xfrm>
-            <a:off x="3611880" y="5376672"/>
-            <a:ext cx="3849624" cy="987551"/>
+              <a:t>   ·   Assumed office: 2026-04-06</a:t>
+            </a:r>
+          </a:p>
+        </p:txBody>
+      </p:sp>
+      <p:sp>
+        <p:nvSpPr>
+          <p:cNvPr id="27" name="TextBox 26"/>
+          <p:cNvSpPr txBox="1"/>
+          <p:nvPr/>
+        </p:nvSpPr>
+        <p:spPr>
+          <a:xfrm>
+            <a:off x="3611880" y="5010912"/>
+            <a:ext cx="8028431" cy="1353311"/>
           </a:xfrm>
           <a:prstGeom prst="rect">
             <a:avLst/>
@@ -34384,180 +33972,24 @@
           <a:p>
             <a:pPr>
               <a:lnSpc>
-                <a:spcPct val="104000"/>
+                <a:spcPct val="103000"/>
               </a:lnSpc>
             </a:pPr>
             <a:r>
-              <a:rPr sz="1050" b="0" i="0">
+              <a:rPr sz="1100" b="0" i="0">
                 <a:solidFill>
                   <a:srgbClr val="2C2C2C"/>
                 </a:solidFill>
                 <a:latin typeface="Open Sans"/>
               </a:rPr>
-              <a:t>Márcio Fernando Elias Rosa, a retired public prosecutor who twice served as São Paulo Attorney General of Justice (2012-2016), joined MDIC as Executive Secretary in January 2023 and was sworn in as Minister on 6 April 2026, succeeding Geraldo Alckmin.</a:t>
-            </a:r>
-          </a:p>
-        </p:txBody>
-      </p:sp>
-      <p:sp>
-        <p:nvSpPr>
-          <p:cNvPr id="27" name="TextBox 26"/>
-          <p:cNvSpPr txBox="1"/>
-          <p:nvPr/>
-        </p:nvSpPr>
-        <p:spPr>
-          <a:xfrm>
-            <a:off x="7790688" y="4041648"/>
-            <a:ext cx="3849624" cy="1152144"/>
-          </a:xfrm>
-          <a:prstGeom prst="rect">
-            <a:avLst/>
-          </a:prstGeom>
-          <a:noFill/>
-        </p:spPr>
-        <p:txBody>
-          <a:bodyPr wrap="square" anchor="t" lIns="0" rIns="0" tIns="0" bIns="0">
-            <a:spAutoFit/>
-          </a:bodyPr>
-          <a:lstStyle/>
-          <a:p>
-            <a:r>
-              <a:rPr sz="750" b="1" i="0" spc="80">
-                <a:solidFill>
-                  <a:srgbClr val="007582"/>
-                </a:solidFill>
-                <a:latin typeface="Open Sans"/>
-              </a:rPr>
-              <a:t>FOREIGN TRADE (SECEX)</a:t>
-            </a:r>
-          </a:p>
-          <a:p>
-            <a:pPr>
-              <a:spcBef>
-                <a:spcPts val="200"/>
-              </a:spcBef>
-            </a:pPr>
-            <a:r>
-              <a:rPr sz="1200" b="1" i="0">
-                <a:solidFill>
-                  <a:srgbClr val="0A314D"/>
-                </a:solidFill>
-                <a:latin typeface="Open Sans"/>
-              </a:rPr>
-              <a:t>Lucas Pedreira do Couto Ferraz</a:t>
-            </a:r>
-          </a:p>
-          <a:p>
-            <a:pPr>
-              <a:lnSpc>
-                <a:spcPct val="104000"/>
-              </a:lnSpc>
-              <a:spcBef>
-                <a:spcPts val="200"/>
-              </a:spcBef>
-            </a:pPr>
-            <a:r>
-              <a:rPr sz="900" b="0" i="1">
-                <a:solidFill>
-                  <a:srgbClr val="54606C"/>
-                </a:solidFill>
-                <a:latin typeface="Open Sans"/>
-              </a:rPr>
-              <a:t>Secretary of Foreign Trade (SECEX)</a:t>
-            </a:r>
-          </a:p>
-        </p:txBody>
-      </p:sp>
-      <p:sp>
-        <p:nvSpPr>
-          <p:cNvPr id="28" name="TextBox 27"/>
-          <p:cNvSpPr txBox="1"/>
-          <p:nvPr/>
-        </p:nvSpPr>
-        <p:spPr>
-          <a:xfrm>
-            <a:off x="7790688" y="5047488"/>
-            <a:ext cx="3849624" cy="310896"/>
-          </a:xfrm>
-          <a:prstGeom prst="rect">
-            <a:avLst/>
-          </a:prstGeom>
-          <a:noFill/>
-        </p:spPr>
-        <p:txBody>
-          <a:bodyPr wrap="square" anchor="t" lIns="0" rIns="0" tIns="0" bIns="0">
-            <a:spAutoFit/>
-          </a:bodyPr>
-          <a:lstStyle/>
-          <a:p>
-            <a:pPr>
-              <a:lnSpc>
-                <a:spcPct val="104000"/>
-              </a:lnSpc>
-            </a:pPr>
-            <a:r>
-              <a:rPr sz="850" b="0" i="0">
-                <a:solidFill>
-                  <a:srgbClr val="2C2C2C"/>
-                </a:solidFill>
-                <a:latin typeface="Open Sans"/>
-              </a:rPr>
-              <a:t>Ministry of Development, Industry, Trade and Services (MDIC) - Secretariat of Foreign Trade (SECEX)</a:t>
-            </a:r>
-            <a:r>
-              <a:rPr sz="850" b="0" i="0">
-                <a:solidFill>
-                  <a:srgbClr val="757D87"/>
-                </a:solidFill>
-                <a:latin typeface="Open Sans"/>
-              </a:rPr>
-              <a:t>  ·  2023-01-01</a:t>
-            </a:r>
-          </a:p>
-        </p:txBody>
-      </p:sp>
-      <p:sp>
-        <p:nvSpPr>
-          <p:cNvPr id="29" name="TextBox 28"/>
-          <p:cNvSpPr txBox="1"/>
-          <p:nvPr/>
-        </p:nvSpPr>
-        <p:spPr>
-          <a:xfrm>
-            <a:off x="7790688" y="5376672"/>
-            <a:ext cx="3849624" cy="987551"/>
-          </a:xfrm>
-          <a:prstGeom prst="rect">
-            <a:avLst/>
-          </a:prstGeom>
-          <a:noFill/>
-        </p:spPr>
-        <p:txBody>
-          <a:bodyPr wrap="square" anchor="t" lIns="0" rIns="0" tIns="0" bIns="0">
-            <a:spAutoFit/>
-          </a:bodyPr>
-          <a:lstStyle/>
-          <a:p>
-            <a:pPr>
-              <a:lnSpc>
-                <a:spcPct val="104000"/>
-              </a:lnSpc>
-            </a:pPr>
-            <a:r>
-              <a:rPr sz="1050" b="0" i="0">
-                <a:solidFill>
-                  <a:srgbClr val="2C2C2C"/>
-                </a:solidFill>
-                <a:latin typeface="Open Sans"/>
-              </a:rPr>
-              <a:t>Lucas Pedreira do Couto Ferraz, an economist with a PhD from FGV's EPGE, where he is a professor, has served as MDIC Secretary of Foreign Trade (SECEX) since January 2023, leading trade negotiations including the Mercosur-EU and OECD agendas.</a:t>
+              <a:t>Retired public prosecutor, lawyer and law professor, born in Ibiúna, São Paulo, in 1962. He spent his career in the São Paulo Public Prosecutor's Office, serving twice as Attorney General of Justice (2012-2016) and as São Paulo State Secretary of Justice. He joined MDIC as Executive Secretary in January 2023, and was sworn in as Minister on 6 April 2026, succeeding Vice President Geraldo Alckmin, who left the post to run for re-election as Lula's running mate. His agenda centers on the Nova Indústria Brasil program, expanding investment and foreign trade.</a:t>
             </a:r>
           </a:p>
         </p:txBody>
       </p:sp>
       <p:cxnSp>
         <p:nvCxnSpPr>
-          <p:cNvPr id="30" name="Connector 29"/>
+          <p:cNvPr id="28" name="Connector 27"/>
           <p:cNvCxnSpPr/>
           <p:nvPr/>
         </p:nvCxnSpPr>
@@ -34593,7 +34025,7 @@
       </p:cxnSp>
       <p:sp>
         <p:nvSpPr>
-          <p:cNvPr id="31" name="TextBox 30"/>
+          <p:cNvPr id="29" name="TextBox 28"/>
           <p:cNvSpPr txBox="1"/>
           <p:nvPr/>
         </p:nvSpPr>
@@ -34627,7 +34059,7 @@
       </p:sp>
       <p:sp>
         <p:nvSpPr>
-          <p:cNvPr id="32" name="TextBox 31"/>
+          <p:cNvPr id="30" name="TextBox 29"/>
           <p:cNvSpPr txBox="1"/>
           <p:nvPr/>
         </p:nvSpPr>
@@ -34661,7 +34093,7 @@
       </p:sp>
       <p:sp>
         <p:nvSpPr>
-          <p:cNvPr id="33" name="TextBox 32"/>
+          <p:cNvPr id="31" name="TextBox 30"/>
           <p:cNvSpPr txBox="1"/>
           <p:nvPr/>
         </p:nvSpPr>
@@ -35343,8 +34775,8 @@
         </p:nvSpPr>
         <p:spPr>
           <a:xfrm>
-            <a:off x="3611880" y="1426464"/>
-            <a:ext cx="8028431" cy="274320"/>
+            <a:off x="3611880" y="1408176"/>
+            <a:ext cx="8028431" cy="256032"/>
           </a:xfrm>
           <a:prstGeom prst="rect">
             <a:avLst/>
@@ -35377,8 +34809,8 @@
         </p:nvSpPr>
         <p:spPr>
           <a:xfrm>
-            <a:off x="3611880" y="1719072"/>
-            <a:ext cx="8028431" cy="420624"/>
+            <a:off x="3611880" y="1682495"/>
+            <a:ext cx="8028431" cy="347472"/>
           </a:xfrm>
           <a:prstGeom prst="rect">
             <a:avLst/>
@@ -35416,8 +34848,8 @@
         </p:nvSpPr>
         <p:spPr>
           <a:xfrm>
-            <a:off x="3611880" y="2157984"/>
-            <a:ext cx="8028431" cy="347472"/>
+            <a:off x="3611880" y="2048256"/>
+            <a:ext cx="8028431" cy="292608"/>
           </a:xfrm>
           <a:prstGeom prst="rect">
             <a:avLst/>
@@ -35464,8 +34896,8 @@
         </p:nvSpPr>
         <p:spPr>
           <a:xfrm>
-            <a:off x="3611880" y="2578608"/>
-            <a:ext cx="8028431" cy="1152143"/>
+            <a:off x="3611880" y="2377440"/>
+            <a:ext cx="8028431" cy="1353311"/>
           </a:xfrm>
           <a:prstGeom prst="rect">
             <a:avLst/>
@@ -35573,8 +35005,8 @@
         </p:nvSpPr>
         <p:spPr>
           <a:xfrm>
-            <a:off x="3611880" y="4041648"/>
-            <a:ext cx="3849624" cy="1152144"/>
+            <a:off x="3611880" y="4023359"/>
+            <a:ext cx="3849624" cy="914400"/>
           </a:xfrm>
           <a:prstGeom prst="rect">
             <a:avLst/>
@@ -35642,8 +35074,8 @@
         </p:nvSpPr>
         <p:spPr>
           <a:xfrm>
-            <a:off x="3611880" y="5047488"/>
-            <a:ext cx="3849624" cy="310896"/>
+            <a:off x="3611880" y="4956048"/>
+            <a:ext cx="3849624" cy="292608"/>
           </a:xfrm>
           <a:prstGeom prst="rect">
             <a:avLst/>
@@ -35690,8 +35122,8 @@
         </p:nvSpPr>
         <p:spPr>
           <a:xfrm>
-            <a:off x="3611880" y="5376672"/>
-            <a:ext cx="3849624" cy="987551"/>
+            <a:off x="3611880" y="5266944"/>
+            <a:ext cx="3849624" cy="1097279"/>
           </a:xfrm>
           <a:prstGeom prst="rect">
             <a:avLst/>
@@ -35729,8 +35161,8 @@
         </p:nvSpPr>
         <p:spPr>
           <a:xfrm>
-            <a:off x="7790688" y="4041648"/>
-            <a:ext cx="3849624" cy="1152144"/>
+            <a:off x="7790688" y="4023359"/>
+            <a:ext cx="3849624" cy="914400"/>
           </a:xfrm>
           <a:prstGeom prst="rect">
             <a:avLst/>
@@ -35798,8 +35230,8 @@
         </p:nvSpPr>
         <p:spPr>
           <a:xfrm>
-            <a:off x="7790688" y="5047488"/>
-            <a:ext cx="3849624" cy="310896"/>
+            <a:off x="7790688" y="4956048"/>
+            <a:ext cx="3849624" cy="292608"/>
           </a:xfrm>
           <a:prstGeom prst="rect">
             <a:avLst/>
@@ -35846,8 +35278,8 @@
         </p:nvSpPr>
         <p:spPr>
           <a:xfrm>
-            <a:off x="7790688" y="5376672"/>
-            <a:ext cx="3849624" cy="987551"/>
+            <a:off x="7790688" y="5266944"/>
+            <a:ext cx="3849624" cy="1097279"/>
           </a:xfrm>
           <a:prstGeom prst="rect">
             <a:avLst/>
@@ -36665,8 +36097,8 @@
         </p:nvSpPr>
         <p:spPr>
           <a:xfrm>
-            <a:off x="3611880" y="1408176"/>
-            <a:ext cx="3849624" cy="1152144"/>
+            <a:off x="3611880" y="1389888"/>
+            <a:ext cx="3849624" cy="914400"/>
           </a:xfrm>
           <a:prstGeom prst="rect">
             <a:avLst/>
@@ -36734,8 +36166,8 @@
         </p:nvSpPr>
         <p:spPr>
           <a:xfrm>
-            <a:off x="3611880" y="2414015"/>
-            <a:ext cx="3849624" cy="310896"/>
+            <a:off x="3611880" y="2322576"/>
+            <a:ext cx="3849624" cy="292608"/>
           </a:xfrm>
           <a:prstGeom prst="rect">
             <a:avLst/>
@@ -36782,8 +36214,8 @@
         </p:nvSpPr>
         <p:spPr>
           <a:xfrm>
-            <a:off x="3611880" y="2743200"/>
-            <a:ext cx="3849624" cy="987551"/>
+            <a:off x="3611880" y="2633472"/>
+            <a:ext cx="3849624" cy="1097279"/>
           </a:xfrm>
           <a:prstGeom prst="rect">
             <a:avLst/>
@@ -36821,8 +36253,8 @@
         </p:nvSpPr>
         <p:spPr>
           <a:xfrm>
-            <a:off x="7790688" y="1408176"/>
-            <a:ext cx="3849624" cy="1152144"/>
+            <a:off x="7790688" y="1389888"/>
+            <a:ext cx="3849624" cy="914400"/>
           </a:xfrm>
           <a:prstGeom prst="rect">
             <a:avLst/>
@@ -36890,8 +36322,8 @@
         </p:nvSpPr>
         <p:spPr>
           <a:xfrm>
-            <a:off x="7790688" y="2414015"/>
-            <a:ext cx="3849624" cy="310896"/>
+            <a:off x="7790688" y="2322576"/>
+            <a:ext cx="3849624" cy="292608"/>
           </a:xfrm>
           <a:prstGeom prst="rect">
             <a:avLst/>
@@ -36938,8 +36370,8 @@
         </p:nvSpPr>
         <p:spPr>
           <a:xfrm>
-            <a:off x="7790688" y="2743200"/>
-            <a:ext cx="3849624" cy="987551"/>
+            <a:off x="7790688" y="2633472"/>
+            <a:ext cx="3849624" cy="1097279"/>
           </a:xfrm>
           <a:prstGeom prst="rect">
             <a:avLst/>
@@ -37047,8 +36479,8 @@
         </p:nvSpPr>
         <p:spPr>
           <a:xfrm>
-            <a:off x="3611880" y="4041648"/>
-            <a:ext cx="3849624" cy="1152144"/>
+            <a:off x="3611880" y="4023359"/>
+            <a:ext cx="3849624" cy="914400"/>
           </a:xfrm>
           <a:prstGeom prst="rect">
             <a:avLst/>
@@ -37116,8 +36548,8 @@
         </p:nvSpPr>
         <p:spPr>
           <a:xfrm>
-            <a:off x="3611880" y="5047488"/>
-            <a:ext cx="3849624" cy="310896"/>
+            <a:off x="3611880" y="4956048"/>
+            <a:ext cx="3849624" cy="292608"/>
           </a:xfrm>
           <a:prstGeom prst="rect">
             <a:avLst/>
@@ -37164,8 +36596,8 @@
         </p:nvSpPr>
         <p:spPr>
           <a:xfrm>
-            <a:off x="3611880" y="5376672"/>
-            <a:ext cx="3849624" cy="987551"/>
+            <a:off x="3611880" y="5266944"/>
+            <a:ext cx="3849624" cy="1097279"/>
           </a:xfrm>
           <a:prstGeom prst="rect">
             <a:avLst/>
@@ -37203,8 +36635,8 @@
         </p:nvSpPr>
         <p:spPr>
           <a:xfrm>
-            <a:off x="7790688" y="4041648"/>
-            <a:ext cx="3849624" cy="1152144"/>
+            <a:off x="7790688" y="4023359"/>
+            <a:ext cx="3849624" cy="914400"/>
           </a:xfrm>
           <a:prstGeom prst="rect">
             <a:avLst/>
@@ -37272,8 +36704,8 @@
         </p:nvSpPr>
         <p:spPr>
           <a:xfrm>
-            <a:off x="7790688" y="5047488"/>
-            <a:ext cx="3849624" cy="310896"/>
+            <a:off x="7790688" y="4956048"/>
+            <a:ext cx="3849624" cy="292608"/>
           </a:xfrm>
           <a:prstGeom prst="rect">
             <a:avLst/>
@@ -37320,8 +36752,8 @@
         </p:nvSpPr>
         <p:spPr>
           <a:xfrm>
-            <a:off x="7790688" y="5376672"/>
-            <a:ext cx="3849624" cy="987551"/>
+            <a:off x="7790688" y="5266944"/>
+            <a:ext cx="3849624" cy="1097279"/>
           </a:xfrm>
           <a:prstGeom prst="rect">
             <a:avLst/>

</xml_diff>

<commit_message>
Apply first batch of 21 official portraits to deck and list
Extracted portraits + name captions from the supplied G20_Portraits
sheet; image-caption pairing cross-checked two independent ways
(document order + spatial nearest-caption) with 21/21 agreement, then
verified visually. Applied to assets/portraits/<slug>.png for: US (4),
UK (3), Turkiye (2), South Korea (3), Saudi Arabia (2 of 3), Russia
(3), Poland (3), Mexico (1 of 3). "Michael Baranowski" caption mapped
to Michal Baranowski. 38 slots remain placeholders (list in GAPS.md).

Normalizer no longer upscales small sources (most supplied images are
72-104px thumbnails; upscaling would only blur them). All deliverables
rebuilt; 684 QA checks pass.

Co-Authored-By: Claude Fable 5 <noreply@anthropic.com>
Claude-Session: https://claude.ai/code/session_01D7VNHN8h6qLVjZi6Tzyhub
</commit_message>
<xml_diff>
--- a/output/g20-ministers-trade-deck.pptx
+++ b/output/g20-ministers-trade-deck.pptx
@@ -12782,7 +12782,7 @@
       </p:sp>
       <p:pic>
         <p:nvPicPr>
-          <p:cNvPr id="16" name="Picture 15" descr="_ph-mexico-pena.png"/>
+          <p:cNvPr id="16" name="Picture 15" descr="mexico-pena.png"/>
           <p:cNvPicPr>
             <a:picLocks noChangeAspect="1"/>
           </p:cNvPicPr>
@@ -12797,7 +12797,7 @@
         <p:spPr>
           <a:xfrm>
             <a:off x="3611880" y="1408176"/>
-            <a:ext cx="731520" cy="914400"/>
+            <a:ext cx="730601" cy="914400"/>
           </a:xfrm>
           <a:prstGeom prst="rect">
             <a:avLst/>
@@ -12813,7 +12813,7 @@
         <p:spPr>
           <a:xfrm>
             <a:off x="3611880" y="1408176"/>
-            <a:ext cx="731520" cy="914400"/>
+            <a:ext cx="730601" cy="914400"/>
           </a:xfrm>
           <a:prstGeom prst="rect">
             <a:avLst/>
@@ -12856,8 +12856,8 @@
         </p:nvSpPr>
         <p:spPr>
           <a:xfrm>
-            <a:off x="4507992" y="1408176"/>
-            <a:ext cx="7132320" cy="256032"/>
+            <a:off x="4507073" y="1408176"/>
+            <a:ext cx="7133238" cy="256032"/>
           </a:xfrm>
           <a:prstGeom prst="rect">
             <a:avLst/>
@@ -12890,8 +12890,8 @@
         </p:nvSpPr>
         <p:spPr>
           <a:xfrm>
-            <a:off x="4507992" y="1682495"/>
-            <a:ext cx="7132320" cy="347472"/>
+            <a:off x="4507073" y="1682495"/>
+            <a:ext cx="7133238" cy="347472"/>
           </a:xfrm>
           <a:prstGeom prst="rect">
             <a:avLst/>
@@ -12929,8 +12929,8 @@
         </p:nvSpPr>
         <p:spPr>
           <a:xfrm>
-            <a:off x="4507992" y="2048256"/>
-            <a:ext cx="7132320" cy="292608"/>
+            <a:off x="4507073" y="2048256"/>
+            <a:ext cx="7133238" cy="292608"/>
           </a:xfrm>
           <a:prstGeom prst="rect">
             <a:avLst/>
@@ -14308,7 +14308,7 @@
       </p:sp>
       <p:pic>
         <p:nvPicPr>
-          <p:cNvPr id="16" name="Picture 15" descr="_ph-poland-gawkowski.png"/>
+          <p:cNvPr id="16" name="Picture 15" descr="poland-gawkowski.png"/>
           <p:cNvPicPr>
             <a:picLocks noChangeAspect="1"/>
           </p:cNvPicPr>
@@ -14323,7 +14323,7 @@
         <p:spPr>
           <a:xfrm>
             <a:off x="3611880" y="1408176"/>
-            <a:ext cx="731520" cy="914400"/>
+            <a:ext cx="730601" cy="914400"/>
           </a:xfrm>
           <a:prstGeom prst="rect">
             <a:avLst/>
@@ -14339,7 +14339,7 @@
         <p:spPr>
           <a:xfrm>
             <a:off x="3611880" y="1408176"/>
-            <a:ext cx="731520" cy="914400"/>
+            <a:ext cx="730601" cy="914400"/>
           </a:xfrm>
           <a:prstGeom prst="rect">
             <a:avLst/>
@@ -14382,8 +14382,8 @@
         </p:nvSpPr>
         <p:spPr>
           <a:xfrm>
-            <a:off x="4507992" y="1408176"/>
-            <a:ext cx="7132320" cy="256032"/>
+            <a:off x="4507073" y="1408176"/>
+            <a:ext cx="7133238" cy="256032"/>
           </a:xfrm>
           <a:prstGeom prst="rect">
             <a:avLst/>
@@ -14416,8 +14416,8 @@
         </p:nvSpPr>
         <p:spPr>
           <a:xfrm>
-            <a:off x="4507992" y="1682495"/>
-            <a:ext cx="7132320" cy="347472"/>
+            <a:off x="4507073" y="1682495"/>
+            <a:ext cx="7133238" cy="347472"/>
           </a:xfrm>
           <a:prstGeom prst="rect">
             <a:avLst/>
@@ -14455,8 +14455,8 @@
         </p:nvSpPr>
         <p:spPr>
           <a:xfrm>
-            <a:off x="4507992" y="2048256"/>
-            <a:ext cx="7132320" cy="292608"/>
+            <a:off x="4507073" y="2048256"/>
+            <a:ext cx="7133238" cy="292608"/>
           </a:xfrm>
           <a:prstGeom prst="rect">
             <a:avLst/>
@@ -14622,7 +14622,7 @@
       </p:sp>
       <p:pic>
         <p:nvPicPr>
-          <p:cNvPr id="24" name="Picture 23" descr="_ph-poland-domanski.png"/>
+          <p:cNvPr id="24" name="Picture 23" descr="poland-domanski.png"/>
           <p:cNvPicPr>
             <a:picLocks noChangeAspect="1"/>
           </p:cNvPicPr>
@@ -14846,7 +14846,7 @@
       </p:sp>
       <p:pic>
         <p:nvPicPr>
-          <p:cNvPr id="29" name="Picture 28" descr="_ph-poland-baranowski.png"/>
+          <p:cNvPr id="29" name="Picture 28" descr="poland-baranowski.png"/>
           <p:cNvPicPr>
             <a:picLocks noChangeAspect="1"/>
           </p:cNvPicPr>
@@ -14861,7 +14861,7 @@
         <p:spPr>
           <a:xfrm>
             <a:off x="7790688" y="4023359"/>
-            <a:ext cx="585216" cy="731520"/>
+            <a:ext cx="584481" cy="731520"/>
           </a:xfrm>
           <a:prstGeom prst="rect">
             <a:avLst/>
@@ -14877,7 +14877,7 @@
         <p:spPr>
           <a:xfrm>
             <a:off x="7790688" y="4023359"/>
-            <a:ext cx="585216" cy="731520"/>
+            <a:ext cx="584480" cy="731520"/>
           </a:xfrm>
           <a:prstGeom prst="rect">
             <a:avLst/>
@@ -14920,8 +14920,8 @@
         </p:nvSpPr>
         <p:spPr>
           <a:xfrm>
-            <a:off x="8503920" y="4023359"/>
-            <a:ext cx="3136391" cy="914400"/>
+            <a:off x="8503184" y="4023359"/>
+            <a:ext cx="3137127" cy="914400"/>
           </a:xfrm>
           <a:prstGeom prst="rect">
             <a:avLst/>
@@ -15850,7 +15850,7 @@
       </p:sp>
       <p:pic>
         <p:nvPicPr>
-          <p:cNvPr id="16" name="Picture 15" descr="_ph-canada-sidhu.png"/>
+          <p:cNvPr id="16" name="Picture 15" descr="russia-shadayev.png"/>
           <p:cNvPicPr>
             <a:picLocks noChangeAspect="1"/>
           </p:cNvPicPr>
@@ -15865,7 +15865,7 @@
         <p:spPr>
           <a:xfrm>
             <a:off x="3611880" y="1408176"/>
-            <a:ext cx="731520" cy="914400"/>
+            <a:ext cx="723900" cy="914400"/>
           </a:xfrm>
           <a:prstGeom prst="rect">
             <a:avLst/>
@@ -15881,7 +15881,7 @@
         <p:spPr>
           <a:xfrm>
             <a:off x="3611880" y="1408176"/>
-            <a:ext cx="731520" cy="914400"/>
+            <a:ext cx="723900" cy="914400"/>
           </a:xfrm>
           <a:prstGeom prst="rect">
             <a:avLst/>
@@ -15924,8 +15924,8 @@
         </p:nvSpPr>
         <p:spPr>
           <a:xfrm>
-            <a:off x="4507992" y="1408176"/>
-            <a:ext cx="7132320" cy="256032"/>
+            <a:off x="4500372" y="1408176"/>
+            <a:ext cx="7139939" cy="256032"/>
           </a:xfrm>
           <a:prstGeom prst="rect">
             <a:avLst/>
@@ -15958,8 +15958,8 @@
         </p:nvSpPr>
         <p:spPr>
           <a:xfrm>
-            <a:off x="4507992" y="1682495"/>
-            <a:ext cx="7132320" cy="347472"/>
+            <a:off x="4500372" y="1682495"/>
+            <a:ext cx="7139939" cy="347472"/>
           </a:xfrm>
           <a:prstGeom prst="rect">
             <a:avLst/>
@@ -15997,8 +15997,8 @@
         </p:nvSpPr>
         <p:spPr>
           <a:xfrm>
-            <a:off x="4507992" y="2048256"/>
-            <a:ext cx="7132320" cy="292608"/>
+            <a:off x="4500372" y="2048256"/>
+            <a:ext cx="7139939" cy="292608"/>
           </a:xfrm>
           <a:prstGeom prst="rect">
             <a:avLst/>
@@ -16164,7 +16164,7 @@
       </p:sp>
       <p:pic>
         <p:nvPicPr>
-          <p:cNvPr id="24" name="Picture 23" descr="_ph-russia-alikhanov.png"/>
+          <p:cNvPr id="24" name="Picture 23" descr="russia-alikhanov.png"/>
           <p:cNvPicPr>
             <a:picLocks noChangeAspect="1"/>
           </p:cNvPicPr>
@@ -16388,7 +16388,7 @@
       </p:sp>
       <p:pic>
         <p:nvPicPr>
-          <p:cNvPr id="29" name="Picture 28" descr="_ph-russia-reshetnikov.png"/>
+          <p:cNvPr id="29" name="Picture 28" descr="russia-reshetnikov.png"/>
           <p:cNvPicPr>
             <a:picLocks noChangeAspect="1"/>
           </p:cNvPicPr>
@@ -16403,7 +16403,7 @@
         <p:spPr>
           <a:xfrm>
             <a:off x="7790688" y="4023359"/>
-            <a:ext cx="585216" cy="731520"/>
+            <a:ext cx="579120" cy="731520"/>
           </a:xfrm>
           <a:prstGeom prst="rect">
             <a:avLst/>
@@ -16419,7 +16419,7 @@
         <p:spPr>
           <a:xfrm>
             <a:off x="7790688" y="4023359"/>
-            <a:ext cx="585216" cy="731520"/>
+            <a:ext cx="579120" cy="731520"/>
           </a:xfrm>
           <a:prstGeom prst="rect">
             <a:avLst/>
@@ -16462,8 +16462,8 @@
         </p:nvSpPr>
         <p:spPr>
           <a:xfrm>
-            <a:off x="8503920" y="4023359"/>
-            <a:ext cx="3136391" cy="914400"/>
+            <a:off x="8497824" y="4023359"/>
+            <a:ext cx="3142488" cy="914400"/>
           </a:xfrm>
           <a:prstGeom prst="rect">
             <a:avLst/>
@@ -17392,7 +17392,7 @@
       </p:sp>
       <p:pic>
         <p:nvPicPr>
-          <p:cNvPr id="16" name="Picture 15" descr="_ph-russia-alikhanov.png"/>
+          <p:cNvPr id="16" name="Picture 15" descr="saudi-alswaha.png"/>
           <p:cNvPicPr>
             <a:picLocks noChangeAspect="1"/>
           </p:cNvPicPr>
@@ -17407,7 +17407,7 @@
         <p:spPr>
           <a:xfrm>
             <a:off x="3611880" y="1408176"/>
-            <a:ext cx="731520" cy="914400"/>
+            <a:ext cx="723900" cy="914400"/>
           </a:xfrm>
           <a:prstGeom prst="rect">
             <a:avLst/>
@@ -17423,7 +17423,7 @@
         <p:spPr>
           <a:xfrm>
             <a:off x="3611880" y="1408176"/>
-            <a:ext cx="731520" cy="914400"/>
+            <a:ext cx="723900" cy="914400"/>
           </a:xfrm>
           <a:prstGeom prst="rect">
             <a:avLst/>
@@ -17466,8 +17466,8 @@
         </p:nvSpPr>
         <p:spPr>
           <a:xfrm>
-            <a:off x="4507992" y="1408176"/>
-            <a:ext cx="7132320" cy="256032"/>
+            <a:off x="4500372" y="1408176"/>
+            <a:ext cx="7139939" cy="256032"/>
           </a:xfrm>
           <a:prstGeom prst="rect">
             <a:avLst/>
@@ -17500,8 +17500,8 @@
         </p:nvSpPr>
         <p:spPr>
           <a:xfrm>
-            <a:off x="4507992" y="1682495"/>
-            <a:ext cx="7132320" cy="347472"/>
+            <a:off x="4500372" y="1682495"/>
+            <a:ext cx="7139939" cy="347472"/>
           </a:xfrm>
           <a:prstGeom prst="rect">
             <a:avLst/>
@@ -17539,8 +17539,8 @@
         </p:nvSpPr>
         <p:spPr>
           <a:xfrm>
-            <a:off x="4507992" y="2048256"/>
-            <a:ext cx="7132320" cy="292608"/>
+            <a:off x="4500372" y="2048256"/>
+            <a:ext cx="7139939" cy="292608"/>
           </a:xfrm>
           <a:prstGeom prst="rect">
             <a:avLst/>
@@ -17914,14 +17914,14 @@
       </p:sp>
       <p:pic>
         <p:nvPicPr>
-          <p:cNvPr id="29" name="Picture 28" descr="_ph-saudi-alqasabi.png"/>
+          <p:cNvPr id="29" name="Picture 28" descr="saudi-abduljabbar.png"/>
           <p:cNvPicPr>
             <a:picLocks noChangeAspect="1"/>
           </p:cNvPicPr>
           <p:nvPr/>
         </p:nvPicPr>
         <p:blipFill>
-          <a:blip r:embed="rId4"/>
+          <a:blip r:embed="rId5"/>
           <a:stretch>
             <a:fillRect/>
           </a:stretch>
@@ -17929,7 +17929,7 @@
         <p:spPr>
           <a:xfrm>
             <a:off x="7790688" y="4023359"/>
-            <a:ext cx="585216" cy="731520"/>
+            <a:ext cx="584481" cy="731520"/>
           </a:xfrm>
           <a:prstGeom prst="rect">
             <a:avLst/>
@@ -17945,7 +17945,7 @@
         <p:spPr>
           <a:xfrm>
             <a:off x="7790688" y="4023359"/>
-            <a:ext cx="585216" cy="731520"/>
+            <a:ext cx="584480" cy="731520"/>
           </a:xfrm>
           <a:prstGeom prst="rect">
             <a:avLst/>
@@ -17988,8 +17988,8 @@
         </p:nvSpPr>
         <p:spPr>
           <a:xfrm>
-            <a:off x="8503920" y="4023359"/>
-            <a:ext cx="3136391" cy="914400"/>
+            <a:off x="8503184" y="4023359"/>
+            <a:ext cx="3137127" cy="914400"/>
           </a:xfrm>
           <a:prstGeom prst="rect">
             <a:avLst/>
@@ -19404,7 +19404,7 @@
       </p:sp>
       <p:pic>
         <p:nvPicPr>
-          <p:cNvPr id="16" name="Picture 15" descr="_ph-korea-bae.png"/>
+          <p:cNvPr id="16" name="Picture 15" descr="korea-bae.png"/>
           <p:cNvPicPr>
             <a:picLocks noChangeAspect="1"/>
           </p:cNvPicPr>
@@ -19419,7 +19419,7 @@
         <p:spPr>
           <a:xfrm>
             <a:off x="3611880" y="1408176"/>
-            <a:ext cx="731520" cy="914400"/>
+            <a:ext cx="735496" cy="914400"/>
           </a:xfrm>
           <a:prstGeom prst="rect">
             <a:avLst/>
@@ -19435,7 +19435,7 @@
         <p:spPr>
           <a:xfrm>
             <a:off x="3611880" y="1408176"/>
-            <a:ext cx="731520" cy="914400"/>
+            <a:ext cx="735495" cy="914400"/>
           </a:xfrm>
           <a:prstGeom prst="rect">
             <a:avLst/>
@@ -19478,8 +19478,8 @@
         </p:nvSpPr>
         <p:spPr>
           <a:xfrm>
-            <a:off x="4507992" y="1408176"/>
-            <a:ext cx="7132320" cy="256032"/>
+            <a:off x="4511967" y="1408176"/>
+            <a:ext cx="7128344" cy="256032"/>
           </a:xfrm>
           <a:prstGeom prst="rect">
             <a:avLst/>
@@ -19512,8 +19512,8 @@
         </p:nvSpPr>
         <p:spPr>
           <a:xfrm>
-            <a:off x="4507992" y="1682495"/>
-            <a:ext cx="7132320" cy="347472"/>
+            <a:off x="4511967" y="1682495"/>
+            <a:ext cx="7128344" cy="347472"/>
           </a:xfrm>
           <a:prstGeom prst="rect">
             <a:avLst/>
@@ -19551,8 +19551,8 @@
         </p:nvSpPr>
         <p:spPr>
           <a:xfrm>
-            <a:off x="4507992" y="2048256"/>
-            <a:ext cx="7132320" cy="292608"/>
+            <a:off x="4511967" y="2048256"/>
+            <a:ext cx="7128344" cy="292608"/>
           </a:xfrm>
           <a:prstGeom prst="rect">
             <a:avLst/>
@@ -19702,7 +19702,7 @@
       </p:sp>
       <p:pic>
         <p:nvPicPr>
-          <p:cNvPr id="24" name="Picture 23" descr="_ph-korea-kim.png"/>
+          <p:cNvPr id="24" name="Picture 23" descr="korea-kim.png"/>
           <p:cNvPicPr>
             <a:picLocks noChangeAspect="1"/>
           </p:cNvPicPr>
@@ -19717,7 +19717,7 @@
         <p:spPr>
           <a:xfrm>
             <a:off x="3611880" y="4023359"/>
-            <a:ext cx="585216" cy="731520"/>
+            <a:ext cx="579120" cy="731520"/>
           </a:xfrm>
           <a:prstGeom prst="rect">
             <a:avLst/>
@@ -19733,7 +19733,7 @@
         <p:spPr>
           <a:xfrm>
             <a:off x="3611880" y="4023359"/>
-            <a:ext cx="585216" cy="731520"/>
+            <a:ext cx="579120" cy="731520"/>
           </a:xfrm>
           <a:prstGeom prst="rect">
             <a:avLst/>
@@ -19776,8 +19776,8 @@
         </p:nvSpPr>
         <p:spPr>
           <a:xfrm>
-            <a:off x="4325112" y="4023359"/>
-            <a:ext cx="3136391" cy="914400"/>
+            <a:off x="4319016" y="4023359"/>
+            <a:ext cx="3142488" cy="914400"/>
           </a:xfrm>
           <a:prstGeom prst="rect">
             <a:avLst/>
@@ -19926,7 +19926,7 @@
       </p:sp>
       <p:pic>
         <p:nvPicPr>
-          <p:cNvPr id="29" name="Picture 28" descr="_ph-china-hejun.png"/>
+          <p:cNvPr id="29" name="Picture 28" descr="korea-yeo.png"/>
           <p:cNvPicPr>
             <a:picLocks noChangeAspect="1"/>
           </p:cNvPicPr>
@@ -19941,7 +19941,7 @@
         <p:spPr>
           <a:xfrm>
             <a:off x="7790688" y="4023359"/>
-            <a:ext cx="585216" cy="731520"/>
+            <a:ext cx="579120" cy="731520"/>
           </a:xfrm>
           <a:prstGeom prst="rect">
             <a:avLst/>
@@ -19957,7 +19957,7 @@
         <p:spPr>
           <a:xfrm>
             <a:off x="7790688" y="4023359"/>
-            <a:ext cx="585216" cy="731520"/>
+            <a:ext cx="579120" cy="731520"/>
           </a:xfrm>
           <a:prstGeom prst="rect">
             <a:avLst/>
@@ -20000,8 +20000,8 @@
         </p:nvSpPr>
         <p:spPr>
           <a:xfrm>
-            <a:off x="8503920" y="4023359"/>
-            <a:ext cx="3136391" cy="914400"/>
+            <a:off x="8497824" y="4023359"/>
+            <a:ext cx="3142488" cy="914400"/>
           </a:xfrm>
           <a:prstGeom prst="rect">
             <a:avLst/>
@@ -20930,7 +20930,7 @@
       </p:sp>
       <p:pic>
         <p:nvPicPr>
-          <p:cNvPr id="16" name="Picture 15" descr="_ph-brazil-rosa.png"/>
+          <p:cNvPr id="16" name="Picture 15" descr="turkiye-kacir.png"/>
           <p:cNvPicPr>
             <a:picLocks noChangeAspect="1"/>
           </p:cNvPicPr>
@@ -20945,7 +20945,7 @@
         <p:spPr>
           <a:xfrm>
             <a:off x="3611880" y="1408176"/>
-            <a:ext cx="731520" cy="914400"/>
+            <a:ext cx="723900" cy="914400"/>
           </a:xfrm>
           <a:prstGeom prst="rect">
             <a:avLst/>
@@ -20961,7 +20961,7 @@
         <p:spPr>
           <a:xfrm>
             <a:off x="3611880" y="1408176"/>
-            <a:ext cx="731520" cy="914400"/>
+            <a:ext cx="723900" cy="914400"/>
           </a:xfrm>
           <a:prstGeom prst="rect">
             <a:avLst/>
@@ -21004,8 +21004,8 @@
         </p:nvSpPr>
         <p:spPr>
           <a:xfrm>
-            <a:off x="4507992" y="1408176"/>
-            <a:ext cx="7132320" cy="256032"/>
+            <a:off x="4500372" y="1408176"/>
+            <a:ext cx="7139939" cy="256032"/>
           </a:xfrm>
           <a:prstGeom prst="rect">
             <a:avLst/>
@@ -21038,8 +21038,8 @@
         </p:nvSpPr>
         <p:spPr>
           <a:xfrm>
-            <a:off x="4507992" y="1682495"/>
-            <a:ext cx="7132320" cy="347472"/>
+            <a:off x="4500372" y="1682495"/>
+            <a:ext cx="7139939" cy="347472"/>
           </a:xfrm>
           <a:prstGeom prst="rect">
             <a:avLst/>
@@ -21077,8 +21077,8 @@
         </p:nvSpPr>
         <p:spPr>
           <a:xfrm>
-            <a:off x="4507992" y="2048256"/>
-            <a:ext cx="7132320" cy="292608"/>
+            <a:off x="4500372" y="2048256"/>
+            <a:ext cx="7139939" cy="292608"/>
           </a:xfrm>
           <a:prstGeom prst="rect">
             <a:avLst/>
@@ -21244,7 +21244,7 @@
       </p:sp>
       <p:pic>
         <p:nvPicPr>
-          <p:cNvPr id="24" name="Picture 23" descr="_ph-turkiye-bolat.png"/>
+          <p:cNvPr id="24" name="Picture 23" descr="turkiye-bolat.png"/>
           <p:cNvPicPr>
             <a:picLocks noChangeAspect="1"/>
           </p:cNvPicPr>
@@ -22252,7 +22252,7 @@
       </p:sp>
       <p:pic>
         <p:nvPicPr>
-          <p:cNvPr id="16" name="Picture 15" descr="_ph-uk-kendall.png"/>
+          <p:cNvPr id="16" name="Picture 15" descr="uk-kendall.png"/>
           <p:cNvPicPr>
             <a:picLocks noChangeAspect="1"/>
           </p:cNvPicPr>
@@ -22566,7 +22566,7 @@
       </p:sp>
       <p:pic>
         <p:nvPicPr>
-          <p:cNvPr id="24" name="Picture 23" descr="_ph-uk-kyle.png"/>
+          <p:cNvPr id="24" name="Picture 23" descr="uk-kyle.png"/>
           <p:cNvPicPr>
             <a:picLocks noChangeAspect="1"/>
           </p:cNvPicPr>
@@ -22790,7 +22790,7 @@
       </p:sp>
       <p:pic>
         <p:nvPicPr>
-          <p:cNvPr id="29" name="Picture 28" descr="_ph-uk-bryant.png"/>
+          <p:cNvPr id="29" name="Picture 28" descr="uk-bryant.png"/>
           <p:cNvPicPr>
             <a:picLocks noChangeAspect="1"/>
           </p:cNvPicPr>
@@ -23794,7 +23794,7 @@
       </p:sp>
       <p:pic>
         <p:nvPicPr>
-          <p:cNvPr id="16" name="Picture 15" descr="_ph-us-kratsios.png"/>
+          <p:cNvPr id="16" name="Picture 15" descr="us-kratsios.png"/>
           <p:cNvPicPr>
             <a:picLocks noChangeAspect="1"/>
           </p:cNvPicPr>
@@ -23809,7 +23809,7 @@
         <p:spPr>
           <a:xfrm>
             <a:off x="3611880" y="1389888"/>
-            <a:ext cx="585216" cy="731520"/>
+            <a:ext cx="588397" cy="731520"/>
           </a:xfrm>
           <a:prstGeom prst="rect">
             <a:avLst/>
@@ -23825,7 +23825,7 @@
         <p:spPr>
           <a:xfrm>
             <a:off x="3611880" y="1389888"/>
-            <a:ext cx="585216" cy="731520"/>
+            <a:ext cx="588396" cy="731520"/>
           </a:xfrm>
           <a:prstGeom prst="rect">
             <a:avLst/>
@@ -23868,8 +23868,8 @@
         </p:nvSpPr>
         <p:spPr>
           <a:xfrm>
-            <a:off x="4325112" y="1389888"/>
-            <a:ext cx="3136391" cy="914400"/>
+            <a:off x="4328292" y="1389888"/>
+            <a:ext cx="3133211" cy="914400"/>
           </a:xfrm>
           <a:prstGeom prst="rect">
             <a:avLst/>
@@ -24018,7 +24018,7 @@
       </p:sp>
       <p:pic>
         <p:nvPicPr>
-          <p:cNvPr id="21" name="Picture 20" descr="_ph-japan-akazawa.png"/>
+          <p:cNvPr id="21" name="Picture 20" descr="us-roth.png"/>
           <p:cNvPicPr>
             <a:picLocks noChangeAspect="1"/>
           </p:cNvPicPr>
@@ -24033,7 +24033,7 @@
         <p:spPr>
           <a:xfrm>
             <a:off x="7790688" y="1389888"/>
-            <a:ext cx="585216" cy="731520"/>
+            <a:ext cx="579120" cy="731520"/>
           </a:xfrm>
           <a:prstGeom prst="rect">
             <a:avLst/>
@@ -24049,7 +24049,7 @@
         <p:spPr>
           <a:xfrm>
             <a:off x="7790688" y="1389888"/>
-            <a:ext cx="585216" cy="731520"/>
+            <a:ext cx="579120" cy="731520"/>
           </a:xfrm>
           <a:prstGeom prst="rect">
             <a:avLst/>
@@ -24092,8 +24092,8 @@
         </p:nvSpPr>
         <p:spPr>
           <a:xfrm>
-            <a:off x="8503920" y="1389888"/>
-            <a:ext cx="3136391" cy="914400"/>
+            <a:off x="8497824" y="1389888"/>
+            <a:ext cx="3142488" cy="914400"/>
           </a:xfrm>
           <a:prstGeom prst="rect">
             <a:avLst/>
@@ -24312,7 +24312,7 @@
       </p:sp>
       <p:pic>
         <p:nvPicPr>
-          <p:cNvPr id="28" name="Picture 27" descr="_ph-us-lutnick.png"/>
+          <p:cNvPr id="28" name="Picture 27" descr="us-lutnick.png"/>
           <p:cNvPicPr>
             <a:picLocks noChangeAspect="1"/>
           </p:cNvPicPr>
@@ -24327,7 +24327,7 @@
         <p:spPr>
           <a:xfrm>
             <a:off x="3611880" y="4023359"/>
-            <a:ext cx="585216" cy="731520"/>
+            <a:ext cx="579120" cy="731520"/>
           </a:xfrm>
           <a:prstGeom prst="rect">
             <a:avLst/>
@@ -24343,7 +24343,7 @@
         <p:spPr>
           <a:xfrm>
             <a:off x="3611880" y="4023359"/>
-            <a:ext cx="585216" cy="731520"/>
+            <a:ext cx="579120" cy="731520"/>
           </a:xfrm>
           <a:prstGeom prst="rect">
             <a:avLst/>
@@ -24386,8 +24386,8 @@
         </p:nvSpPr>
         <p:spPr>
           <a:xfrm>
-            <a:off x="4325112" y="4023359"/>
-            <a:ext cx="3136391" cy="914400"/>
+            <a:off x="4319016" y="4023359"/>
+            <a:ext cx="3142488" cy="914400"/>
           </a:xfrm>
           <a:prstGeom prst="rect">
             <a:avLst/>
@@ -24536,7 +24536,7 @@
       </p:sp>
       <p:pic>
         <p:nvPicPr>
-          <p:cNvPr id="33" name="Picture 32" descr="_ph-us-greer.png"/>
+          <p:cNvPr id="33" name="Picture 32" descr="us-greer.png"/>
           <p:cNvPicPr>
             <a:picLocks noChangeAspect="1"/>
           </p:cNvPicPr>
@@ -24551,7 +24551,7 @@
         <p:spPr>
           <a:xfrm>
             <a:off x="7790688" y="4023359"/>
-            <a:ext cx="585216" cy="731520"/>
+            <a:ext cx="579120" cy="731520"/>
           </a:xfrm>
           <a:prstGeom prst="rect">
             <a:avLst/>
@@ -24567,7 +24567,7 @@
         <p:spPr>
           <a:xfrm>
             <a:off x="7790688" y="4023359"/>
-            <a:ext cx="585216" cy="731520"/>
+            <a:ext cx="579120" cy="731520"/>
           </a:xfrm>
           <a:prstGeom prst="rect">
             <a:avLst/>
@@ -24610,8 +24610,8 @@
         </p:nvSpPr>
         <p:spPr>
           <a:xfrm>
-            <a:off x="8503920" y="4023359"/>
-            <a:ext cx="3136391" cy="914400"/>
+            <a:off x="8497824" y="4023359"/>
+            <a:ext cx="3142488" cy="914400"/>
           </a:xfrm>
           <a:prstGeom prst="rect">
             <a:avLst/>

</xml_diff>

<commit_message>
Apply second portrait batch: 22 new officials (43/59 total)
Extracted from the second G20_Portraits sheet (44 images; 21 were
batch-one duplicates, skipped per instruction). Pairing cross-checked
two ways with 44/44 agreement and verified visually. New portraits:
Mexico (Ebrard, Gutierrez), Japan (Matsumoto, Akazawa), Italy (Butti,
Urso, Tajani), Indonesia (Hafid, Airlangga, Santoso), India (Vaishnaw,
Agrawal, Goyal), Germany (Wildberger, Reiche), France (Le Henanff,
Forissier), China (Li Lecheng, Yin Hejun, Li Chenggang, Wang Wentao),
Canada (Solomon).

Dominic LeBlanc's image in the sheet was a 36x36 broken-image icon
(photo did not embed) - discarded; his slot stays a placeholder.

16 slots remain: Argentina (3), Australia (3), Brazil (3), Canada
(Sidhu, LeBlanc), Saudi Arabia (Al-Qasabi), EU (2), AU (2).
684 QA checks pass.

Co-Authored-By: Claude Fable 5 <noreply@anthropic.com>
Claude-Session: https://claude.ai/code/session_01D7VNHN8h6qLVjZi6Tzyhub
</commit_message>
<xml_diff>
--- a/output/g20-ministers-trade-deck.pptx
+++ b/output/g20-ministers-trade-deck.pptx
@@ -4238,7 +4238,7 @@
       </p:sp>
       <p:pic>
         <p:nvPicPr>
-          <p:cNvPr id="16" name="Picture 15" descr="_ph-france-lehenanff.png"/>
+          <p:cNvPr id="16" name="Picture 15" descr="france-lehenanff.png"/>
           <p:cNvPicPr>
             <a:picLocks noChangeAspect="1"/>
           </p:cNvPicPr>
@@ -4253,7 +4253,7 @@
         <p:spPr>
           <a:xfrm>
             <a:off x="3611880" y="1408176"/>
-            <a:ext cx="731520" cy="914400"/>
+            <a:ext cx="730601" cy="914400"/>
           </a:xfrm>
           <a:prstGeom prst="rect">
             <a:avLst/>
@@ -4269,7 +4269,7 @@
         <p:spPr>
           <a:xfrm>
             <a:off x="3611880" y="1408176"/>
-            <a:ext cx="731520" cy="914400"/>
+            <a:ext cx="730601" cy="914400"/>
           </a:xfrm>
           <a:prstGeom prst="rect">
             <a:avLst/>
@@ -4312,8 +4312,8 @@
         </p:nvSpPr>
         <p:spPr>
           <a:xfrm>
-            <a:off x="4507992" y="1408176"/>
-            <a:ext cx="7132320" cy="256032"/>
+            <a:off x="4507073" y="1408176"/>
+            <a:ext cx="7133238" cy="256032"/>
           </a:xfrm>
           <a:prstGeom prst="rect">
             <a:avLst/>
@@ -4346,8 +4346,8 @@
         </p:nvSpPr>
         <p:spPr>
           <a:xfrm>
-            <a:off x="4507992" y="1682495"/>
-            <a:ext cx="7132320" cy="347472"/>
+            <a:off x="4507073" y="1682495"/>
+            <a:ext cx="7133238" cy="347472"/>
           </a:xfrm>
           <a:prstGeom prst="rect">
             <a:avLst/>
@@ -4385,8 +4385,8 @@
         </p:nvSpPr>
         <p:spPr>
           <a:xfrm>
-            <a:off x="4507992" y="2048256"/>
-            <a:ext cx="7132320" cy="292608"/>
+            <a:off x="4507073" y="2048256"/>
+            <a:ext cx="7133238" cy="292608"/>
           </a:xfrm>
           <a:prstGeom prst="rect">
             <a:avLst/>
@@ -4536,7 +4536,7 @@
       </p:sp>
       <p:pic>
         <p:nvPicPr>
-          <p:cNvPr id="24" name="Picture 23" descr="_ph-france-forissier.png"/>
+          <p:cNvPr id="24" name="Picture 23" descr="france-forissier.png"/>
           <p:cNvPicPr>
             <a:picLocks noChangeAspect="1"/>
           </p:cNvPicPr>
@@ -4551,7 +4551,7 @@
         <p:spPr>
           <a:xfrm>
             <a:off x="3611880" y="4041648"/>
-            <a:ext cx="731520" cy="914400"/>
+            <a:ext cx="732503" cy="914400"/>
           </a:xfrm>
           <a:prstGeom prst="rect">
             <a:avLst/>
@@ -4567,7 +4567,7 @@
         <p:spPr>
           <a:xfrm>
             <a:off x="3611880" y="4041648"/>
-            <a:ext cx="731520" cy="914400"/>
+            <a:ext cx="732503" cy="914400"/>
           </a:xfrm>
           <a:prstGeom prst="rect">
             <a:avLst/>
@@ -4610,8 +4610,8 @@
         </p:nvSpPr>
         <p:spPr>
           <a:xfrm>
-            <a:off x="4507992" y="4041648"/>
-            <a:ext cx="7132320" cy="256032"/>
+            <a:off x="4508975" y="4041648"/>
+            <a:ext cx="7131336" cy="256032"/>
           </a:xfrm>
           <a:prstGeom prst="rect">
             <a:avLst/>
@@ -4644,8 +4644,8 @@
         </p:nvSpPr>
         <p:spPr>
           <a:xfrm>
-            <a:off x="4507992" y="4315968"/>
-            <a:ext cx="7132320" cy="347472"/>
+            <a:off x="4508975" y="4315968"/>
+            <a:ext cx="7131336" cy="347472"/>
           </a:xfrm>
           <a:prstGeom prst="rect">
             <a:avLst/>
@@ -4683,8 +4683,8 @@
         </p:nvSpPr>
         <p:spPr>
           <a:xfrm>
-            <a:off x="4507992" y="4681727"/>
-            <a:ext cx="7132320" cy="292608"/>
+            <a:off x="4508975" y="4681727"/>
+            <a:ext cx="7131336" cy="292608"/>
           </a:xfrm>
           <a:prstGeom prst="rect">
             <a:avLst/>
@@ -5544,7 +5544,7 @@
       </p:sp>
       <p:pic>
         <p:nvPicPr>
-          <p:cNvPr id="16" name="Picture 15" descr="_ph-germany-wildberger.png"/>
+          <p:cNvPr id="16" name="Picture 15" descr="germany-wildberger.png"/>
           <p:cNvPicPr>
             <a:picLocks noChangeAspect="1"/>
           </p:cNvPicPr>
@@ -5559,7 +5559,7 @@
         <p:spPr>
           <a:xfrm>
             <a:off x="3611880" y="1408176"/>
-            <a:ext cx="731520" cy="914400"/>
+            <a:ext cx="730601" cy="914400"/>
           </a:xfrm>
           <a:prstGeom prst="rect">
             <a:avLst/>
@@ -5575,7 +5575,7 @@
         <p:spPr>
           <a:xfrm>
             <a:off x="3611880" y="1408176"/>
-            <a:ext cx="731520" cy="914400"/>
+            <a:ext cx="730601" cy="914400"/>
           </a:xfrm>
           <a:prstGeom prst="rect">
             <a:avLst/>
@@ -5618,8 +5618,8 @@
         </p:nvSpPr>
         <p:spPr>
           <a:xfrm>
-            <a:off x="4507992" y="1408176"/>
-            <a:ext cx="7132320" cy="256032"/>
+            <a:off x="4507073" y="1408176"/>
+            <a:ext cx="7133238" cy="256032"/>
           </a:xfrm>
           <a:prstGeom prst="rect">
             <a:avLst/>
@@ -5652,8 +5652,8 @@
         </p:nvSpPr>
         <p:spPr>
           <a:xfrm>
-            <a:off x="4507992" y="1682495"/>
-            <a:ext cx="7132320" cy="347472"/>
+            <a:off x="4507073" y="1682495"/>
+            <a:ext cx="7133238" cy="347472"/>
           </a:xfrm>
           <a:prstGeom prst="rect">
             <a:avLst/>
@@ -5691,8 +5691,8 @@
         </p:nvSpPr>
         <p:spPr>
           <a:xfrm>
-            <a:off x="4507992" y="2048256"/>
-            <a:ext cx="7132320" cy="292608"/>
+            <a:off x="4507073" y="2048256"/>
+            <a:ext cx="7133238" cy="292608"/>
           </a:xfrm>
           <a:prstGeom prst="rect">
             <a:avLst/>
@@ -5842,7 +5842,7 @@
       </p:sp>
       <p:pic>
         <p:nvPicPr>
-          <p:cNvPr id="24" name="Picture 23" descr="_ph-germany-reiche.png"/>
+          <p:cNvPr id="24" name="Picture 23" descr="germany-reiche.png"/>
           <p:cNvPicPr>
             <a:picLocks noChangeAspect="1"/>
           </p:cNvPicPr>
@@ -5857,7 +5857,7 @@
         <p:spPr>
           <a:xfrm>
             <a:off x="3611880" y="4041648"/>
-            <a:ext cx="731520" cy="914400"/>
+            <a:ext cx="730601" cy="914400"/>
           </a:xfrm>
           <a:prstGeom prst="rect">
             <a:avLst/>
@@ -5873,7 +5873,7 @@
         <p:spPr>
           <a:xfrm>
             <a:off x="3611880" y="4041648"/>
-            <a:ext cx="731520" cy="914400"/>
+            <a:ext cx="730601" cy="914400"/>
           </a:xfrm>
           <a:prstGeom prst="rect">
             <a:avLst/>
@@ -5916,8 +5916,8 @@
         </p:nvSpPr>
         <p:spPr>
           <a:xfrm>
-            <a:off x="4507992" y="4041648"/>
-            <a:ext cx="7132320" cy="256032"/>
+            <a:off x="4507073" y="4041648"/>
+            <a:ext cx="7133238" cy="256032"/>
           </a:xfrm>
           <a:prstGeom prst="rect">
             <a:avLst/>
@@ -5950,8 +5950,8 @@
         </p:nvSpPr>
         <p:spPr>
           <a:xfrm>
-            <a:off x="4507992" y="4315968"/>
-            <a:ext cx="7132320" cy="347472"/>
+            <a:off x="4507073" y="4315968"/>
+            <a:ext cx="7133238" cy="347472"/>
           </a:xfrm>
           <a:prstGeom prst="rect">
             <a:avLst/>
@@ -5989,8 +5989,8 @@
         </p:nvSpPr>
         <p:spPr>
           <a:xfrm>
-            <a:off x="4507992" y="4681727"/>
-            <a:ext cx="7132320" cy="292608"/>
+            <a:off x="4507073" y="4681727"/>
+            <a:ext cx="7133238" cy="292608"/>
           </a:xfrm>
           <a:prstGeom prst="rect">
             <a:avLst/>
@@ -6866,7 +6866,7 @@
       </p:sp>
       <p:pic>
         <p:nvPicPr>
-          <p:cNvPr id="16" name="Picture 15" descr="_ph-india-vaishnaw.png"/>
+          <p:cNvPr id="16" name="Picture 15" descr="india-vaishnaw.png"/>
           <p:cNvPicPr>
             <a:picLocks noChangeAspect="1"/>
           </p:cNvPicPr>
@@ -7180,7 +7180,7 @@
       </p:sp>
       <p:pic>
         <p:nvPicPr>
-          <p:cNvPr id="24" name="Picture 23" descr="_ph-india-goyal.png"/>
+          <p:cNvPr id="24" name="Picture 23" descr="india-goyal.png"/>
           <p:cNvPicPr>
             <a:picLocks noChangeAspect="1"/>
           </p:cNvPicPr>
@@ -7195,7 +7195,7 @@
         <p:spPr>
           <a:xfrm>
             <a:off x="3611880" y="4023359"/>
-            <a:ext cx="585216" cy="731520"/>
+            <a:ext cx="582884" cy="731520"/>
           </a:xfrm>
           <a:prstGeom prst="rect">
             <a:avLst/>
@@ -7211,7 +7211,7 @@
         <p:spPr>
           <a:xfrm>
             <a:off x="3611880" y="4023359"/>
-            <a:ext cx="585216" cy="731520"/>
+            <a:ext cx="582884" cy="731520"/>
           </a:xfrm>
           <a:prstGeom prst="rect">
             <a:avLst/>
@@ -7254,8 +7254,8 @@
         </p:nvSpPr>
         <p:spPr>
           <a:xfrm>
-            <a:off x="4325112" y="4023359"/>
-            <a:ext cx="3136391" cy="914400"/>
+            <a:off x="4322780" y="4023359"/>
+            <a:ext cx="3138723" cy="914400"/>
           </a:xfrm>
           <a:prstGeom prst="rect">
             <a:avLst/>
@@ -7404,7 +7404,7 @@
       </p:sp>
       <p:pic>
         <p:nvPicPr>
-          <p:cNvPr id="29" name="Picture 28" descr="_ph-india-agrawal.png"/>
+          <p:cNvPr id="29" name="Picture 28" descr="india-agrawal.png"/>
           <p:cNvPicPr>
             <a:picLocks noChangeAspect="1"/>
           </p:cNvPicPr>
@@ -7419,7 +7419,7 @@
         <p:spPr>
           <a:xfrm>
             <a:off x="7790688" y="4023359"/>
-            <a:ext cx="585216" cy="731520"/>
+            <a:ext cx="584481" cy="731520"/>
           </a:xfrm>
           <a:prstGeom prst="rect">
             <a:avLst/>
@@ -7435,7 +7435,7 @@
         <p:spPr>
           <a:xfrm>
             <a:off x="7790688" y="4023359"/>
-            <a:ext cx="585216" cy="731520"/>
+            <a:ext cx="584480" cy="731520"/>
           </a:xfrm>
           <a:prstGeom prst="rect">
             <a:avLst/>
@@ -7478,8 +7478,8 @@
         </p:nvSpPr>
         <p:spPr>
           <a:xfrm>
-            <a:off x="8503920" y="4023359"/>
-            <a:ext cx="3136391" cy="914400"/>
+            <a:off x="8503184" y="4023359"/>
+            <a:ext cx="3137127" cy="914400"/>
           </a:xfrm>
           <a:prstGeom prst="rect">
             <a:avLst/>
@@ -8408,7 +8408,7 @@
       </p:sp>
       <p:pic>
         <p:nvPicPr>
-          <p:cNvPr id="16" name="Picture 15" descr="_ph-indonesia-hafid.png"/>
+          <p:cNvPr id="16" name="Picture 15" descr="indonesia-hafid.png"/>
           <p:cNvPicPr>
             <a:picLocks noChangeAspect="1"/>
           </p:cNvPicPr>
@@ -8423,7 +8423,7 @@
         <p:spPr>
           <a:xfrm>
             <a:off x="3611880" y="1408176"/>
-            <a:ext cx="731520" cy="914400"/>
+            <a:ext cx="730601" cy="914400"/>
           </a:xfrm>
           <a:prstGeom prst="rect">
             <a:avLst/>
@@ -8439,7 +8439,7 @@
         <p:spPr>
           <a:xfrm>
             <a:off x="3611880" y="1408176"/>
-            <a:ext cx="731520" cy="914400"/>
+            <a:ext cx="730601" cy="914400"/>
           </a:xfrm>
           <a:prstGeom prst="rect">
             <a:avLst/>
@@ -8482,8 +8482,8 @@
         </p:nvSpPr>
         <p:spPr>
           <a:xfrm>
-            <a:off x="4507992" y="1408176"/>
-            <a:ext cx="7132320" cy="256032"/>
+            <a:off x="4507073" y="1408176"/>
+            <a:ext cx="7133238" cy="256032"/>
           </a:xfrm>
           <a:prstGeom prst="rect">
             <a:avLst/>
@@ -8516,8 +8516,8 @@
         </p:nvSpPr>
         <p:spPr>
           <a:xfrm>
-            <a:off x="4507992" y="1682495"/>
-            <a:ext cx="7132320" cy="347472"/>
+            <a:off x="4507073" y="1682495"/>
+            <a:ext cx="7133238" cy="347472"/>
           </a:xfrm>
           <a:prstGeom prst="rect">
             <a:avLst/>
@@ -8555,8 +8555,8 @@
         </p:nvSpPr>
         <p:spPr>
           <a:xfrm>
-            <a:off x="4507992" y="2048256"/>
-            <a:ext cx="7132320" cy="292608"/>
+            <a:off x="4507073" y="2048256"/>
+            <a:ext cx="7133238" cy="292608"/>
           </a:xfrm>
           <a:prstGeom prst="rect">
             <a:avLst/>
@@ -8706,7 +8706,7 @@
       </p:sp>
       <p:pic>
         <p:nvPicPr>
-          <p:cNvPr id="24" name="Picture 23" descr="_ph-indonesia-santoso.png"/>
+          <p:cNvPr id="24" name="Picture 23" descr="indonesia-santoso.png"/>
           <p:cNvPicPr>
             <a:picLocks noChangeAspect="1"/>
           </p:cNvPicPr>
@@ -8721,7 +8721,7 @@
         <p:spPr>
           <a:xfrm>
             <a:off x="3611880" y="4023359"/>
-            <a:ext cx="585216" cy="731520"/>
+            <a:ext cx="587433" cy="731520"/>
           </a:xfrm>
           <a:prstGeom prst="rect">
             <a:avLst/>
@@ -8737,7 +8737,7 @@
         <p:spPr>
           <a:xfrm>
             <a:off x="3611880" y="4023359"/>
-            <a:ext cx="585216" cy="731520"/>
+            <a:ext cx="587432" cy="731520"/>
           </a:xfrm>
           <a:prstGeom prst="rect">
             <a:avLst/>
@@ -8780,8 +8780,8 @@
         </p:nvSpPr>
         <p:spPr>
           <a:xfrm>
-            <a:off x="4325112" y="4023359"/>
-            <a:ext cx="3136391" cy="914400"/>
+            <a:off x="4327328" y="4023359"/>
+            <a:ext cx="3134175" cy="914400"/>
           </a:xfrm>
           <a:prstGeom prst="rect">
             <a:avLst/>
@@ -8930,7 +8930,7 @@
       </p:sp>
       <p:pic>
         <p:nvPicPr>
-          <p:cNvPr id="29" name="Picture 28" descr="_ph-indonesia-airlangga.png"/>
+          <p:cNvPr id="29" name="Picture 28" descr="indonesia-airlangga.png"/>
           <p:cNvPicPr>
             <a:picLocks noChangeAspect="1"/>
           </p:cNvPicPr>
@@ -8945,7 +8945,7 @@
         <p:spPr>
           <a:xfrm>
             <a:off x="7790688" y="4023359"/>
-            <a:ext cx="585216" cy="731520"/>
+            <a:ext cx="584481" cy="731520"/>
           </a:xfrm>
           <a:prstGeom prst="rect">
             <a:avLst/>
@@ -8961,7 +8961,7 @@
         <p:spPr>
           <a:xfrm>
             <a:off x="7790688" y="4023359"/>
-            <a:ext cx="585216" cy="731520"/>
+            <a:ext cx="584480" cy="731520"/>
           </a:xfrm>
           <a:prstGeom prst="rect">
             <a:avLst/>
@@ -9004,8 +9004,8 @@
         </p:nvSpPr>
         <p:spPr>
           <a:xfrm>
-            <a:off x="8503920" y="4023359"/>
-            <a:ext cx="3136391" cy="914400"/>
+            <a:off x="8503184" y="4023359"/>
+            <a:ext cx="3137127" cy="914400"/>
           </a:xfrm>
           <a:prstGeom prst="rect">
             <a:avLst/>
@@ -9934,7 +9934,7 @@
       </p:sp>
       <p:pic>
         <p:nvPicPr>
-          <p:cNvPr id="16" name="Picture 15" descr="_ph-italy-butti.png"/>
+          <p:cNvPr id="16" name="Picture 15" descr="italy-butti.png"/>
           <p:cNvPicPr>
             <a:picLocks noChangeAspect="1"/>
           </p:cNvPicPr>
@@ -9949,7 +9949,7 @@
         <p:spPr>
           <a:xfrm>
             <a:off x="3611880" y="1408176"/>
-            <a:ext cx="731520" cy="914400"/>
+            <a:ext cx="730601" cy="914400"/>
           </a:xfrm>
           <a:prstGeom prst="rect">
             <a:avLst/>
@@ -9965,7 +9965,7 @@
         <p:spPr>
           <a:xfrm>
             <a:off x="3611880" y="1408176"/>
-            <a:ext cx="731520" cy="914400"/>
+            <a:ext cx="730601" cy="914400"/>
           </a:xfrm>
           <a:prstGeom prst="rect">
             <a:avLst/>
@@ -10008,8 +10008,8 @@
         </p:nvSpPr>
         <p:spPr>
           <a:xfrm>
-            <a:off x="4507992" y="1408176"/>
-            <a:ext cx="7132320" cy="256032"/>
+            <a:off x="4507073" y="1408176"/>
+            <a:ext cx="7133238" cy="256032"/>
           </a:xfrm>
           <a:prstGeom prst="rect">
             <a:avLst/>
@@ -10042,8 +10042,8 @@
         </p:nvSpPr>
         <p:spPr>
           <a:xfrm>
-            <a:off x="4507992" y="1682495"/>
-            <a:ext cx="7132320" cy="347472"/>
+            <a:off x="4507073" y="1682495"/>
+            <a:ext cx="7133238" cy="347472"/>
           </a:xfrm>
           <a:prstGeom prst="rect">
             <a:avLst/>
@@ -10081,8 +10081,8 @@
         </p:nvSpPr>
         <p:spPr>
           <a:xfrm>
-            <a:off x="4507992" y="2048256"/>
-            <a:ext cx="7132320" cy="292608"/>
+            <a:off x="4507073" y="2048256"/>
+            <a:ext cx="7133238" cy="292608"/>
           </a:xfrm>
           <a:prstGeom prst="rect">
             <a:avLst/>
@@ -10232,7 +10232,7 @@
       </p:sp>
       <p:pic>
         <p:nvPicPr>
-          <p:cNvPr id="24" name="Picture 23" descr="_ph-italy-tajani.png"/>
+          <p:cNvPr id="24" name="Picture 23" descr="italy-tajani.png"/>
           <p:cNvPicPr>
             <a:picLocks noChangeAspect="1"/>
           </p:cNvPicPr>
@@ -10247,7 +10247,7 @@
         <p:spPr>
           <a:xfrm>
             <a:off x="3611880" y="4023359"/>
-            <a:ext cx="585216" cy="731520"/>
+            <a:ext cx="584481" cy="731520"/>
           </a:xfrm>
           <a:prstGeom prst="rect">
             <a:avLst/>
@@ -10263,7 +10263,7 @@
         <p:spPr>
           <a:xfrm>
             <a:off x="3611880" y="4023359"/>
-            <a:ext cx="585216" cy="731520"/>
+            <a:ext cx="584480" cy="731520"/>
           </a:xfrm>
           <a:prstGeom prst="rect">
             <a:avLst/>
@@ -10306,8 +10306,8 @@
         </p:nvSpPr>
         <p:spPr>
           <a:xfrm>
-            <a:off x="4325112" y="4023359"/>
-            <a:ext cx="3136391" cy="914400"/>
+            <a:off x="4324376" y="4023359"/>
+            <a:ext cx="3137127" cy="914400"/>
           </a:xfrm>
           <a:prstGeom prst="rect">
             <a:avLst/>
@@ -10456,7 +10456,7 @@
       </p:sp>
       <p:pic>
         <p:nvPicPr>
-          <p:cNvPr id="29" name="Picture 28" descr="_ph-italy-urso.png"/>
+          <p:cNvPr id="29" name="Picture 28" descr="italy-urso.png"/>
           <p:cNvPicPr>
             <a:picLocks noChangeAspect="1"/>
           </p:cNvPicPr>
@@ -10471,7 +10471,7 @@
         <p:spPr>
           <a:xfrm>
             <a:off x="7790688" y="4023359"/>
-            <a:ext cx="585216" cy="731520"/>
+            <a:ext cx="586740" cy="731520"/>
           </a:xfrm>
           <a:prstGeom prst="rect">
             <a:avLst/>
@@ -10487,7 +10487,7 @@
         <p:spPr>
           <a:xfrm>
             <a:off x="7790688" y="4023359"/>
-            <a:ext cx="585216" cy="731520"/>
+            <a:ext cx="586740" cy="731520"/>
           </a:xfrm>
           <a:prstGeom prst="rect">
             <a:avLst/>
@@ -10530,8 +10530,8 @@
         </p:nvSpPr>
         <p:spPr>
           <a:xfrm>
-            <a:off x="8503920" y="4023359"/>
-            <a:ext cx="3136391" cy="914400"/>
+            <a:off x="8505444" y="4023359"/>
+            <a:ext cx="3134868" cy="914400"/>
           </a:xfrm>
           <a:prstGeom prst="rect">
             <a:avLst/>
@@ -11460,7 +11460,7 @@
       </p:sp>
       <p:pic>
         <p:nvPicPr>
-          <p:cNvPr id="16" name="Picture 15" descr="_ph-japan-matsumoto.png"/>
+          <p:cNvPr id="16" name="Picture 15" descr="japan-matsumoto.png"/>
           <p:cNvPicPr>
             <a:picLocks noChangeAspect="1"/>
           </p:cNvPicPr>
@@ -11475,7 +11475,7 @@
         <p:spPr>
           <a:xfrm>
             <a:off x="3611880" y="1408176"/>
-            <a:ext cx="731520" cy="914400"/>
+            <a:ext cx="733710" cy="914400"/>
           </a:xfrm>
           <a:prstGeom prst="rect">
             <a:avLst/>
@@ -11491,7 +11491,7 @@
         <p:spPr>
           <a:xfrm>
             <a:off x="3611880" y="1408176"/>
-            <a:ext cx="731520" cy="914400"/>
+            <a:ext cx="733710" cy="914400"/>
           </a:xfrm>
           <a:prstGeom prst="rect">
             <a:avLst/>
@@ -11534,8 +11534,8 @@
         </p:nvSpPr>
         <p:spPr>
           <a:xfrm>
-            <a:off x="4507992" y="1408176"/>
-            <a:ext cx="7132320" cy="256032"/>
+            <a:off x="4510182" y="1408176"/>
+            <a:ext cx="7130129" cy="256032"/>
           </a:xfrm>
           <a:prstGeom prst="rect">
             <a:avLst/>
@@ -11568,8 +11568,8 @@
         </p:nvSpPr>
         <p:spPr>
           <a:xfrm>
-            <a:off x="4507992" y="1682495"/>
-            <a:ext cx="7132320" cy="347472"/>
+            <a:off x="4510182" y="1682495"/>
+            <a:ext cx="7130129" cy="347472"/>
           </a:xfrm>
           <a:prstGeom prst="rect">
             <a:avLst/>
@@ -11607,8 +11607,8 @@
         </p:nvSpPr>
         <p:spPr>
           <a:xfrm>
-            <a:off x="4507992" y="2048256"/>
-            <a:ext cx="7132320" cy="292608"/>
+            <a:off x="4510182" y="2048256"/>
+            <a:ext cx="7130129" cy="292608"/>
           </a:xfrm>
           <a:prstGeom prst="rect">
             <a:avLst/>
@@ -11758,7 +11758,7 @@
       </p:sp>
       <p:pic>
         <p:nvPicPr>
-          <p:cNvPr id="24" name="Picture 23" descr="_ph-japan-akazawa.png"/>
+          <p:cNvPr id="24" name="Picture 23" descr="japan-akazawa.png"/>
           <p:cNvPicPr>
             <a:picLocks noChangeAspect="1"/>
           </p:cNvPicPr>
@@ -11773,7 +11773,7 @@
         <p:spPr>
           <a:xfrm>
             <a:off x="3611880" y="4041648"/>
-            <a:ext cx="731520" cy="914400"/>
+            <a:ext cx="732503" cy="914400"/>
           </a:xfrm>
           <a:prstGeom prst="rect">
             <a:avLst/>
@@ -11789,7 +11789,7 @@
         <p:spPr>
           <a:xfrm>
             <a:off x="3611880" y="4041648"/>
-            <a:ext cx="731520" cy="914400"/>
+            <a:ext cx="732503" cy="914400"/>
           </a:xfrm>
           <a:prstGeom prst="rect">
             <a:avLst/>
@@ -11832,8 +11832,8 @@
         </p:nvSpPr>
         <p:spPr>
           <a:xfrm>
-            <a:off x="4507992" y="4041648"/>
-            <a:ext cx="7132320" cy="256032"/>
+            <a:off x="4508975" y="4041648"/>
+            <a:ext cx="7131336" cy="256032"/>
           </a:xfrm>
           <a:prstGeom prst="rect">
             <a:avLst/>
@@ -11866,8 +11866,8 @@
         </p:nvSpPr>
         <p:spPr>
           <a:xfrm>
-            <a:off x="4507992" y="4315968"/>
-            <a:ext cx="7132320" cy="347472"/>
+            <a:off x="4508975" y="4315968"/>
+            <a:ext cx="7131336" cy="347472"/>
           </a:xfrm>
           <a:prstGeom prst="rect">
             <a:avLst/>
@@ -11905,8 +11905,8 @@
         </p:nvSpPr>
         <p:spPr>
           <a:xfrm>
-            <a:off x="4507992" y="4681727"/>
-            <a:ext cx="7132320" cy="292608"/>
+            <a:off x="4508975" y="4681727"/>
+            <a:ext cx="7131336" cy="292608"/>
           </a:xfrm>
           <a:prstGeom prst="rect">
             <a:avLst/>
@@ -12797,7 +12797,7 @@
         <p:spPr>
           <a:xfrm>
             <a:off x="3611880" y="1408176"/>
-            <a:ext cx="730601" cy="914400"/>
+            <a:ext cx="734291" cy="914400"/>
           </a:xfrm>
           <a:prstGeom prst="rect">
             <a:avLst/>
@@ -12813,7 +12813,7 @@
         <p:spPr>
           <a:xfrm>
             <a:off x="3611880" y="1408176"/>
-            <a:ext cx="730601" cy="914400"/>
+            <a:ext cx="734290" cy="914400"/>
           </a:xfrm>
           <a:prstGeom prst="rect">
             <a:avLst/>
@@ -12856,8 +12856,8 @@
         </p:nvSpPr>
         <p:spPr>
           <a:xfrm>
-            <a:off x="4507073" y="1408176"/>
-            <a:ext cx="7133238" cy="256032"/>
+            <a:off x="4510762" y="1408176"/>
+            <a:ext cx="7129549" cy="256032"/>
           </a:xfrm>
           <a:prstGeom prst="rect">
             <a:avLst/>
@@ -12890,8 +12890,8 @@
         </p:nvSpPr>
         <p:spPr>
           <a:xfrm>
-            <a:off x="4507073" y="1682495"/>
-            <a:ext cx="7133238" cy="347472"/>
+            <a:off x="4510762" y="1682495"/>
+            <a:ext cx="7129549" cy="347472"/>
           </a:xfrm>
           <a:prstGeom prst="rect">
             <a:avLst/>
@@ -12929,8 +12929,8 @@
         </p:nvSpPr>
         <p:spPr>
           <a:xfrm>
-            <a:off x="4507073" y="2048256"/>
-            <a:ext cx="7133238" cy="292608"/>
+            <a:off x="4510762" y="2048256"/>
+            <a:ext cx="7129549" cy="292608"/>
           </a:xfrm>
           <a:prstGeom prst="rect">
             <a:avLst/>
@@ -13080,7 +13080,7 @@
       </p:sp>
       <p:pic>
         <p:nvPicPr>
-          <p:cNvPr id="24" name="Picture 23" descr="_ph-mexico-ebrard.png"/>
+          <p:cNvPr id="24" name="Picture 23" descr="mexico-ebrard.png"/>
           <p:cNvPicPr>
             <a:picLocks noChangeAspect="1"/>
           </p:cNvPicPr>
@@ -13095,7 +13095,7 @@
         <p:spPr>
           <a:xfrm>
             <a:off x="3611880" y="4023359"/>
-            <a:ext cx="585216" cy="731520"/>
+            <a:ext cx="587433" cy="731520"/>
           </a:xfrm>
           <a:prstGeom prst="rect">
             <a:avLst/>
@@ -13111,7 +13111,7 @@
         <p:spPr>
           <a:xfrm>
             <a:off x="3611880" y="4023359"/>
-            <a:ext cx="585216" cy="731520"/>
+            <a:ext cx="587432" cy="731520"/>
           </a:xfrm>
           <a:prstGeom prst="rect">
             <a:avLst/>
@@ -13154,8 +13154,8 @@
         </p:nvSpPr>
         <p:spPr>
           <a:xfrm>
-            <a:off x="4325112" y="4023359"/>
-            <a:ext cx="3136391" cy="914400"/>
+            <a:off x="4327328" y="4023359"/>
+            <a:ext cx="3134175" cy="914400"/>
           </a:xfrm>
           <a:prstGeom prst="rect">
             <a:avLst/>
@@ -13304,7 +13304,7 @@
       </p:sp>
       <p:pic>
         <p:nvPicPr>
-          <p:cNvPr id="29" name="Picture 28" descr="_ph-mexico-gutierrez.png"/>
+          <p:cNvPr id="29" name="Picture 28" descr="mexico-gutierrez.png"/>
           <p:cNvPicPr>
             <a:picLocks noChangeAspect="1"/>
           </p:cNvPicPr>
@@ -13319,7 +13319,7 @@
         <p:spPr>
           <a:xfrm>
             <a:off x="7790688" y="4023359"/>
-            <a:ext cx="585216" cy="731520"/>
+            <a:ext cx="584481" cy="731520"/>
           </a:xfrm>
           <a:prstGeom prst="rect">
             <a:avLst/>
@@ -13335,7 +13335,7 @@
         <p:spPr>
           <a:xfrm>
             <a:off x="7790688" y="4023359"/>
-            <a:ext cx="585216" cy="731520"/>
+            <a:ext cx="584480" cy="731520"/>
           </a:xfrm>
           <a:prstGeom prst="rect">
             <a:avLst/>
@@ -13378,8 +13378,8 @@
         </p:nvSpPr>
         <p:spPr>
           <a:xfrm>
-            <a:off x="8503920" y="4023359"/>
-            <a:ext cx="3136391" cy="914400"/>
+            <a:off x="8503184" y="4023359"/>
+            <a:ext cx="3137127" cy="914400"/>
           </a:xfrm>
           <a:prstGeom prst="rect">
             <a:avLst/>
@@ -14323,7 +14323,7 @@
         <p:spPr>
           <a:xfrm>
             <a:off x="3611880" y="1408176"/>
-            <a:ext cx="730601" cy="914400"/>
+            <a:ext cx="734291" cy="914400"/>
           </a:xfrm>
           <a:prstGeom prst="rect">
             <a:avLst/>
@@ -14339,7 +14339,7 @@
         <p:spPr>
           <a:xfrm>
             <a:off x="3611880" y="1408176"/>
-            <a:ext cx="730601" cy="914400"/>
+            <a:ext cx="734290" cy="914400"/>
           </a:xfrm>
           <a:prstGeom prst="rect">
             <a:avLst/>
@@ -14382,8 +14382,8 @@
         </p:nvSpPr>
         <p:spPr>
           <a:xfrm>
-            <a:off x="4507073" y="1408176"/>
-            <a:ext cx="7133238" cy="256032"/>
+            <a:off x="4510762" y="1408176"/>
+            <a:ext cx="7129549" cy="256032"/>
           </a:xfrm>
           <a:prstGeom prst="rect">
             <a:avLst/>
@@ -14416,8 +14416,8 @@
         </p:nvSpPr>
         <p:spPr>
           <a:xfrm>
-            <a:off x="4507073" y="1682495"/>
-            <a:ext cx="7133238" cy="347472"/>
+            <a:off x="4510762" y="1682495"/>
+            <a:ext cx="7129549" cy="347472"/>
           </a:xfrm>
           <a:prstGeom prst="rect">
             <a:avLst/>
@@ -14455,8 +14455,8 @@
         </p:nvSpPr>
         <p:spPr>
           <a:xfrm>
-            <a:off x="4507073" y="2048256"/>
-            <a:ext cx="7133238" cy="292608"/>
+            <a:off x="4510762" y="2048256"/>
+            <a:ext cx="7129549" cy="292608"/>
           </a:xfrm>
           <a:prstGeom prst="rect">
             <a:avLst/>
@@ -14861,7 +14861,7 @@
         <p:spPr>
           <a:xfrm>
             <a:off x="7790688" y="4023359"/>
-            <a:ext cx="584481" cy="731520"/>
+            <a:ext cx="587433" cy="731520"/>
           </a:xfrm>
           <a:prstGeom prst="rect">
             <a:avLst/>
@@ -14877,7 +14877,7 @@
         <p:spPr>
           <a:xfrm>
             <a:off x="7790688" y="4023359"/>
-            <a:ext cx="584480" cy="731520"/>
+            <a:ext cx="587432" cy="731520"/>
           </a:xfrm>
           <a:prstGeom prst="rect">
             <a:avLst/>
@@ -14920,8 +14920,8 @@
         </p:nvSpPr>
         <p:spPr>
           <a:xfrm>
-            <a:off x="8503184" y="4023359"/>
-            <a:ext cx="3137127" cy="914400"/>
+            <a:off x="8506136" y="4023359"/>
+            <a:ext cx="3134175" cy="914400"/>
           </a:xfrm>
           <a:prstGeom prst="rect">
             <a:avLst/>
@@ -15865,7 +15865,7 @@
         <p:spPr>
           <a:xfrm>
             <a:off x="3611880" y="1408176"/>
-            <a:ext cx="723900" cy="914400"/>
+            <a:ext cx="731520" cy="914400"/>
           </a:xfrm>
           <a:prstGeom prst="rect">
             <a:avLst/>
@@ -15881,7 +15881,7 @@
         <p:spPr>
           <a:xfrm>
             <a:off x="3611880" y="1408176"/>
-            <a:ext cx="723900" cy="914400"/>
+            <a:ext cx="731520" cy="914400"/>
           </a:xfrm>
           <a:prstGeom prst="rect">
             <a:avLst/>
@@ -15924,8 +15924,8 @@
         </p:nvSpPr>
         <p:spPr>
           <a:xfrm>
-            <a:off x="4500372" y="1408176"/>
-            <a:ext cx="7139939" cy="256032"/>
+            <a:off x="4507992" y="1408176"/>
+            <a:ext cx="7132320" cy="256032"/>
           </a:xfrm>
           <a:prstGeom prst="rect">
             <a:avLst/>
@@ -15958,8 +15958,8 @@
         </p:nvSpPr>
         <p:spPr>
           <a:xfrm>
-            <a:off x="4500372" y="1682495"/>
-            <a:ext cx="7139939" cy="347472"/>
+            <a:off x="4507992" y="1682495"/>
+            <a:ext cx="7132320" cy="347472"/>
           </a:xfrm>
           <a:prstGeom prst="rect">
             <a:avLst/>
@@ -15997,8 +15997,8 @@
         </p:nvSpPr>
         <p:spPr>
           <a:xfrm>
-            <a:off x="4500372" y="2048256"/>
-            <a:ext cx="7139939" cy="292608"/>
+            <a:off x="4507992" y="2048256"/>
+            <a:ext cx="7132320" cy="292608"/>
           </a:xfrm>
           <a:prstGeom prst="rect">
             <a:avLst/>
@@ -16403,7 +16403,7 @@
         <p:spPr>
           <a:xfrm>
             <a:off x="7790688" y="4023359"/>
-            <a:ext cx="579120" cy="731520"/>
+            <a:ext cx="585216" cy="731520"/>
           </a:xfrm>
           <a:prstGeom prst="rect">
             <a:avLst/>
@@ -16419,7 +16419,7 @@
         <p:spPr>
           <a:xfrm>
             <a:off x="7790688" y="4023359"/>
-            <a:ext cx="579120" cy="731520"/>
+            <a:ext cx="585216" cy="731520"/>
           </a:xfrm>
           <a:prstGeom prst="rect">
             <a:avLst/>
@@ -16462,8 +16462,8 @@
         </p:nvSpPr>
         <p:spPr>
           <a:xfrm>
-            <a:off x="8497824" y="4023359"/>
-            <a:ext cx="3142488" cy="914400"/>
+            <a:off x="8503920" y="4023359"/>
+            <a:ext cx="3136391" cy="914400"/>
           </a:xfrm>
           <a:prstGeom prst="rect">
             <a:avLst/>
@@ -17407,7 +17407,7 @@
         <p:spPr>
           <a:xfrm>
             <a:off x="3611880" y="1408176"/>
-            <a:ext cx="723900" cy="914400"/>
+            <a:ext cx="731520" cy="914400"/>
           </a:xfrm>
           <a:prstGeom prst="rect">
             <a:avLst/>
@@ -17423,7 +17423,7 @@
         <p:spPr>
           <a:xfrm>
             <a:off x="3611880" y="1408176"/>
-            <a:ext cx="723900" cy="914400"/>
+            <a:ext cx="731520" cy="914400"/>
           </a:xfrm>
           <a:prstGeom prst="rect">
             <a:avLst/>
@@ -17466,8 +17466,8 @@
         </p:nvSpPr>
         <p:spPr>
           <a:xfrm>
-            <a:off x="4500372" y="1408176"/>
-            <a:ext cx="7139939" cy="256032"/>
+            <a:off x="4507992" y="1408176"/>
+            <a:ext cx="7132320" cy="256032"/>
           </a:xfrm>
           <a:prstGeom prst="rect">
             <a:avLst/>
@@ -17500,8 +17500,8 @@
         </p:nvSpPr>
         <p:spPr>
           <a:xfrm>
-            <a:off x="4500372" y="1682495"/>
-            <a:ext cx="7139939" cy="347472"/>
+            <a:off x="4507992" y="1682495"/>
+            <a:ext cx="7132320" cy="347472"/>
           </a:xfrm>
           <a:prstGeom prst="rect">
             <a:avLst/>
@@ -17539,8 +17539,8 @@
         </p:nvSpPr>
         <p:spPr>
           <a:xfrm>
-            <a:off x="4500372" y="2048256"/>
-            <a:ext cx="7139939" cy="292608"/>
+            <a:off x="4507992" y="2048256"/>
+            <a:ext cx="7132320" cy="292608"/>
           </a:xfrm>
           <a:prstGeom prst="rect">
             <a:avLst/>
@@ -17929,7 +17929,7 @@
         <p:spPr>
           <a:xfrm>
             <a:off x="7790688" y="4023359"/>
-            <a:ext cx="584481" cy="731520"/>
+            <a:ext cx="587433" cy="731520"/>
           </a:xfrm>
           <a:prstGeom prst="rect">
             <a:avLst/>
@@ -17945,7 +17945,7 @@
         <p:spPr>
           <a:xfrm>
             <a:off x="7790688" y="4023359"/>
-            <a:ext cx="584480" cy="731520"/>
+            <a:ext cx="587432" cy="731520"/>
           </a:xfrm>
           <a:prstGeom prst="rect">
             <a:avLst/>
@@ -17988,8 +17988,8 @@
         </p:nvSpPr>
         <p:spPr>
           <a:xfrm>
-            <a:off x="8503184" y="4023359"/>
-            <a:ext cx="3137127" cy="914400"/>
+            <a:off x="8506136" y="4023359"/>
+            <a:ext cx="3134175" cy="914400"/>
           </a:xfrm>
           <a:prstGeom prst="rect">
             <a:avLst/>
@@ -19419,7 +19419,7 @@
         <p:spPr>
           <a:xfrm>
             <a:off x="3611880" y="1408176"/>
-            <a:ext cx="735496" cy="914400"/>
+            <a:ext cx="725557" cy="914400"/>
           </a:xfrm>
           <a:prstGeom prst="rect">
             <a:avLst/>
@@ -19435,7 +19435,7 @@
         <p:spPr>
           <a:xfrm>
             <a:off x="3611880" y="1408176"/>
-            <a:ext cx="735495" cy="914400"/>
+            <a:ext cx="725556" cy="914400"/>
           </a:xfrm>
           <a:prstGeom prst="rect">
             <a:avLst/>
@@ -19478,8 +19478,8 @@
         </p:nvSpPr>
         <p:spPr>
           <a:xfrm>
-            <a:off x="4511967" y="1408176"/>
-            <a:ext cx="7128344" cy="256032"/>
+            <a:off x="4502028" y="1408176"/>
+            <a:ext cx="7138283" cy="256032"/>
           </a:xfrm>
           <a:prstGeom prst="rect">
             <a:avLst/>
@@ -19512,8 +19512,8 @@
         </p:nvSpPr>
         <p:spPr>
           <a:xfrm>
-            <a:off x="4511967" y="1682495"/>
-            <a:ext cx="7128344" cy="347472"/>
+            <a:off x="4502028" y="1682495"/>
+            <a:ext cx="7138283" cy="347472"/>
           </a:xfrm>
           <a:prstGeom prst="rect">
             <a:avLst/>
@@ -19551,8 +19551,8 @@
         </p:nvSpPr>
         <p:spPr>
           <a:xfrm>
-            <a:off x="4511967" y="2048256"/>
-            <a:ext cx="7128344" cy="292608"/>
+            <a:off x="4502028" y="2048256"/>
+            <a:ext cx="7138283" cy="292608"/>
           </a:xfrm>
           <a:prstGeom prst="rect">
             <a:avLst/>
@@ -19717,7 +19717,7 @@
         <p:spPr>
           <a:xfrm>
             <a:off x="3611880" y="4023359"/>
-            <a:ext cx="579120" cy="731520"/>
+            <a:ext cx="585216" cy="731520"/>
           </a:xfrm>
           <a:prstGeom prst="rect">
             <a:avLst/>
@@ -19733,7 +19733,7 @@
         <p:spPr>
           <a:xfrm>
             <a:off x="3611880" y="4023359"/>
-            <a:ext cx="579120" cy="731520"/>
+            <a:ext cx="585216" cy="731520"/>
           </a:xfrm>
           <a:prstGeom prst="rect">
             <a:avLst/>
@@ -19776,8 +19776,8 @@
         </p:nvSpPr>
         <p:spPr>
           <a:xfrm>
-            <a:off x="4319016" y="4023359"/>
-            <a:ext cx="3142488" cy="914400"/>
+            <a:off x="4325112" y="4023359"/>
+            <a:ext cx="3136391" cy="914400"/>
           </a:xfrm>
           <a:prstGeom prst="rect">
             <a:avLst/>
@@ -19941,7 +19941,7 @@
         <p:spPr>
           <a:xfrm>
             <a:off x="7790688" y="4023359"/>
-            <a:ext cx="579120" cy="731520"/>
+            <a:ext cx="585216" cy="731520"/>
           </a:xfrm>
           <a:prstGeom prst="rect">
             <a:avLst/>
@@ -19957,7 +19957,7 @@
         <p:spPr>
           <a:xfrm>
             <a:off x="7790688" y="4023359"/>
-            <a:ext cx="579120" cy="731520"/>
+            <a:ext cx="585216" cy="731520"/>
           </a:xfrm>
           <a:prstGeom prst="rect">
             <a:avLst/>
@@ -20000,8 +20000,8 @@
         </p:nvSpPr>
         <p:spPr>
           <a:xfrm>
-            <a:off x="8497824" y="4023359"/>
-            <a:ext cx="3142488" cy="914400"/>
+            <a:off x="8503920" y="4023359"/>
+            <a:ext cx="3136391" cy="914400"/>
           </a:xfrm>
           <a:prstGeom prst="rect">
             <a:avLst/>
@@ -20945,7 +20945,7 @@
         <p:spPr>
           <a:xfrm>
             <a:off x="3611880" y="1408176"/>
-            <a:ext cx="723900" cy="914400"/>
+            <a:ext cx="731520" cy="914400"/>
           </a:xfrm>
           <a:prstGeom prst="rect">
             <a:avLst/>
@@ -20961,7 +20961,7 @@
         <p:spPr>
           <a:xfrm>
             <a:off x="3611880" y="1408176"/>
-            <a:ext cx="723900" cy="914400"/>
+            <a:ext cx="731520" cy="914400"/>
           </a:xfrm>
           <a:prstGeom prst="rect">
             <a:avLst/>
@@ -21004,8 +21004,8 @@
         </p:nvSpPr>
         <p:spPr>
           <a:xfrm>
-            <a:off x="4500372" y="1408176"/>
-            <a:ext cx="7139939" cy="256032"/>
+            <a:off x="4507992" y="1408176"/>
+            <a:ext cx="7132320" cy="256032"/>
           </a:xfrm>
           <a:prstGeom prst="rect">
             <a:avLst/>
@@ -21038,8 +21038,8 @@
         </p:nvSpPr>
         <p:spPr>
           <a:xfrm>
-            <a:off x="4500372" y="1682495"/>
-            <a:ext cx="7139939" cy="347472"/>
+            <a:off x="4507992" y="1682495"/>
+            <a:ext cx="7132320" cy="347472"/>
           </a:xfrm>
           <a:prstGeom prst="rect">
             <a:avLst/>
@@ -21077,8 +21077,8 @@
         </p:nvSpPr>
         <p:spPr>
           <a:xfrm>
-            <a:off x="4500372" y="2048256"/>
-            <a:ext cx="7139939" cy="292608"/>
+            <a:off x="4507992" y="2048256"/>
+            <a:ext cx="7132320" cy="292608"/>
           </a:xfrm>
           <a:prstGeom prst="rect">
             <a:avLst/>
@@ -23809,7 +23809,7 @@
         <p:spPr>
           <a:xfrm>
             <a:off x="3611880" y="1389888"/>
-            <a:ext cx="588397" cy="731520"/>
+            <a:ext cx="580445" cy="731520"/>
           </a:xfrm>
           <a:prstGeom prst="rect">
             <a:avLst/>
@@ -23825,7 +23825,7 @@
         <p:spPr>
           <a:xfrm>
             <a:off x="3611880" y="1389888"/>
-            <a:ext cx="588396" cy="731520"/>
+            <a:ext cx="580445" cy="731520"/>
           </a:xfrm>
           <a:prstGeom prst="rect">
             <a:avLst/>
@@ -23868,8 +23868,8 @@
         </p:nvSpPr>
         <p:spPr>
           <a:xfrm>
-            <a:off x="4328292" y="1389888"/>
-            <a:ext cx="3133211" cy="914400"/>
+            <a:off x="4320341" y="1389888"/>
+            <a:ext cx="3141162" cy="914400"/>
           </a:xfrm>
           <a:prstGeom prst="rect">
             <a:avLst/>
@@ -24033,7 +24033,7 @@
         <p:spPr>
           <a:xfrm>
             <a:off x="7790688" y="1389888"/>
-            <a:ext cx="579120" cy="731520"/>
+            <a:ext cx="585216" cy="731520"/>
           </a:xfrm>
           <a:prstGeom prst="rect">
             <a:avLst/>
@@ -24049,7 +24049,7 @@
         <p:spPr>
           <a:xfrm>
             <a:off x="7790688" y="1389888"/>
-            <a:ext cx="579120" cy="731520"/>
+            <a:ext cx="585216" cy="731520"/>
           </a:xfrm>
           <a:prstGeom prst="rect">
             <a:avLst/>
@@ -24092,8 +24092,8 @@
         </p:nvSpPr>
         <p:spPr>
           <a:xfrm>
-            <a:off x="8497824" y="1389888"/>
-            <a:ext cx="3142488" cy="914400"/>
+            <a:off x="8503920" y="1389888"/>
+            <a:ext cx="3136391" cy="914400"/>
           </a:xfrm>
           <a:prstGeom prst="rect">
             <a:avLst/>
@@ -24327,7 +24327,7 @@
         <p:spPr>
           <a:xfrm>
             <a:off x="3611880" y="4023359"/>
-            <a:ext cx="579120" cy="731520"/>
+            <a:ext cx="585216" cy="731520"/>
           </a:xfrm>
           <a:prstGeom prst="rect">
             <a:avLst/>
@@ -24343,7 +24343,7 @@
         <p:spPr>
           <a:xfrm>
             <a:off x="3611880" y="4023359"/>
-            <a:ext cx="579120" cy="731520"/>
+            <a:ext cx="585216" cy="731520"/>
           </a:xfrm>
           <a:prstGeom prst="rect">
             <a:avLst/>
@@ -24386,8 +24386,8 @@
         </p:nvSpPr>
         <p:spPr>
           <a:xfrm>
-            <a:off x="4319016" y="4023359"/>
-            <a:ext cx="3142488" cy="914400"/>
+            <a:off x="4325112" y="4023359"/>
+            <a:ext cx="3136391" cy="914400"/>
           </a:xfrm>
           <a:prstGeom prst="rect">
             <a:avLst/>
@@ -24551,7 +24551,7 @@
         <p:spPr>
           <a:xfrm>
             <a:off x="7790688" y="4023359"/>
-            <a:ext cx="579120" cy="731520"/>
+            <a:ext cx="585216" cy="731520"/>
           </a:xfrm>
           <a:prstGeom prst="rect">
             <a:avLst/>
@@ -24567,7 +24567,7 @@
         <p:spPr>
           <a:xfrm>
             <a:off x="7790688" y="4023359"/>
-            <a:ext cx="579120" cy="731520"/>
+            <a:ext cx="585216" cy="731520"/>
           </a:xfrm>
           <a:prstGeom prst="rect">
             <a:avLst/>
@@ -24610,8 +24610,8 @@
         </p:nvSpPr>
         <p:spPr>
           <a:xfrm>
-            <a:off x="8497824" y="4023359"/>
-            <a:ext cx="3142488" cy="914400"/>
+            <a:off x="8503920" y="4023359"/>
+            <a:ext cx="3136391" cy="914400"/>
           </a:xfrm>
           <a:prstGeom prst="rect">
             <a:avLst/>
@@ -38497,7 +38497,7 @@
       </p:sp>
       <p:pic>
         <p:nvPicPr>
-          <p:cNvPr id="16" name="Picture 15" descr="_ph-canada-solomon.png"/>
+          <p:cNvPr id="16" name="Picture 15" descr="canada-solomon.png"/>
           <p:cNvPicPr>
             <a:picLocks noChangeAspect="1"/>
           </p:cNvPicPr>
@@ -38512,7 +38512,7 @@
         <p:spPr>
           <a:xfrm>
             <a:off x="3611880" y="1408176"/>
-            <a:ext cx="731520" cy="914400"/>
+            <a:ext cx="732622" cy="914400"/>
           </a:xfrm>
           <a:prstGeom prst="rect">
             <a:avLst/>
@@ -38528,7 +38528,7 @@
         <p:spPr>
           <a:xfrm>
             <a:off x="3611880" y="1408176"/>
-            <a:ext cx="731520" cy="914400"/>
+            <a:ext cx="732621" cy="914400"/>
           </a:xfrm>
           <a:prstGeom prst="rect">
             <a:avLst/>
@@ -38571,8 +38571,8 @@
         </p:nvSpPr>
         <p:spPr>
           <a:xfrm>
-            <a:off x="4507992" y="1408176"/>
-            <a:ext cx="7132320" cy="256032"/>
+            <a:off x="4509093" y="1408176"/>
+            <a:ext cx="7131218" cy="256032"/>
           </a:xfrm>
           <a:prstGeom prst="rect">
             <a:avLst/>
@@ -38605,8 +38605,8 @@
         </p:nvSpPr>
         <p:spPr>
           <a:xfrm>
-            <a:off x="4507992" y="1682495"/>
-            <a:ext cx="7132320" cy="347472"/>
+            <a:off x="4509093" y="1682495"/>
+            <a:ext cx="7131218" cy="347472"/>
           </a:xfrm>
           <a:prstGeom prst="rect">
             <a:avLst/>
@@ -38644,8 +38644,8 @@
         </p:nvSpPr>
         <p:spPr>
           <a:xfrm>
-            <a:off x="4507992" y="2048256"/>
-            <a:ext cx="7132320" cy="292608"/>
+            <a:off x="4509093" y="2048256"/>
+            <a:ext cx="7131218" cy="292608"/>
           </a:xfrm>
           <a:prstGeom prst="rect">
             <a:avLst/>
@@ -40023,7 +40023,7 @@
       </p:sp>
       <p:pic>
         <p:nvPicPr>
-          <p:cNvPr id="16" name="Picture 15" descr="_ph-china-lilecheng.png"/>
+          <p:cNvPr id="16" name="Picture 15" descr="china-lilecheng.png"/>
           <p:cNvPicPr>
             <a:picLocks noChangeAspect="1"/>
           </p:cNvPicPr>
@@ -40038,7 +40038,7 @@
         <p:spPr>
           <a:xfrm>
             <a:off x="3611880" y="1389888"/>
-            <a:ext cx="585216" cy="731520"/>
+            <a:ext cx="586003" cy="731520"/>
           </a:xfrm>
           <a:prstGeom prst="rect">
             <a:avLst/>
@@ -40054,7 +40054,7 @@
         <p:spPr>
           <a:xfrm>
             <a:off x="3611880" y="1389888"/>
-            <a:ext cx="585216" cy="731520"/>
+            <a:ext cx="586002" cy="731520"/>
           </a:xfrm>
           <a:prstGeom prst="rect">
             <a:avLst/>
@@ -40097,8 +40097,8 @@
         </p:nvSpPr>
         <p:spPr>
           <a:xfrm>
-            <a:off x="4325112" y="1389888"/>
-            <a:ext cx="3136391" cy="914400"/>
+            <a:off x="4325898" y="1389888"/>
+            <a:ext cx="3135605" cy="914400"/>
           </a:xfrm>
           <a:prstGeom prst="rect">
             <a:avLst/>
@@ -40247,7 +40247,7 @@
       </p:sp>
       <p:pic>
         <p:nvPicPr>
-          <p:cNvPr id="21" name="Picture 20" descr="_ph-china-hejun.png"/>
+          <p:cNvPr id="21" name="Picture 20" descr="china-hejun.png"/>
           <p:cNvPicPr>
             <a:picLocks noChangeAspect="1"/>
           </p:cNvPicPr>
@@ -40262,7 +40262,7 @@
         <p:spPr>
           <a:xfrm>
             <a:off x="7790688" y="1389888"/>
-            <a:ext cx="585216" cy="731520"/>
+            <a:ext cx="587614" cy="731520"/>
           </a:xfrm>
           <a:prstGeom prst="rect">
             <a:avLst/>
@@ -40278,7 +40278,7 @@
         <p:spPr>
           <a:xfrm>
             <a:off x="7790688" y="1389888"/>
-            <a:ext cx="585216" cy="731520"/>
+            <a:ext cx="587614" cy="731520"/>
           </a:xfrm>
           <a:prstGeom prst="rect">
             <a:avLst/>
@@ -40321,8 +40321,8 @@
         </p:nvSpPr>
         <p:spPr>
           <a:xfrm>
-            <a:off x="8503920" y="1389888"/>
-            <a:ext cx="3136391" cy="914400"/>
+            <a:off x="8506318" y="1389888"/>
+            <a:ext cx="3133993" cy="914400"/>
           </a:xfrm>
           <a:prstGeom prst="rect">
             <a:avLst/>
@@ -40541,7 +40541,7 @@
       </p:sp>
       <p:pic>
         <p:nvPicPr>
-          <p:cNvPr id="28" name="Picture 27" descr="_ph-china-wangwentao.png"/>
+          <p:cNvPr id="28" name="Picture 27" descr="china-wangwentao.png"/>
           <p:cNvPicPr>
             <a:picLocks noChangeAspect="1"/>
           </p:cNvPicPr>
@@ -40556,7 +40556,7 @@
         <p:spPr>
           <a:xfrm>
             <a:off x="3611880" y="4023359"/>
-            <a:ext cx="585216" cy="731520"/>
+            <a:ext cx="587433" cy="731520"/>
           </a:xfrm>
           <a:prstGeom prst="rect">
             <a:avLst/>
@@ -40572,7 +40572,7 @@
         <p:spPr>
           <a:xfrm>
             <a:off x="3611880" y="4023359"/>
-            <a:ext cx="585216" cy="731520"/>
+            <a:ext cx="587432" cy="731520"/>
           </a:xfrm>
           <a:prstGeom prst="rect">
             <a:avLst/>
@@ -40615,8 +40615,8 @@
         </p:nvSpPr>
         <p:spPr>
           <a:xfrm>
-            <a:off x="4325112" y="4023359"/>
-            <a:ext cx="3136391" cy="914400"/>
+            <a:off x="4327328" y="4023359"/>
+            <a:ext cx="3134175" cy="914400"/>
           </a:xfrm>
           <a:prstGeom prst="rect">
             <a:avLst/>
@@ -40765,7 +40765,7 @@
       </p:sp>
       <p:pic>
         <p:nvPicPr>
-          <p:cNvPr id="33" name="Picture 32" descr="_ph-china-lichenggang.png"/>
+          <p:cNvPr id="33" name="Picture 32" descr="china-lichenggang.png"/>
           <p:cNvPicPr>
             <a:picLocks noChangeAspect="1"/>
           </p:cNvPicPr>
@@ -40780,7 +40780,7 @@
         <p:spPr>
           <a:xfrm>
             <a:off x="7790688" y="4023359"/>
-            <a:ext cx="585216" cy="731520"/>
+            <a:ext cx="584481" cy="731520"/>
           </a:xfrm>
           <a:prstGeom prst="rect">
             <a:avLst/>
@@ -40796,7 +40796,7 @@
         <p:spPr>
           <a:xfrm>
             <a:off x="7790688" y="4023359"/>
-            <a:ext cx="585216" cy="731520"/>
+            <a:ext cx="584480" cy="731520"/>
           </a:xfrm>
           <a:prstGeom prst="rect">
             <a:avLst/>
@@ -40839,8 +40839,8 @@
         </p:nvSpPr>
         <p:spPr>
           <a:xfrm>
-            <a:off x="8503920" y="4023359"/>
-            <a:ext cx="3136391" cy="914400"/>
+            <a:off x="8503184" y="4023359"/>
+            <a:ext cx="3137127" cy="914400"/>
           </a:xfrm>
           <a:prstGeom prst="rect">
             <a:avLst/>

</xml_diff>

<commit_message>
Apply final portrait batch: 9 new officials (52/59 total)
From the third sheet (53 images, 53/53 pairing agreement, visually
verified): Canada complete (LeBlanc - real photo this time - and
Sidhu), Brazil complete (Santos, Siqueira Filho, Elias Rosa),
Australia complete (Charlton, Ayres, Farrell), Argentina (Quirno).

Held out: "Luis Caputo" - not an official on the verified roster
(Argentina's slots are Genua, Quirno, Lavigne); flagged to preparer
rather than guessed. Li Chenggang's image in this sheet is byte-
identical to the prior event candid, so no replacement was applied.

Remaining placeholders (7): Argentina (Genua, Lavigne), Saudi Arabia
(Al-Qasabi), EU (Virkkunen, Sefcovic), AU (Mataboge, Tatchouop
Belobe). 684 QA checks pass.

Co-Authored-By: Claude Fable 5 <noreply@anthropic.com>
Claude-Session: https://claude.ai/code/session_01D7VNHN8h6qLVjZi6Tzyhub
</commit_message>
<xml_diff>
--- a/output/g20-ministers-trade-deck.pptx
+++ b/output/g20-ministers-trade-deck.pptx
@@ -4253,7 +4253,7 @@
         <p:spPr>
           <a:xfrm>
             <a:off x="3611880" y="1408176"/>
-            <a:ext cx="730601" cy="914400"/>
+            <a:ext cx="734291" cy="914400"/>
           </a:xfrm>
           <a:prstGeom prst="rect">
             <a:avLst/>
@@ -4269,7 +4269,7 @@
         <p:spPr>
           <a:xfrm>
             <a:off x="3611880" y="1408176"/>
-            <a:ext cx="730601" cy="914400"/>
+            <a:ext cx="734290" cy="914400"/>
           </a:xfrm>
           <a:prstGeom prst="rect">
             <a:avLst/>
@@ -4312,8 +4312,8 @@
         </p:nvSpPr>
         <p:spPr>
           <a:xfrm>
-            <a:off x="4507073" y="1408176"/>
-            <a:ext cx="7133238" cy="256032"/>
+            <a:off x="4510762" y="1408176"/>
+            <a:ext cx="7129549" cy="256032"/>
           </a:xfrm>
           <a:prstGeom prst="rect">
             <a:avLst/>
@@ -4346,8 +4346,8 @@
         </p:nvSpPr>
         <p:spPr>
           <a:xfrm>
-            <a:off x="4507073" y="1682495"/>
-            <a:ext cx="7133238" cy="347472"/>
+            <a:off x="4510762" y="1682495"/>
+            <a:ext cx="7129549" cy="347472"/>
           </a:xfrm>
           <a:prstGeom prst="rect">
             <a:avLst/>
@@ -4385,8 +4385,8 @@
         </p:nvSpPr>
         <p:spPr>
           <a:xfrm>
-            <a:off x="4507073" y="2048256"/>
-            <a:ext cx="7133238" cy="292608"/>
+            <a:off x="4510762" y="2048256"/>
+            <a:ext cx="7129549" cy="292608"/>
           </a:xfrm>
           <a:prstGeom prst="rect">
             <a:avLst/>
@@ -4551,7 +4551,7 @@
         <p:spPr>
           <a:xfrm>
             <a:off x="3611880" y="4041648"/>
-            <a:ext cx="732503" cy="914400"/>
+            <a:ext cx="727587" cy="914400"/>
           </a:xfrm>
           <a:prstGeom prst="rect">
             <a:avLst/>
@@ -4567,7 +4567,7 @@
         <p:spPr>
           <a:xfrm>
             <a:off x="3611880" y="4041648"/>
-            <a:ext cx="732503" cy="914400"/>
+            <a:ext cx="727587" cy="914400"/>
           </a:xfrm>
           <a:prstGeom prst="rect">
             <a:avLst/>
@@ -4610,8 +4610,8 @@
         </p:nvSpPr>
         <p:spPr>
           <a:xfrm>
-            <a:off x="4508975" y="4041648"/>
-            <a:ext cx="7131336" cy="256032"/>
+            <a:off x="4504059" y="4041648"/>
+            <a:ext cx="7136252" cy="256032"/>
           </a:xfrm>
           <a:prstGeom prst="rect">
             <a:avLst/>
@@ -4644,8 +4644,8 @@
         </p:nvSpPr>
         <p:spPr>
           <a:xfrm>
-            <a:off x="4508975" y="4315968"/>
-            <a:ext cx="7131336" cy="347472"/>
+            <a:off x="4504059" y="4315968"/>
+            <a:ext cx="7136252" cy="347472"/>
           </a:xfrm>
           <a:prstGeom prst="rect">
             <a:avLst/>
@@ -4683,8 +4683,8 @@
         </p:nvSpPr>
         <p:spPr>
           <a:xfrm>
-            <a:off x="4508975" y="4681727"/>
-            <a:ext cx="7131336" cy="292608"/>
+            <a:off x="4504059" y="4681727"/>
+            <a:ext cx="7136252" cy="292608"/>
           </a:xfrm>
           <a:prstGeom prst="rect">
             <a:avLst/>
@@ -5559,7 +5559,7 @@
         <p:spPr>
           <a:xfrm>
             <a:off x="3611880" y="1408176"/>
-            <a:ext cx="730601" cy="914400"/>
+            <a:ext cx="734291" cy="914400"/>
           </a:xfrm>
           <a:prstGeom prst="rect">
             <a:avLst/>
@@ -5575,7 +5575,7 @@
         <p:spPr>
           <a:xfrm>
             <a:off x="3611880" y="1408176"/>
-            <a:ext cx="730601" cy="914400"/>
+            <a:ext cx="734290" cy="914400"/>
           </a:xfrm>
           <a:prstGeom prst="rect">
             <a:avLst/>
@@ -5618,8 +5618,8 @@
         </p:nvSpPr>
         <p:spPr>
           <a:xfrm>
-            <a:off x="4507073" y="1408176"/>
-            <a:ext cx="7133238" cy="256032"/>
+            <a:off x="4510762" y="1408176"/>
+            <a:ext cx="7129549" cy="256032"/>
           </a:xfrm>
           <a:prstGeom prst="rect">
             <a:avLst/>
@@ -5652,8 +5652,8 @@
         </p:nvSpPr>
         <p:spPr>
           <a:xfrm>
-            <a:off x="4507073" y="1682495"/>
-            <a:ext cx="7133238" cy="347472"/>
+            <a:off x="4510762" y="1682495"/>
+            <a:ext cx="7129549" cy="347472"/>
           </a:xfrm>
           <a:prstGeom prst="rect">
             <a:avLst/>
@@ -5691,8 +5691,8 @@
         </p:nvSpPr>
         <p:spPr>
           <a:xfrm>
-            <a:off x="4507073" y="2048256"/>
-            <a:ext cx="7133238" cy="292608"/>
+            <a:off x="4510762" y="2048256"/>
+            <a:ext cx="7129549" cy="292608"/>
           </a:xfrm>
           <a:prstGeom prst="rect">
             <a:avLst/>
@@ -5857,7 +5857,7 @@
         <p:spPr>
           <a:xfrm>
             <a:off x="3611880" y="4041648"/>
-            <a:ext cx="730601" cy="914400"/>
+            <a:ext cx="734291" cy="914400"/>
           </a:xfrm>
           <a:prstGeom prst="rect">
             <a:avLst/>
@@ -5873,7 +5873,7 @@
         <p:spPr>
           <a:xfrm>
             <a:off x="3611880" y="4041648"/>
-            <a:ext cx="730601" cy="914400"/>
+            <a:ext cx="734290" cy="914400"/>
           </a:xfrm>
           <a:prstGeom prst="rect">
             <a:avLst/>
@@ -5916,8 +5916,8 @@
         </p:nvSpPr>
         <p:spPr>
           <a:xfrm>
-            <a:off x="4507073" y="4041648"/>
-            <a:ext cx="7133238" cy="256032"/>
+            <a:off x="4510762" y="4041648"/>
+            <a:ext cx="7129549" cy="256032"/>
           </a:xfrm>
           <a:prstGeom prst="rect">
             <a:avLst/>
@@ -5950,8 +5950,8 @@
         </p:nvSpPr>
         <p:spPr>
           <a:xfrm>
-            <a:off x="4507073" y="4315968"/>
-            <a:ext cx="7133238" cy="347472"/>
+            <a:off x="4510762" y="4315968"/>
+            <a:ext cx="7129549" cy="347472"/>
           </a:xfrm>
           <a:prstGeom prst="rect">
             <a:avLst/>
@@ -5989,8 +5989,8 @@
         </p:nvSpPr>
         <p:spPr>
           <a:xfrm>
-            <a:off x="4507073" y="4681727"/>
-            <a:ext cx="7133238" cy="292608"/>
+            <a:off x="4510762" y="4681727"/>
+            <a:ext cx="7129549" cy="292608"/>
           </a:xfrm>
           <a:prstGeom prst="rect">
             <a:avLst/>
@@ -7195,7 +7195,7 @@
         <p:spPr>
           <a:xfrm>
             <a:off x="3611880" y="4023359"/>
-            <a:ext cx="582884" cy="731520"/>
+            <a:ext cx="585216" cy="731520"/>
           </a:xfrm>
           <a:prstGeom prst="rect">
             <a:avLst/>
@@ -7211,7 +7211,7 @@
         <p:spPr>
           <a:xfrm>
             <a:off x="3611880" y="4023359"/>
-            <a:ext cx="582884" cy="731520"/>
+            <a:ext cx="585216" cy="731520"/>
           </a:xfrm>
           <a:prstGeom prst="rect">
             <a:avLst/>
@@ -7254,8 +7254,8 @@
         </p:nvSpPr>
         <p:spPr>
           <a:xfrm>
-            <a:off x="4322780" y="4023359"/>
-            <a:ext cx="3138723" cy="914400"/>
+            <a:off x="4325112" y="4023359"/>
+            <a:ext cx="3136391" cy="914400"/>
           </a:xfrm>
           <a:prstGeom prst="rect">
             <a:avLst/>
@@ -7419,7 +7419,7 @@
         <p:spPr>
           <a:xfrm>
             <a:off x="7790688" y="4023359"/>
-            <a:ext cx="584481" cy="731520"/>
+            <a:ext cx="587433" cy="731520"/>
           </a:xfrm>
           <a:prstGeom prst="rect">
             <a:avLst/>
@@ -7435,7 +7435,7 @@
         <p:spPr>
           <a:xfrm>
             <a:off x="7790688" y="4023359"/>
-            <a:ext cx="584480" cy="731520"/>
+            <a:ext cx="587432" cy="731520"/>
           </a:xfrm>
           <a:prstGeom prst="rect">
             <a:avLst/>
@@ -7478,8 +7478,8 @@
         </p:nvSpPr>
         <p:spPr>
           <a:xfrm>
-            <a:off x="8503184" y="4023359"/>
-            <a:ext cx="3137127" cy="914400"/>
+            <a:off x="8506136" y="4023359"/>
+            <a:ext cx="3134175" cy="914400"/>
           </a:xfrm>
           <a:prstGeom prst="rect">
             <a:avLst/>
@@ -8423,7 +8423,7 @@
         <p:spPr>
           <a:xfrm>
             <a:off x="3611880" y="1408176"/>
-            <a:ext cx="730601" cy="914400"/>
+            <a:ext cx="734291" cy="914400"/>
           </a:xfrm>
           <a:prstGeom prst="rect">
             <a:avLst/>
@@ -8439,7 +8439,7 @@
         <p:spPr>
           <a:xfrm>
             <a:off x="3611880" y="1408176"/>
-            <a:ext cx="730601" cy="914400"/>
+            <a:ext cx="734290" cy="914400"/>
           </a:xfrm>
           <a:prstGeom prst="rect">
             <a:avLst/>
@@ -8482,8 +8482,8 @@
         </p:nvSpPr>
         <p:spPr>
           <a:xfrm>
-            <a:off x="4507073" y="1408176"/>
-            <a:ext cx="7133238" cy="256032"/>
+            <a:off x="4510762" y="1408176"/>
+            <a:ext cx="7129549" cy="256032"/>
           </a:xfrm>
           <a:prstGeom prst="rect">
             <a:avLst/>
@@ -8516,8 +8516,8 @@
         </p:nvSpPr>
         <p:spPr>
           <a:xfrm>
-            <a:off x="4507073" y="1682495"/>
-            <a:ext cx="7133238" cy="347472"/>
+            <a:off x="4510762" y="1682495"/>
+            <a:ext cx="7129549" cy="347472"/>
           </a:xfrm>
           <a:prstGeom prst="rect">
             <a:avLst/>
@@ -8555,8 +8555,8 @@
         </p:nvSpPr>
         <p:spPr>
           <a:xfrm>
-            <a:off x="4507073" y="2048256"/>
-            <a:ext cx="7133238" cy="292608"/>
+            <a:off x="4510762" y="2048256"/>
+            <a:ext cx="7129549" cy="292608"/>
           </a:xfrm>
           <a:prstGeom prst="rect">
             <a:avLst/>
@@ -8721,7 +8721,7 @@
         <p:spPr>
           <a:xfrm>
             <a:off x="3611880" y="4023359"/>
-            <a:ext cx="587433" cy="731520"/>
+            <a:ext cx="583738" cy="731520"/>
           </a:xfrm>
           <a:prstGeom prst="rect">
             <a:avLst/>
@@ -8737,7 +8737,7 @@
         <p:spPr>
           <a:xfrm>
             <a:off x="3611880" y="4023359"/>
-            <a:ext cx="587432" cy="731520"/>
+            <a:ext cx="583738" cy="731520"/>
           </a:xfrm>
           <a:prstGeom prst="rect">
             <a:avLst/>
@@ -8780,8 +8780,8 @@
         </p:nvSpPr>
         <p:spPr>
           <a:xfrm>
-            <a:off x="4327328" y="4023359"/>
-            <a:ext cx="3134175" cy="914400"/>
+            <a:off x="4323634" y="4023359"/>
+            <a:ext cx="3137869" cy="914400"/>
           </a:xfrm>
           <a:prstGeom prst="rect">
             <a:avLst/>
@@ -8945,7 +8945,7 @@
         <p:spPr>
           <a:xfrm>
             <a:off x="7790688" y="4023359"/>
-            <a:ext cx="584481" cy="731520"/>
+            <a:ext cx="587433" cy="731520"/>
           </a:xfrm>
           <a:prstGeom prst="rect">
             <a:avLst/>
@@ -8961,7 +8961,7 @@
         <p:spPr>
           <a:xfrm>
             <a:off x="7790688" y="4023359"/>
-            <a:ext cx="584480" cy="731520"/>
+            <a:ext cx="587432" cy="731520"/>
           </a:xfrm>
           <a:prstGeom prst="rect">
             <a:avLst/>
@@ -9004,8 +9004,8 @@
         </p:nvSpPr>
         <p:spPr>
           <a:xfrm>
-            <a:off x="8503184" y="4023359"/>
-            <a:ext cx="3137127" cy="914400"/>
+            <a:off x="8506136" y="4023359"/>
+            <a:ext cx="3134175" cy="914400"/>
           </a:xfrm>
           <a:prstGeom prst="rect">
             <a:avLst/>
@@ -9949,7 +9949,7 @@
         <p:spPr>
           <a:xfrm>
             <a:off x="3611880" y="1408176"/>
-            <a:ext cx="730601" cy="914400"/>
+            <a:ext cx="734291" cy="914400"/>
           </a:xfrm>
           <a:prstGeom prst="rect">
             <a:avLst/>
@@ -9965,7 +9965,7 @@
         <p:spPr>
           <a:xfrm>
             <a:off x="3611880" y="1408176"/>
-            <a:ext cx="730601" cy="914400"/>
+            <a:ext cx="734290" cy="914400"/>
           </a:xfrm>
           <a:prstGeom prst="rect">
             <a:avLst/>
@@ -10008,8 +10008,8 @@
         </p:nvSpPr>
         <p:spPr>
           <a:xfrm>
-            <a:off x="4507073" y="1408176"/>
-            <a:ext cx="7133238" cy="256032"/>
+            <a:off x="4510762" y="1408176"/>
+            <a:ext cx="7129549" cy="256032"/>
           </a:xfrm>
           <a:prstGeom prst="rect">
             <a:avLst/>
@@ -10042,8 +10042,8 @@
         </p:nvSpPr>
         <p:spPr>
           <a:xfrm>
-            <a:off x="4507073" y="1682495"/>
-            <a:ext cx="7133238" cy="347472"/>
+            <a:off x="4510762" y="1682495"/>
+            <a:ext cx="7129549" cy="347472"/>
           </a:xfrm>
           <a:prstGeom prst="rect">
             <a:avLst/>
@@ -10081,8 +10081,8 @@
         </p:nvSpPr>
         <p:spPr>
           <a:xfrm>
-            <a:off x="4507073" y="2048256"/>
-            <a:ext cx="7133238" cy="292608"/>
+            <a:off x="4510762" y="2048256"/>
+            <a:ext cx="7129549" cy="292608"/>
           </a:xfrm>
           <a:prstGeom prst="rect">
             <a:avLst/>
@@ -10247,7 +10247,7 @@
         <p:spPr>
           <a:xfrm>
             <a:off x="3611880" y="4023359"/>
-            <a:ext cx="584481" cy="731520"/>
+            <a:ext cx="587433" cy="731520"/>
           </a:xfrm>
           <a:prstGeom prst="rect">
             <a:avLst/>
@@ -10263,7 +10263,7 @@
         <p:spPr>
           <a:xfrm>
             <a:off x="3611880" y="4023359"/>
-            <a:ext cx="584480" cy="731520"/>
+            <a:ext cx="587432" cy="731520"/>
           </a:xfrm>
           <a:prstGeom prst="rect">
             <a:avLst/>
@@ -10306,8 +10306,8 @@
         </p:nvSpPr>
         <p:spPr>
           <a:xfrm>
-            <a:off x="4324376" y="4023359"/>
-            <a:ext cx="3137127" cy="914400"/>
+            <a:off x="4327328" y="4023359"/>
+            <a:ext cx="3134175" cy="914400"/>
           </a:xfrm>
           <a:prstGeom prst="rect">
             <a:avLst/>
@@ -10471,7 +10471,7 @@
         <p:spPr>
           <a:xfrm>
             <a:off x="7790688" y="4023359"/>
-            <a:ext cx="586740" cy="731520"/>
+            <a:ext cx="582930" cy="731520"/>
           </a:xfrm>
           <a:prstGeom prst="rect">
             <a:avLst/>
@@ -10487,7 +10487,7 @@
         <p:spPr>
           <a:xfrm>
             <a:off x="7790688" y="4023359"/>
-            <a:ext cx="586740" cy="731520"/>
+            <a:ext cx="582930" cy="731520"/>
           </a:xfrm>
           <a:prstGeom prst="rect">
             <a:avLst/>
@@ -10530,8 +10530,8 @@
         </p:nvSpPr>
         <p:spPr>
           <a:xfrm>
-            <a:off x="8505444" y="4023359"/>
-            <a:ext cx="3134868" cy="914400"/>
+            <a:off x="8501634" y="4023359"/>
+            <a:ext cx="3138677" cy="914400"/>
           </a:xfrm>
           <a:prstGeom prst="rect">
             <a:avLst/>
@@ -11475,7 +11475,7 @@
         <p:spPr>
           <a:xfrm>
             <a:off x="3611880" y="1408176"/>
-            <a:ext cx="733710" cy="914400"/>
+            <a:ext cx="728235" cy="914400"/>
           </a:xfrm>
           <a:prstGeom prst="rect">
             <a:avLst/>
@@ -11491,7 +11491,7 @@
         <p:spPr>
           <a:xfrm>
             <a:off x="3611880" y="1408176"/>
-            <a:ext cx="733710" cy="914400"/>
+            <a:ext cx="728234" cy="914400"/>
           </a:xfrm>
           <a:prstGeom prst="rect">
             <a:avLst/>
@@ -11534,8 +11534,8 @@
         </p:nvSpPr>
         <p:spPr>
           <a:xfrm>
-            <a:off x="4510182" y="1408176"/>
-            <a:ext cx="7130129" cy="256032"/>
+            <a:off x="4504706" y="1408176"/>
+            <a:ext cx="7135605" cy="256032"/>
           </a:xfrm>
           <a:prstGeom prst="rect">
             <a:avLst/>
@@ -11568,8 +11568,8 @@
         </p:nvSpPr>
         <p:spPr>
           <a:xfrm>
-            <a:off x="4510182" y="1682495"/>
-            <a:ext cx="7130129" cy="347472"/>
+            <a:off x="4504706" y="1682495"/>
+            <a:ext cx="7135605" cy="347472"/>
           </a:xfrm>
           <a:prstGeom prst="rect">
             <a:avLst/>
@@ -11607,8 +11607,8 @@
         </p:nvSpPr>
         <p:spPr>
           <a:xfrm>
-            <a:off x="4510182" y="2048256"/>
-            <a:ext cx="7130129" cy="292608"/>
+            <a:off x="4504706" y="2048256"/>
+            <a:ext cx="7135605" cy="292608"/>
           </a:xfrm>
           <a:prstGeom prst="rect">
             <a:avLst/>
@@ -11773,7 +11773,7 @@
         <p:spPr>
           <a:xfrm>
             <a:off x="3611880" y="4041648"/>
-            <a:ext cx="732503" cy="914400"/>
+            <a:ext cx="727587" cy="914400"/>
           </a:xfrm>
           <a:prstGeom prst="rect">
             <a:avLst/>
@@ -11789,7 +11789,7 @@
         <p:spPr>
           <a:xfrm>
             <a:off x="3611880" y="4041648"/>
-            <a:ext cx="732503" cy="914400"/>
+            <a:ext cx="727587" cy="914400"/>
           </a:xfrm>
           <a:prstGeom prst="rect">
             <a:avLst/>
@@ -11832,8 +11832,8 @@
         </p:nvSpPr>
         <p:spPr>
           <a:xfrm>
-            <a:off x="4508975" y="4041648"/>
-            <a:ext cx="7131336" cy="256032"/>
+            <a:off x="4504059" y="4041648"/>
+            <a:ext cx="7136252" cy="256032"/>
           </a:xfrm>
           <a:prstGeom prst="rect">
             <a:avLst/>
@@ -11866,8 +11866,8 @@
         </p:nvSpPr>
         <p:spPr>
           <a:xfrm>
-            <a:off x="4508975" y="4315968"/>
-            <a:ext cx="7131336" cy="347472"/>
+            <a:off x="4504059" y="4315968"/>
+            <a:ext cx="7136252" cy="347472"/>
           </a:xfrm>
           <a:prstGeom prst="rect">
             <a:avLst/>
@@ -11905,8 +11905,8 @@
         </p:nvSpPr>
         <p:spPr>
           <a:xfrm>
-            <a:off x="4508975" y="4681727"/>
-            <a:ext cx="7131336" cy="292608"/>
+            <a:off x="4504059" y="4681727"/>
+            <a:ext cx="7136252" cy="292608"/>
           </a:xfrm>
           <a:prstGeom prst="rect">
             <a:avLst/>
@@ -12797,7 +12797,7 @@
         <p:spPr>
           <a:xfrm>
             <a:off x="3611880" y="1408176"/>
-            <a:ext cx="734291" cy="914400"/>
+            <a:ext cx="729673" cy="914400"/>
           </a:xfrm>
           <a:prstGeom prst="rect">
             <a:avLst/>
@@ -12813,7 +12813,7 @@
         <p:spPr>
           <a:xfrm>
             <a:off x="3611880" y="1408176"/>
-            <a:ext cx="734290" cy="914400"/>
+            <a:ext cx="729672" cy="914400"/>
           </a:xfrm>
           <a:prstGeom prst="rect">
             <a:avLst/>
@@ -12856,8 +12856,8 @@
         </p:nvSpPr>
         <p:spPr>
           <a:xfrm>
-            <a:off x="4510762" y="1408176"/>
-            <a:ext cx="7129549" cy="256032"/>
+            <a:off x="4506144" y="1408176"/>
+            <a:ext cx="7134167" cy="256032"/>
           </a:xfrm>
           <a:prstGeom prst="rect">
             <a:avLst/>
@@ -12890,8 +12890,8 @@
         </p:nvSpPr>
         <p:spPr>
           <a:xfrm>
-            <a:off x="4510762" y="1682495"/>
-            <a:ext cx="7129549" cy="347472"/>
+            <a:off x="4506144" y="1682495"/>
+            <a:ext cx="7134167" cy="347472"/>
           </a:xfrm>
           <a:prstGeom prst="rect">
             <a:avLst/>
@@ -12929,8 +12929,8 @@
         </p:nvSpPr>
         <p:spPr>
           <a:xfrm>
-            <a:off x="4510762" y="2048256"/>
-            <a:ext cx="7129549" cy="292608"/>
+            <a:off x="4506144" y="2048256"/>
+            <a:ext cx="7134167" cy="292608"/>
           </a:xfrm>
           <a:prstGeom prst="rect">
             <a:avLst/>
@@ -13095,7 +13095,7 @@
         <p:spPr>
           <a:xfrm>
             <a:off x="3611880" y="4023359"/>
-            <a:ext cx="587433" cy="731520"/>
+            <a:ext cx="583738" cy="731520"/>
           </a:xfrm>
           <a:prstGeom prst="rect">
             <a:avLst/>
@@ -13111,7 +13111,7 @@
         <p:spPr>
           <a:xfrm>
             <a:off x="3611880" y="4023359"/>
-            <a:ext cx="587432" cy="731520"/>
+            <a:ext cx="583738" cy="731520"/>
           </a:xfrm>
           <a:prstGeom prst="rect">
             <a:avLst/>
@@ -13154,8 +13154,8 @@
         </p:nvSpPr>
         <p:spPr>
           <a:xfrm>
-            <a:off x="4327328" y="4023359"/>
-            <a:ext cx="3134175" cy="914400"/>
+            <a:off x="4323634" y="4023359"/>
+            <a:ext cx="3137869" cy="914400"/>
           </a:xfrm>
           <a:prstGeom prst="rect">
             <a:avLst/>
@@ -13319,7 +13319,7 @@
         <p:spPr>
           <a:xfrm>
             <a:off x="7790688" y="4023359"/>
-            <a:ext cx="584481" cy="731520"/>
+            <a:ext cx="587433" cy="731520"/>
           </a:xfrm>
           <a:prstGeom prst="rect">
             <a:avLst/>
@@ -13335,7 +13335,7 @@
         <p:spPr>
           <a:xfrm>
             <a:off x="7790688" y="4023359"/>
-            <a:ext cx="584480" cy="731520"/>
+            <a:ext cx="587432" cy="731520"/>
           </a:xfrm>
           <a:prstGeom prst="rect">
             <a:avLst/>
@@ -13378,8 +13378,8 @@
         </p:nvSpPr>
         <p:spPr>
           <a:xfrm>
-            <a:off x="8503184" y="4023359"/>
-            <a:ext cx="3137127" cy="914400"/>
+            <a:off x="8506136" y="4023359"/>
+            <a:ext cx="3134175" cy="914400"/>
           </a:xfrm>
           <a:prstGeom prst="rect">
             <a:avLst/>
@@ -14323,7 +14323,7 @@
         <p:spPr>
           <a:xfrm>
             <a:off x="3611880" y="1408176"/>
-            <a:ext cx="734291" cy="914400"/>
+            <a:ext cx="729673" cy="914400"/>
           </a:xfrm>
           <a:prstGeom prst="rect">
             <a:avLst/>
@@ -14339,7 +14339,7 @@
         <p:spPr>
           <a:xfrm>
             <a:off x="3611880" y="1408176"/>
-            <a:ext cx="734290" cy="914400"/>
+            <a:ext cx="729672" cy="914400"/>
           </a:xfrm>
           <a:prstGeom prst="rect">
             <a:avLst/>
@@ -14382,8 +14382,8 @@
         </p:nvSpPr>
         <p:spPr>
           <a:xfrm>
-            <a:off x="4510762" y="1408176"/>
-            <a:ext cx="7129549" cy="256032"/>
+            <a:off x="4506144" y="1408176"/>
+            <a:ext cx="7134167" cy="256032"/>
           </a:xfrm>
           <a:prstGeom prst="rect">
             <a:avLst/>
@@ -14416,8 +14416,8 @@
         </p:nvSpPr>
         <p:spPr>
           <a:xfrm>
-            <a:off x="4510762" y="1682495"/>
-            <a:ext cx="7129549" cy="347472"/>
+            <a:off x="4506144" y="1682495"/>
+            <a:ext cx="7134167" cy="347472"/>
           </a:xfrm>
           <a:prstGeom prst="rect">
             <a:avLst/>
@@ -14455,8 +14455,8 @@
         </p:nvSpPr>
         <p:spPr>
           <a:xfrm>
-            <a:off x="4510762" y="2048256"/>
-            <a:ext cx="7129549" cy="292608"/>
+            <a:off x="4506144" y="2048256"/>
+            <a:ext cx="7134167" cy="292608"/>
           </a:xfrm>
           <a:prstGeom prst="rect">
             <a:avLst/>
@@ -14861,7 +14861,7 @@
         <p:spPr>
           <a:xfrm>
             <a:off x="7790688" y="4023359"/>
-            <a:ext cx="587433" cy="731520"/>
+            <a:ext cx="583738" cy="731520"/>
           </a:xfrm>
           <a:prstGeom prst="rect">
             <a:avLst/>
@@ -14877,7 +14877,7 @@
         <p:spPr>
           <a:xfrm>
             <a:off x="7790688" y="4023359"/>
-            <a:ext cx="587432" cy="731520"/>
+            <a:ext cx="583738" cy="731520"/>
           </a:xfrm>
           <a:prstGeom prst="rect">
             <a:avLst/>
@@ -14920,8 +14920,8 @@
         </p:nvSpPr>
         <p:spPr>
           <a:xfrm>
-            <a:off x="8506136" y="4023359"/>
-            <a:ext cx="3134175" cy="914400"/>
+            <a:off x="8502442" y="4023359"/>
+            <a:ext cx="3137869" cy="914400"/>
           </a:xfrm>
           <a:prstGeom prst="rect">
             <a:avLst/>
@@ -17929,7 +17929,7 @@
         <p:spPr>
           <a:xfrm>
             <a:off x="7790688" y="4023359"/>
-            <a:ext cx="587433" cy="731520"/>
+            <a:ext cx="583738" cy="731520"/>
           </a:xfrm>
           <a:prstGeom prst="rect">
             <a:avLst/>
@@ -17945,7 +17945,7 @@
         <p:spPr>
           <a:xfrm>
             <a:off x="7790688" y="4023359"/>
-            <a:ext cx="587432" cy="731520"/>
+            <a:ext cx="583738" cy="731520"/>
           </a:xfrm>
           <a:prstGeom prst="rect">
             <a:avLst/>
@@ -17988,8 +17988,8 @@
         </p:nvSpPr>
         <p:spPr>
           <a:xfrm>
-            <a:off x="8506136" y="4023359"/>
-            <a:ext cx="3134175" cy="914400"/>
+            <a:off x="8502442" y="4023359"/>
+            <a:ext cx="3137869" cy="914400"/>
           </a:xfrm>
           <a:prstGeom prst="rect">
             <a:avLst/>
@@ -19419,7 +19419,7 @@
         <p:spPr>
           <a:xfrm>
             <a:off x="3611880" y="1408176"/>
-            <a:ext cx="725557" cy="914400"/>
+            <a:ext cx="733530" cy="914400"/>
           </a:xfrm>
           <a:prstGeom prst="rect">
             <a:avLst/>
@@ -19435,7 +19435,7 @@
         <p:spPr>
           <a:xfrm>
             <a:off x="3611880" y="1408176"/>
-            <a:ext cx="725556" cy="914400"/>
+            <a:ext cx="733529" cy="914400"/>
           </a:xfrm>
           <a:prstGeom prst="rect">
             <a:avLst/>
@@ -19478,8 +19478,8 @@
         </p:nvSpPr>
         <p:spPr>
           <a:xfrm>
-            <a:off x="4502028" y="1408176"/>
-            <a:ext cx="7138283" cy="256032"/>
+            <a:off x="4510001" y="1408176"/>
+            <a:ext cx="7130310" cy="256032"/>
           </a:xfrm>
           <a:prstGeom prst="rect">
             <a:avLst/>
@@ -19512,8 +19512,8 @@
         </p:nvSpPr>
         <p:spPr>
           <a:xfrm>
-            <a:off x="4502028" y="1682495"/>
-            <a:ext cx="7138283" cy="347472"/>
+            <a:off x="4510001" y="1682495"/>
+            <a:ext cx="7130310" cy="347472"/>
           </a:xfrm>
           <a:prstGeom prst="rect">
             <a:avLst/>
@@ -19551,8 +19551,8 @@
         </p:nvSpPr>
         <p:spPr>
           <a:xfrm>
-            <a:off x="4502028" y="2048256"/>
-            <a:ext cx="7138283" cy="292608"/>
+            <a:off x="4510001" y="2048256"/>
+            <a:ext cx="7130310" cy="292608"/>
           </a:xfrm>
           <a:prstGeom prst="rect">
             <a:avLst/>
@@ -23809,7 +23809,7 @@
         <p:spPr>
           <a:xfrm>
             <a:off x="3611880" y="1389888"/>
-            <a:ext cx="580445" cy="731520"/>
+            <a:ext cx="586824" cy="731520"/>
           </a:xfrm>
           <a:prstGeom prst="rect">
             <a:avLst/>
@@ -23825,7 +23825,7 @@
         <p:spPr>
           <a:xfrm>
             <a:off x="3611880" y="1389888"/>
-            <a:ext cx="580445" cy="731520"/>
+            <a:ext cx="586823" cy="731520"/>
           </a:xfrm>
           <a:prstGeom prst="rect">
             <a:avLst/>
@@ -23868,8 +23868,8 @@
         </p:nvSpPr>
         <p:spPr>
           <a:xfrm>
-            <a:off x="4320341" y="1389888"/>
-            <a:ext cx="3141162" cy="914400"/>
+            <a:off x="4326719" y="1389888"/>
+            <a:ext cx="3134784" cy="914400"/>
           </a:xfrm>
           <a:prstGeom prst="rect">
             <a:avLst/>
@@ -34192,7 +34192,7 @@
       </p:sp>
       <p:pic>
         <p:nvPicPr>
-          <p:cNvPr id="24" name="Picture 23" descr="_ph-argentina-quirno.png"/>
+          <p:cNvPr id="24" name="Picture 23" descr="argentina-quirno.png"/>
           <p:cNvPicPr>
             <a:picLocks noChangeAspect="1"/>
           </p:cNvPicPr>
@@ -34207,7 +34207,7 @@
         <p:spPr>
           <a:xfrm>
             <a:off x="3611880" y="4023359"/>
-            <a:ext cx="585216" cy="731520"/>
+            <a:ext cx="584481" cy="731520"/>
           </a:xfrm>
           <a:prstGeom prst="rect">
             <a:avLst/>
@@ -34223,7 +34223,7 @@
         <p:spPr>
           <a:xfrm>
             <a:off x="3611880" y="4023359"/>
-            <a:ext cx="585216" cy="731520"/>
+            <a:ext cx="584480" cy="731520"/>
           </a:xfrm>
           <a:prstGeom prst="rect">
             <a:avLst/>
@@ -34266,8 +34266,8 @@
         </p:nvSpPr>
         <p:spPr>
           <a:xfrm>
-            <a:off x="4325112" y="4023359"/>
-            <a:ext cx="3136391" cy="914400"/>
+            <a:off x="4324376" y="4023359"/>
+            <a:ext cx="3137127" cy="914400"/>
           </a:xfrm>
           <a:prstGeom prst="rect">
             <a:avLst/>
@@ -35429,7 +35429,7 @@
       </p:sp>
       <p:pic>
         <p:nvPicPr>
-          <p:cNvPr id="16" name="Picture 15" descr="_ph-australia-charlton.png"/>
+          <p:cNvPr id="16" name="Picture 15" descr="australia-charlton.png"/>
           <p:cNvPicPr>
             <a:picLocks noChangeAspect="1"/>
           </p:cNvPicPr>
@@ -35444,7 +35444,7 @@
         <p:spPr>
           <a:xfrm>
             <a:off x="3611880" y="1389888"/>
-            <a:ext cx="585216" cy="731520"/>
+            <a:ext cx="586097" cy="731520"/>
           </a:xfrm>
           <a:prstGeom prst="rect">
             <a:avLst/>
@@ -35460,7 +35460,7 @@
         <p:spPr>
           <a:xfrm>
             <a:off x="3611880" y="1389888"/>
-            <a:ext cx="585216" cy="731520"/>
+            <a:ext cx="586097" cy="731520"/>
           </a:xfrm>
           <a:prstGeom prst="rect">
             <a:avLst/>
@@ -35503,8 +35503,8 @@
         </p:nvSpPr>
         <p:spPr>
           <a:xfrm>
-            <a:off x="4325112" y="1389888"/>
-            <a:ext cx="3136391" cy="914400"/>
+            <a:off x="4325993" y="1389888"/>
+            <a:ext cx="3135510" cy="914400"/>
           </a:xfrm>
           <a:prstGeom prst="rect">
             <a:avLst/>
@@ -35653,7 +35653,7 @@
       </p:sp>
       <p:pic>
         <p:nvPicPr>
-          <p:cNvPr id="21" name="Picture 20" descr="_ph-australia-ayres.png"/>
+          <p:cNvPr id="21" name="Picture 20" descr="australia-ayres.png"/>
           <p:cNvPicPr>
             <a:picLocks noChangeAspect="1"/>
           </p:cNvPicPr>
@@ -35668,7 +35668,7 @@
         <p:spPr>
           <a:xfrm>
             <a:off x="7790688" y="1389888"/>
-            <a:ext cx="585216" cy="731520"/>
+            <a:ext cx="584481" cy="731520"/>
           </a:xfrm>
           <a:prstGeom prst="rect">
             <a:avLst/>
@@ -35684,7 +35684,7 @@
         <p:spPr>
           <a:xfrm>
             <a:off x="7790688" y="1389888"/>
-            <a:ext cx="585216" cy="731520"/>
+            <a:ext cx="584480" cy="731520"/>
           </a:xfrm>
           <a:prstGeom prst="rect">
             <a:avLst/>
@@ -35727,8 +35727,8 @@
         </p:nvSpPr>
         <p:spPr>
           <a:xfrm>
-            <a:off x="8503920" y="1389888"/>
-            <a:ext cx="3136391" cy="914400"/>
+            <a:off x="8503184" y="1389888"/>
+            <a:ext cx="3137127" cy="914400"/>
           </a:xfrm>
           <a:prstGeom prst="rect">
             <a:avLst/>
@@ -35947,7 +35947,7 @@
       </p:sp>
       <p:pic>
         <p:nvPicPr>
-          <p:cNvPr id="28" name="Picture 27" descr="_ph-australia-farrell.png"/>
+          <p:cNvPr id="28" name="Picture 27" descr="australia-farrell.png"/>
           <p:cNvPicPr>
             <a:picLocks noChangeAspect="1"/>
           </p:cNvPicPr>
@@ -35962,7 +35962,7 @@
         <p:spPr>
           <a:xfrm>
             <a:off x="3611880" y="4041648"/>
-            <a:ext cx="731520" cy="914400"/>
+            <a:ext cx="733778" cy="914400"/>
           </a:xfrm>
           <a:prstGeom prst="rect">
             <a:avLst/>
@@ -35978,7 +35978,7 @@
         <p:spPr>
           <a:xfrm>
             <a:off x="3611880" y="4041648"/>
-            <a:ext cx="731520" cy="914400"/>
+            <a:ext cx="733777" cy="914400"/>
           </a:xfrm>
           <a:prstGeom prst="rect">
             <a:avLst/>
@@ -36021,8 +36021,8 @@
         </p:nvSpPr>
         <p:spPr>
           <a:xfrm>
-            <a:off x="4507992" y="4041648"/>
-            <a:ext cx="7132320" cy="256032"/>
+            <a:off x="4510249" y="4041648"/>
+            <a:ext cx="7130062" cy="256032"/>
           </a:xfrm>
           <a:prstGeom prst="rect">
             <a:avLst/>
@@ -36055,8 +36055,8 @@
         </p:nvSpPr>
         <p:spPr>
           <a:xfrm>
-            <a:off x="4507992" y="4315968"/>
-            <a:ext cx="7132320" cy="347472"/>
+            <a:off x="4510249" y="4315968"/>
+            <a:ext cx="7130062" cy="347472"/>
           </a:xfrm>
           <a:prstGeom prst="rect">
             <a:avLst/>
@@ -36094,8 +36094,8 @@
         </p:nvSpPr>
         <p:spPr>
           <a:xfrm>
-            <a:off x="4507992" y="4681727"/>
-            <a:ext cx="7132320" cy="292608"/>
+            <a:off x="4510249" y="4681727"/>
+            <a:ext cx="7130062" cy="292608"/>
           </a:xfrm>
           <a:prstGeom prst="rect">
             <a:avLst/>
@@ -36971,7 +36971,7 @@
       </p:sp>
       <p:pic>
         <p:nvPicPr>
-          <p:cNvPr id="16" name="Picture 15" descr="_ph-brazil-siqueira.png"/>
+          <p:cNvPr id="16" name="Picture 15" descr="brazil-siqueira.png"/>
           <p:cNvPicPr>
             <a:picLocks noChangeAspect="1"/>
           </p:cNvPicPr>
@@ -36986,7 +36986,7 @@
         <p:spPr>
           <a:xfrm>
             <a:off x="3611880" y="1389888"/>
-            <a:ext cx="585216" cy="731520"/>
+            <a:ext cx="586740" cy="731520"/>
           </a:xfrm>
           <a:prstGeom prst="rect">
             <a:avLst/>
@@ -37002,7 +37002,7 @@
         <p:spPr>
           <a:xfrm>
             <a:off x="3611880" y="1389888"/>
-            <a:ext cx="585216" cy="731520"/>
+            <a:ext cx="586740" cy="731520"/>
           </a:xfrm>
           <a:prstGeom prst="rect">
             <a:avLst/>
@@ -37045,8 +37045,8 @@
         </p:nvSpPr>
         <p:spPr>
           <a:xfrm>
-            <a:off x="4325112" y="1389888"/>
-            <a:ext cx="3136391" cy="914400"/>
+            <a:off x="4326636" y="1389888"/>
+            <a:ext cx="3134868" cy="914400"/>
           </a:xfrm>
           <a:prstGeom prst="rect">
             <a:avLst/>
@@ -37195,7 +37195,7 @@
       </p:sp>
       <p:pic>
         <p:nvPicPr>
-          <p:cNvPr id="21" name="Picture 20" descr="_ph-brazil-santos.png"/>
+          <p:cNvPr id="21" name="Picture 20" descr="brazil-santos.png"/>
           <p:cNvPicPr>
             <a:picLocks noChangeAspect="1"/>
           </p:cNvPicPr>
@@ -37210,7 +37210,7 @@
         <p:spPr>
           <a:xfrm>
             <a:off x="7790688" y="1389888"/>
-            <a:ext cx="585216" cy="731520"/>
+            <a:ext cx="582736" cy="731520"/>
           </a:xfrm>
           <a:prstGeom prst="rect">
             <a:avLst/>
@@ -37226,7 +37226,7 @@
         <p:spPr>
           <a:xfrm>
             <a:off x="7790688" y="1389888"/>
-            <a:ext cx="585216" cy="731520"/>
+            <a:ext cx="582736" cy="731520"/>
           </a:xfrm>
           <a:prstGeom prst="rect">
             <a:avLst/>
@@ -37269,8 +37269,8 @@
         </p:nvSpPr>
         <p:spPr>
           <a:xfrm>
-            <a:off x="8503920" y="1389888"/>
-            <a:ext cx="3136391" cy="914400"/>
+            <a:off x="8501440" y="1389888"/>
+            <a:ext cx="3138871" cy="914400"/>
           </a:xfrm>
           <a:prstGeom prst="rect">
             <a:avLst/>
@@ -37489,7 +37489,7 @@
       </p:sp>
       <p:pic>
         <p:nvPicPr>
-          <p:cNvPr id="28" name="Picture 27" descr="_ph-brazil-rosa.png"/>
+          <p:cNvPr id="28" name="Picture 27" descr="brazil-rosa.png"/>
           <p:cNvPicPr>
             <a:picLocks noChangeAspect="1"/>
           </p:cNvPicPr>
@@ -37504,7 +37504,7 @@
         <p:spPr>
           <a:xfrm>
             <a:off x="3611880" y="4041648"/>
-            <a:ext cx="731520" cy="914400"/>
+            <a:ext cx="730601" cy="914400"/>
           </a:xfrm>
           <a:prstGeom prst="rect">
             <a:avLst/>
@@ -37520,7 +37520,7 @@
         <p:spPr>
           <a:xfrm>
             <a:off x="3611880" y="4041648"/>
-            <a:ext cx="731520" cy="914400"/>
+            <a:ext cx="730601" cy="914400"/>
           </a:xfrm>
           <a:prstGeom prst="rect">
             <a:avLst/>
@@ -37563,8 +37563,8 @@
         </p:nvSpPr>
         <p:spPr>
           <a:xfrm>
-            <a:off x="4507992" y="4041648"/>
-            <a:ext cx="7132320" cy="256032"/>
+            <a:off x="4507073" y="4041648"/>
+            <a:ext cx="7133238" cy="256032"/>
           </a:xfrm>
           <a:prstGeom prst="rect">
             <a:avLst/>
@@ -37597,8 +37597,8 @@
         </p:nvSpPr>
         <p:spPr>
           <a:xfrm>
-            <a:off x="4507992" y="4315968"/>
-            <a:ext cx="7132320" cy="347472"/>
+            <a:off x="4507073" y="4315968"/>
+            <a:ext cx="7133238" cy="347472"/>
           </a:xfrm>
           <a:prstGeom prst="rect">
             <a:avLst/>
@@ -37636,8 +37636,8 @@
         </p:nvSpPr>
         <p:spPr>
           <a:xfrm>
-            <a:off x="4507992" y="4681727"/>
-            <a:ext cx="7132320" cy="292608"/>
+            <a:off x="4507073" y="4681727"/>
+            <a:ext cx="7133238" cy="292608"/>
           </a:xfrm>
           <a:prstGeom prst="rect">
             <a:avLst/>
@@ -38512,7 +38512,7 @@
         <p:spPr>
           <a:xfrm>
             <a:off x="3611880" y="1408176"/>
-            <a:ext cx="732622" cy="914400"/>
+            <a:ext cx="727113" cy="914400"/>
           </a:xfrm>
           <a:prstGeom prst="rect">
             <a:avLst/>
@@ -38528,7 +38528,7 @@
         <p:spPr>
           <a:xfrm>
             <a:off x="3611880" y="1408176"/>
-            <a:ext cx="732621" cy="914400"/>
+            <a:ext cx="727113" cy="914400"/>
           </a:xfrm>
           <a:prstGeom prst="rect">
             <a:avLst/>
@@ -38571,8 +38571,8 @@
         </p:nvSpPr>
         <p:spPr>
           <a:xfrm>
-            <a:off x="4509093" y="1408176"/>
-            <a:ext cx="7131218" cy="256032"/>
+            <a:off x="4503585" y="1408176"/>
+            <a:ext cx="7136726" cy="256032"/>
           </a:xfrm>
           <a:prstGeom prst="rect">
             <a:avLst/>
@@ -38605,8 +38605,8 @@
         </p:nvSpPr>
         <p:spPr>
           <a:xfrm>
-            <a:off x="4509093" y="1682495"/>
-            <a:ext cx="7131218" cy="347472"/>
+            <a:off x="4503585" y="1682495"/>
+            <a:ext cx="7136726" cy="347472"/>
           </a:xfrm>
           <a:prstGeom prst="rect">
             <a:avLst/>
@@ -38644,8 +38644,8 @@
         </p:nvSpPr>
         <p:spPr>
           <a:xfrm>
-            <a:off x="4509093" y="2048256"/>
-            <a:ext cx="7131218" cy="292608"/>
+            <a:off x="4503585" y="2048256"/>
+            <a:ext cx="7136726" cy="292608"/>
           </a:xfrm>
           <a:prstGeom prst="rect">
             <a:avLst/>
@@ -38795,7 +38795,7 @@
       </p:sp>
       <p:pic>
         <p:nvPicPr>
-          <p:cNvPr id="24" name="Picture 23" descr="_ph-canada-sidhu.png"/>
+          <p:cNvPr id="24" name="Picture 23" descr="canada-sidhu.png"/>
           <p:cNvPicPr>
             <a:picLocks noChangeAspect="1"/>
           </p:cNvPicPr>
@@ -39019,7 +39019,7 @@
       </p:sp>
       <p:pic>
         <p:nvPicPr>
-          <p:cNvPr id="29" name="Picture 28" descr="_ph-argentina-genua.png"/>
+          <p:cNvPr id="29" name="Picture 28" descr="canada-leblanc.png"/>
           <p:cNvPicPr>
             <a:picLocks noChangeAspect="1"/>
           </p:cNvPicPr>
@@ -39034,7 +39034,7 @@
         <p:spPr>
           <a:xfrm>
             <a:off x="7790688" y="4023359"/>
-            <a:ext cx="585216" cy="731520"/>
+            <a:ext cx="586097" cy="731520"/>
           </a:xfrm>
           <a:prstGeom prst="rect">
             <a:avLst/>
@@ -39050,7 +39050,7 @@
         <p:spPr>
           <a:xfrm>
             <a:off x="7790688" y="4023359"/>
-            <a:ext cx="585216" cy="731520"/>
+            <a:ext cx="586097" cy="731520"/>
           </a:xfrm>
           <a:prstGeom prst="rect">
             <a:avLst/>
@@ -39093,8 +39093,8 @@
         </p:nvSpPr>
         <p:spPr>
           <a:xfrm>
-            <a:off x="8503920" y="4023359"/>
-            <a:ext cx="3136391" cy="914400"/>
+            <a:off x="8504801" y="4023359"/>
+            <a:ext cx="3135510" cy="914400"/>
           </a:xfrm>
           <a:prstGeom prst="rect">
             <a:avLst/>
@@ -40038,7 +40038,7 @@
         <p:spPr>
           <a:xfrm>
             <a:off x="3611880" y="1389888"/>
-            <a:ext cx="586003" cy="731520"/>
+            <a:ext cx="582070" cy="731520"/>
           </a:xfrm>
           <a:prstGeom prst="rect">
             <a:avLst/>
@@ -40054,7 +40054,7 @@
         <p:spPr>
           <a:xfrm>
             <a:off x="3611880" y="1389888"/>
-            <a:ext cx="586002" cy="731520"/>
+            <a:ext cx="582069" cy="731520"/>
           </a:xfrm>
           <a:prstGeom prst="rect">
             <a:avLst/>
@@ -40097,8 +40097,8 @@
         </p:nvSpPr>
         <p:spPr>
           <a:xfrm>
-            <a:off x="4325898" y="1389888"/>
-            <a:ext cx="3135605" cy="914400"/>
+            <a:off x="4321965" y="1389888"/>
+            <a:ext cx="3139538" cy="914400"/>
           </a:xfrm>
           <a:prstGeom prst="rect">
             <a:avLst/>
@@ -40262,7 +40262,7 @@
         <p:spPr>
           <a:xfrm>
             <a:off x="7790688" y="1389888"/>
-            <a:ext cx="587614" cy="731520"/>
+            <a:ext cx="583617" cy="731520"/>
           </a:xfrm>
           <a:prstGeom prst="rect">
             <a:avLst/>
@@ -40278,7 +40278,7 @@
         <p:spPr>
           <a:xfrm>
             <a:off x="7790688" y="1389888"/>
-            <a:ext cx="587614" cy="731520"/>
+            <a:ext cx="583617" cy="731520"/>
           </a:xfrm>
           <a:prstGeom prst="rect">
             <a:avLst/>
@@ -40321,8 +40321,8 @@
         </p:nvSpPr>
         <p:spPr>
           <a:xfrm>
-            <a:off x="8506318" y="1389888"/>
-            <a:ext cx="3133993" cy="914400"/>
+            <a:off x="8502321" y="1389888"/>
+            <a:ext cx="3137990" cy="914400"/>
           </a:xfrm>
           <a:prstGeom prst="rect">
             <a:avLst/>
@@ -40556,7 +40556,7 @@
         <p:spPr>
           <a:xfrm>
             <a:off x="3611880" y="4023359"/>
-            <a:ext cx="587433" cy="731520"/>
+            <a:ext cx="583738" cy="731520"/>
           </a:xfrm>
           <a:prstGeom prst="rect">
             <a:avLst/>
@@ -40572,7 +40572,7 @@
         <p:spPr>
           <a:xfrm>
             <a:off x="3611880" y="4023359"/>
-            <a:ext cx="587432" cy="731520"/>
+            <a:ext cx="583738" cy="731520"/>
           </a:xfrm>
           <a:prstGeom prst="rect">
             <a:avLst/>
@@ -40615,8 +40615,8 @@
         </p:nvSpPr>
         <p:spPr>
           <a:xfrm>
-            <a:off x="4327328" y="4023359"/>
-            <a:ext cx="3134175" cy="914400"/>
+            <a:off x="4323634" y="4023359"/>
+            <a:ext cx="3137869" cy="914400"/>
           </a:xfrm>
           <a:prstGeom prst="rect">
             <a:avLst/>
@@ -40780,7 +40780,7 @@
         <p:spPr>
           <a:xfrm>
             <a:off x="7790688" y="4023359"/>
-            <a:ext cx="584481" cy="731520"/>
+            <a:ext cx="587433" cy="731520"/>
           </a:xfrm>
           <a:prstGeom prst="rect">
             <a:avLst/>
@@ -40796,7 +40796,7 @@
         <p:spPr>
           <a:xfrm>
             <a:off x="7790688" y="4023359"/>
-            <a:ext cx="584480" cy="731520"/>
+            <a:ext cx="587432" cy="731520"/>
           </a:xfrm>
           <a:prstGeom prst="rect">
             <a:avLst/>
@@ -40839,8 +40839,8 @@
         </p:nvSpPr>
         <p:spPr>
           <a:xfrm>
-            <a:off x="8503184" y="4023359"/>
-            <a:ext cx="3137127" cy="914400"/>
+            <a:off x="8506136" y="4023359"/>
+            <a:ext cx="3134175" cy="914400"/>
           </a:xfrm>
           <a:prstGeom prst="rect">
             <a:avLst/>

</xml_diff>

<commit_message>
Final 7 portraits (59/59 complete); standardize number formats
Portraits: extracted the final seven from the fourth sheet (docx) -
Genua, Lavigne, Al-Qasabi, Virkkunen, Sefcovic, Mataboge, Tatchouop
Belobe - all high-resolution; caption pairing verified in document
order and visually. Every displayed official in the deck and list now
carries a real portrait (59/59). Luis Caputo's photo remains unused
(not on the verified roster).

Number standardization across deliverables: workbook cells now render
$X,XXX.XB with minus-sign negatives (matching the deck's tables);
the list's Key Figures tables use the same $X,XXX.XB form (prose
sentences keep spelled-out billions). Deck already used this format.

684 QA checks pass.

Co-Authored-By: Claude Fable 5 <noreply@anthropic.com>
Claude-Session: https://claude.ai/code/session_01D7VNHN8h6qLVjZi6Tzyhub
</commit_message>
<xml_diff>
--- a/output/g20-ministers-trade-deck.pptx
+++ b/output/g20-ministers-trade-deck.pptx
@@ -4253,7 +4253,7 @@
         <p:spPr>
           <a:xfrm>
             <a:off x="3611880" y="1408176"/>
-            <a:ext cx="734291" cy="914400"/>
+            <a:ext cx="729673" cy="914400"/>
           </a:xfrm>
           <a:prstGeom prst="rect">
             <a:avLst/>
@@ -4269,7 +4269,7 @@
         <p:spPr>
           <a:xfrm>
             <a:off x="3611880" y="1408176"/>
-            <a:ext cx="734290" cy="914400"/>
+            <a:ext cx="729672" cy="914400"/>
           </a:xfrm>
           <a:prstGeom prst="rect">
             <a:avLst/>
@@ -4312,8 +4312,8 @@
         </p:nvSpPr>
         <p:spPr>
           <a:xfrm>
-            <a:off x="4510762" y="1408176"/>
-            <a:ext cx="7129549" cy="256032"/>
+            <a:off x="4506144" y="1408176"/>
+            <a:ext cx="7134167" cy="256032"/>
           </a:xfrm>
           <a:prstGeom prst="rect">
             <a:avLst/>
@@ -4346,8 +4346,8 @@
         </p:nvSpPr>
         <p:spPr>
           <a:xfrm>
-            <a:off x="4510762" y="1682495"/>
-            <a:ext cx="7129549" cy="347472"/>
+            <a:off x="4506144" y="1682495"/>
+            <a:ext cx="7134167" cy="347472"/>
           </a:xfrm>
           <a:prstGeom prst="rect">
             <a:avLst/>
@@ -4385,8 +4385,8 @@
         </p:nvSpPr>
         <p:spPr>
           <a:xfrm>
-            <a:off x="4510762" y="2048256"/>
-            <a:ext cx="7129549" cy="292608"/>
+            <a:off x="4506144" y="2048256"/>
+            <a:ext cx="7134167" cy="292608"/>
           </a:xfrm>
           <a:prstGeom prst="rect">
             <a:avLst/>
@@ -4551,7 +4551,7 @@
         <p:spPr>
           <a:xfrm>
             <a:off x="3611880" y="4041648"/>
-            <a:ext cx="727587" cy="914400"/>
+            <a:ext cx="731520" cy="914400"/>
           </a:xfrm>
           <a:prstGeom prst="rect">
             <a:avLst/>
@@ -4567,7 +4567,7 @@
         <p:spPr>
           <a:xfrm>
             <a:off x="3611880" y="4041648"/>
-            <a:ext cx="727587" cy="914400"/>
+            <a:ext cx="731520" cy="914400"/>
           </a:xfrm>
           <a:prstGeom prst="rect">
             <a:avLst/>
@@ -4610,8 +4610,8 @@
         </p:nvSpPr>
         <p:spPr>
           <a:xfrm>
-            <a:off x="4504059" y="4041648"/>
-            <a:ext cx="7136252" cy="256032"/>
+            <a:off x="4507992" y="4041648"/>
+            <a:ext cx="7132320" cy="256032"/>
           </a:xfrm>
           <a:prstGeom prst="rect">
             <a:avLst/>
@@ -4644,8 +4644,8 @@
         </p:nvSpPr>
         <p:spPr>
           <a:xfrm>
-            <a:off x="4504059" y="4315968"/>
-            <a:ext cx="7136252" cy="347472"/>
+            <a:off x="4507992" y="4315968"/>
+            <a:ext cx="7132320" cy="347472"/>
           </a:xfrm>
           <a:prstGeom prst="rect">
             <a:avLst/>
@@ -4683,8 +4683,8 @@
         </p:nvSpPr>
         <p:spPr>
           <a:xfrm>
-            <a:off x="4504059" y="4681727"/>
-            <a:ext cx="7136252" cy="292608"/>
+            <a:off x="4507992" y="4681727"/>
+            <a:ext cx="7132320" cy="292608"/>
           </a:xfrm>
           <a:prstGeom prst="rect">
             <a:avLst/>
@@ -5559,7 +5559,7 @@
         <p:spPr>
           <a:xfrm>
             <a:off x="3611880" y="1408176"/>
-            <a:ext cx="734291" cy="914400"/>
+            <a:ext cx="729673" cy="914400"/>
           </a:xfrm>
           <a:prstGeom prst="rect">
             <a:avLst/>
@@ -5575,7 +5575,7 @@
         <p:spPr>
           <a:xfrm>
             <a:off x="3611880" y="1408176"/>
-            <a:ext cx="734290" cy="914400"/>
+            <a:ext cx="729672" cy="914400"/>
           </a:xfrm>
           <a:prstGeom prst="rect">
             <a:avLst/>
@@ -5618,8 +5618,8 @@
         </p:nvSpPr>
         <p:spPr>
           <a:xfrm>
-            <a:off x="4510762" y="1408176"/>
-            <a:ext cx="7129549" cy="256032"/>
+            <a:off x="4506144" y="1408176"/>
+            <a:ext cx="7134167" cy="256032"/>
           </a:xfrm>
           <a:prstGeom prst="rect">
             <a:avLst/>
@@ -5652,8 +5652,8 @@
         </p:nvSpPr>
         <p:spPr>
           <a:xfrm>
-            <a:off x="4510762" y="1682495"/>
-            <a:ext cx="7129549" cy="347472"/>
+            <a:off x="4506144" y="1682495"/>
+            <a:ext cx="7134167" cy="347472"/>
           </a:xfrm>
           <a:prstGeom prst="rect">
             <a:avLst/>
@@ -5691,8 +5691,8 @@
         </p:nvSpPr>
         <p:spPr>
           <a:xfrm>
-            <a:off x="4510762" y="2048256"/>
-            <a:ext cx="7129549" cy="292608"/>
+            <a:off x="4506144" y="2048256"/>
+            <a:ext cx="7134167" cy="292608"/>
           </a:xfrm>
           <a:prstGeom prst="rect">
             <a:avLst/>
@@ -5857,7 +5857,7 @@
         <p:spPr>
           <a:xfrm>
             <a:off x="3611880" y="4041648"/>
-            <a:ext cx="734291" cy="914400"/>
+            <a:ext cx="729673" cy="914400"/>
           </a:xfrm>
           <a:prstGeom prst="rect">
             <a:avLst/>
@@ -5873,7 +5873,7 @@
         <p:spPr>
           <a:xfrm>
             <a:off x="3611880" y="4041648"/>
-            <a:ext cx="734290" cy="914400"/>
+            <a:ext cx="729672" cy="914400"/>
           </a:xfrm>
           <a:prstGeom prst="rect">
             <a:avLst/>
@@ -5916,8 +5916,8 @@
         </p:nvSpPr>
         <p:spPr>
           <a:xfrm>
-            <a:off x="4510762" y="4041648"/>
-            <a:ext cx="7129549" cy="256032"/>
+            <a:off x="4506144" y="4041648"/>
+            <a:ext cx="7134167" cy="256032"/>
           </a:xfrm>
           <a:prstGeom prst="rect">
             <a:avLst/>
@@ -5950,8 +5950,8 @@
         </p:nvSpPr>
         <p:spPr>
           <a:xfrm>
-            <a:off x="4510762" y="4315968"/>
-            <a:ext cx="7129549" cy="347472"/>
+            <a:off x="4506144" y="4315968"/>
+            <a:ext cx="7134167" cy="347472"/>
           </a:xfrm>
           <a:prstGeom prst="rect">
             <a:avLst/>
@@ -5989,8 +5989,8 @@
         </p:nvSpPr>
         <p:spPr>
           <a:xfrm>
-            <a:off x="4510762" y="4681727"/>
-            <a:ext cx="7129549" cy="292608"/>
+            <a:off x="4506144" y="4681727"/>
+            <a:ext cx="7134167" cy="292608"/>
           </a:xfrm>
           <a:prstGeom prst="rect">
             <a:avLst/>
@@ -7419,7 +7419,7 @@
         <p:spPr>
           <a:xfrm>
             <a:off x="7790688" y="4023359"/>
-            <a:ext cx="587433" cy="731520"/>
+            <a:ext cx="583738" cy="731520"/>
           </a:xfrm>
           <a:prstGeom prst="rect">
             <a:avLst/>
@@ -7435,7 +7435,7 @@
         <p:spPr>
           <a:xfrm>
             <a:off x="7790688" y="4023359"/>
-            <a:ext cx="587432" cy="731520"/>
+            <a:ext cx="583738" cy="731520"/>
           </a:xfrm>
           <a:prstGeom prst="rect">
             <a:avLst/>
@@ -7478,8 +7478,8 @@
         </p:nvSpPr>
         <p:spPr>
           <a:xfrm>
-            <a:off x="8506136" y="4023359"/>
-            <a:ext cx="3134175" cy="914400"/>
+            <a:off x="8502442" y="4023359"/>
+            <a:ext cx="3137869" cy="914400"/>
           </a:xfrm>
           <a:prstGeom prst="rect">
             <a:avLst/>
@@ -8423,7 +8423,7 @@
         <p:spPr>
           <a:xfrm>
             <a:off x="3611880" y="1408176"/>
-            <a:ext cx="734291" cy="914400"/>
+            <a:ext cx="729673" cy="914400"/>
           </a:xfrm>
           <a:prstGeom prst="rect">
             <a:avLst/>
@@ -8439,7 +8439,7 @@
         <p:spPr>
           <a:xfrm>
             <a:off x="3611880" y="1408176"/>
-            <a:ext cx="734290" cy="914400"/>
+            <a:ext cx="729672" cy="914400"/>
           </a:xfrm>
           <a:prstGeom prst="rect">
             <a:avLst/>
@@ -8482,8 +8482,8 @@
         </p:nvSpPr>
         <p:spPr>
           <a:xfrm>
-            <a:off x="4510762" y="1408176"/>
-            <a:ext cx="7129549" cy="256032"/>
+            <a:off x="4506144" y="1408176"/>
+            <a:ext cx="7134167" cy="256032"/>
           </a:xfrm>
           <a:prstGeom prst="rect">
             <a:avLst/>
@@ -8516,8 +8516,8 @@
         </p:nvSpPr>
         <p:spPr>
           <a:xfrm>
-            <a:off x="4510762" y="1682495"/>
-            <a:ext cx="7129549" cy="347472"/>
+            <a:off x="4506144" y="1682495"/>
+            <a:ext cx="7134167" cy="347472"/>
           </a:xfrm>
           <a:prstGeom prst="rect">
             <a:avLst/>
@@ -8555,8 +8555,8 @@
         </p:nvSpPr>
         <p:spPr>
           <a:xfrm>
-            <a:off x="4510762" y="2048256"/>
-            <a:ext cx="7129549" cy="292608"/>
+            <a:off x="4506144" y="2048256"/>
+            <a:ext cx="7134167" cy="292608"/>
           </a:xfrm>
           <a:prstGeom prst="rect">
             <a:avLst/>
@@ -8721,7 +8721,7 @@
         <p:spPr>
           <a:xfrm>
             <a:off x="3611880" y="4023359"/>
-            <a:ext cx="583738" cy="731520"/>
+            <a:ext cx="586701" cy="731520"/>
           </a:xfrm>
           <a:prstGeom prst="rect">
             <a:avLst/>
@@ -8737,7 +8737,7 @@
         <p:spPr>
           <a:xfrm>
             <a:off x="3611880" y="4023359"/>
-            <a:ext cx="583738" cy="731520"/>
+            <a:ext cx="586701" cy="731520"/>
           </a:xfrm>
           <a:prstGeom prst="rect">
             <a:avLst/>
@@ -8780,8 +8780,8 @@
         </p:nvSpPr>
         <p:spPr>
           <a:xfrm>
-            <a:off x="4323634" y="4023359"/>
-            <a:ext cx="3137869" cy="914400"/>
+            <a:off x="4326597" y="4023359"/>
+            <a:ext cx="3134906" cy="914400"/>
           </a:xfrm>
           <a:prstGeom prst="rect">
             <a:avLst/>
@@ -8945,7 +8945,7 @@
         <p:spPr>
           <a:xfrm>
             <a:off x="7790688" y="4023359"/>
-            <a:ext cx="587433" cy="731520"/>
+            <a:ext cx="583738" cy="731520"/>
           </a:xfrm>
           <a:prstGeom prst="rect">
             <a:avLst/>
@@ -8961,7 +8961,7 @@
         <p:spPr>
           <a:xfrm>
             <a:off x="7790688" y="4023359"/>
-            <a:ext cx="587432" cy="731520"/>
+            <a:ext cx="583738" cy="731520"/>
           </a:xfrm>
           <a:prstGeom prst="rect">
             <a:avLst/>
@@ -9004,8 +9004,8 @@
         </p:nvSpPr>
         <p:spPr>
           <a:xfrm>
-            <a:off x="8506136" y="4023359"/>
-            <a:ext cx="3134175" cy="914400"/>
+            <a:off x="8502442" y="4023359"/>
+            <a:ext cx="3137869" cy="914400"/>
           </a:xfrm>
           <a:prstGeom prst="rect">
             <a:avLst/>
@@ -9949,7 +9949,7 @@
         <p:spPr>
           <a:xfrm>
             <a:off x="3611880" y="1408176"/>
-            <a:ext cx="734291" cy="914400"/>
+            <a:ext cx="729673" cy="914400"/>
           </a:xfrm>
           <a:prstGeom prst="rect">
             <a:avLst/>
@@ -9965,7 +9965,7 @@
         <p:spPr>
           <a:xfrm>
             <a:off x="3611880" y="1408176"/>
-            <a:ext cx="734290" cy="914400"/>
+            <a:ext cx="729672" cy="914400"/>
           </a:xfrm>
           <a:prstGeom prst="rect">
             <a:avLst/>
@@ -10008,8 +10008,8 @@
         </p:nvSpPr>
         <p:spPr>
           <a:xfrm>
-            <a:off x="4510762" y="1408176"/>
-            <a:ext cx="7129549" cy="256032"/>
+            <a:off x="4506144" y="1408176"/>
+            <a:ext cx="7134167" cy="256032"/>
           </a:xfrm>
           <a:prstGeom prst="rect">
             <a:avLst/>
@@ -10042,8 +10042,8 @@
         </p:nvSpPr>
         <p:spPr>
           <a:xfrm>
-            <a:off x="4510762" y="1682495"/>
-            <a:ext cx="7129549" cy="347472"/>
+            <a:off x="4506144" y="1682495"/>
+            <a:ext cx="7134167" cy="347472"/>
           </a:xfrm>
           <a:prstGeom prst="rect">
             <a:avLst/>
@@ -10081,8 +10081,8 @@
         </p:nvSpPr>
         <p:spPr>
           <a:xfrm>
-            <a:off x="4510762" y="2048256"/>
-            <a:ext cx="7129549" cy="292608"/>
+            <a:off x="4506144" y="2048256"/>
+            <a:ext cx="7134167" cy="292608"/>
           </a:xfrm>
           <a:prstGeom prst="rect">
             <a:avLst/>
@@ -10247,7 +10247,7 @@
         <p:spPr>
           <a:xfrm>
             <a:off x="3611880" y="4023359"/>
-            <a:ext cx="587433" cy="731520"/>
+            <a:ext cx="583738" cy="731520"/>
           </a:xfrm>
           <a:prstGeom prst="rect">
             <a:avLst/>
@@ -10263,7 +10263,7 @@
         <p:spPr>
           <a:xfrm>
             <a:off x="3611880" y="4023359"/>
-            <a:ext cx="587432" cy="731520"/>
+            <a:ext cx="583738" cy="731520"/>
           </a:xfrm>
           <a:prstGeom prst="rect">
             <a:avLst/>
@@ -10306,8 +10306,8 @@
         </p:nvSpPr>
         <p:spPr>
           <a:xfrm>
-            <a:off x="4327328" y="4023359"/>
-            <a:ext cx="3134175" cy="914400"/>
+            <a:off x="4323634" y="4023359"/>
+            <a:ext cx="3137869" cy="914400"/>
           </a:xfrm>
           <a:prstGeom prst="rect">
             <a:avLst/>
@@ -10471,7 +10471,7 @@
         <p:spPr>
           <a:xfrm>
             <a:off x="7790688" y="4023359"/>
-            <a:ext cx="582930" cy="731520"/>
+            <a:ext cx="585982" cy="731520"/>
           </a:xfrm>
           <a:prstGeom prst="rect">
             <a:avLst/>
@@ -10487,7 +10487,7 @@
         <p:spPr>
           <a:xfrm>
             <a:off x="7790688" y="4023359"/>
-            <a:ext cx="582930" cy="731520"/>
+            <a:ext cx="585981" cy="731520"/>
           </a:xfrm>
           <a:prstGeom prst="rect">
             <a:avLst/>
@@ -10530,8 +10530,8 @@
         </p:nvSpPr>
         <p:spPr>
           <a:xfrm>
-            <a:off x="8501634" y="4023359"/>
-            <a:ext cx="3138677" cy="914400"/>
+            <a:off x="8504685" y="4023359"/>
+            <a:ext cx="3135626" cy="914400"/>
           </a:xfrm>
           <a:prstGeom prst="rect">
             <a:avLst/>
@@ -11475,7 +11475,7 @@
         <p:spPr>
           <a:xfrm>
             <a:off x="3611880" y="1408176"/>
-            <a:ext cx="728235" cy="914400"/>
+            <a:ext cx="732622" cy="914400"/>
           </a:xfrm>
           <a:prstGeom prst="rect">
             <a:avLst/>
@@ -11491,7 +11491,7 @@
         <p:spPr>
           <a:xfrm>
             <a:off x="3611880" y="1408176"/>
-            <a:ext cx="728234" cy="914400"/>
+            <a:ext cx="732621" cy="914400"/>
           </a:xfrm>
           <a:prstGeom prst="rect">
             <a:avLst/>
@@ -11534,8 +11534,8 @@
         </p:nvSpPr>
         <p:spPr>
           <a:xfrm>
-            <a:off x="4504706" y="1408176"/>
-            <a:ext cx="7135605" cy="256032"/>
+            <a:off x="4509093" y="1408176"/>
+            <a:ext cx="7131218" cy="256032"/>
           </a:xfrm>
           <a:prstGeom prst="rect">
             <a:avLst/>
@@ -11568,8 +11568,8 @@
         </p:nvSpPr>
         <p:spPr>
           <a:xfrm>
-            <a:off x="4504706" y="1682495"/>
-            <a:ext cx="7135605" cy="347472"/>
+            <a:off x="4509093" y="1682495"/>
+            <a:ext cx="7131218" cy="347472"/>
           </a:xfrm>
           <a:prstGeom prst="rect">
             <a:avLst/>
@@ -11607,8 +11607,8 @@
         </p:nvSpPr>
         <p:spPr>
           <a:xfrm>
-            <a:off x="4504706" y="2048256"/>
-            <a:ext cx="7135605" cy="292608"/>
+            <a:off x="4509093" y="2048256"/>
+            <a:ext cx="7131218" cy="292608"/>
           </a:xfrm>
           <a:prstGeom prst="rect">
             <a:avLst/>
@@ -11773,7 +11773,7 @@
         <p:spPr>
           <a:xfrm>
             <a:off x="3611880" y="4041648"/>
-            <a:ext cx="727587" cy="914400"/>
+            <a:ext cx="731520" cy="914400"/>
           </a:xfrm>
           <a:prstGeom prst="rect">
             <a:avLst/>
@@ -11789,7 +11789,7 @@
         <p:spPr>
           <a:xfrm>
             <a:off x="3611880" y="4041648"/>
-            <a:ext cx="727587" cy="914400"/>
+            <a:ext cx="731520" cy="914400"/>
           </a:xfrm>
           <a:prstGeom prst="rect">
             <a:avLst/>
@@ -11832,8 +11832,8 @@
         </p:nvSpPr>
         <p:spPr>
           <a:xfrm>
-            <a:off x="4504059" y="4041648"/>
-            <a:ext cx="7136252" cy="256032"/>
+            <a:off x="4507992" y="4041648"/>
+            <a:ext cx="7132320" cy="256032"/>
           </a:xfrm>
           <a:prstGeom prst="rect">
             <a:avLst/>
@@ -11866,8 +11866,8 @@
         </p:nvSpPr>
         <p:spPr>
           <a:xfrm>
-            <a:off x="4504059" y="4315968"/>
-            <a:ext cx="7136252" cy="347472"/>
+            <a:off x="4507992" y="4315968"/>
+            <a:ext cx="7132320" cy="347472"/>
           </a:xfrm>
           <a:prstGeom prst="rect">
             <a:avLst/>
@@ -11905,8 +11905,8 @@
         </p:nvSpPr>
         <p:spPr>
           <a:xfrm>
-            <a:off x="4504059" y="4681727"/>
-            <a:ext cx="7136252" cy="292608"/>
+            <a:off x="4507992" y="4681727"/>
+            <a:ext cx="7132320" cy="292608"/>
           </a:xfrm>
           <a:prstGeom prst="rect">
             <a:avLst/>
@@ -12797,7 +12797,7 @@
         <p:spPr>
           <a:xfrm>
             <a:off x="3611880" y="1408176"/>
-            <a:ext cx="729673" cy="914400"/>
+            <a:ext cx="733377" cy="914400"/>
           </a:xfrm>
           <a:prstGeom prst="rect">
             <a:avLst/>
@@ -12813,7 +12813,7 @@
         <p:spPr>
           <a:xfrm>
             <a:off x="3611880" y="1408176"/>
-            <a:ext cx="729672" cy="914400"/>
+            <a:ext cx="733376" cy="914400"/>
           </a:xfrm>
           <a:prstGeom prst="rect">
             <a:avLst/>
@@ -12856,8 +12856,8 @@
         </p:nvSpPr>
         <p:spPr>
           <a:xfrm>
-            <a:off x="4506144" y="1408176"/>
-            <a:ext cx="7134167" cy="256032"/>
+            <a:off x="4509848" y="1408176"/>
+            <a:ext cx="7130463" cy="256032"/>
           </a:xfrm>
           <a:prstGeom prst="rect">
             <a:avLst/>
@@ -12890,8 +12890,8 @@
         </p:nvSpPr>
         <p:spPr>
           <a:xfrm>
-            <a:off x="4506144" y="1682495"/>
-            <a:ext cx="7134167" cy="347472"/>
+            <a:off x="4509848" y="1682495"/>
+            <a:ext cx="7130463" cy="347472"/>
           </a:xfrm>
           <a:prstGeom prst="rect">
             <a:avLst/>
@@ -12929,8 +12929,8 @@
         </p:nvSpPr>
         <p:spPr>
           <a:xfrm>
-            <a:off x="4506144" y="2048256"/>
-            <a:ext cx="7134167" cy="292608"/>
+            <a:off x="4509848" y="2048256"/>
+            <a:ext cx="7130463" cy="292608"/>
           </a:xfrm>
           <a:prstGeom prst="rect">
             <a:avLst/>
@@ -13095,7 +13095,7 @@
         <p:spPr>
           <a:xfrm>
             <a:off x="3611880" y="4023359"/>
-            <a:ext cx="583738" cy="731520"/>
+            <a:ext cx="586701" cy="731520"/>
           </a:xfrm>
           <a:prstGeom prst="rect">
             <a:avLst/>
@@ -13111,7 +13111,7 @@
         <p:spPr>
           <a:xfrm>
             <a:off x="3611880" y="4023359"/>
-            <a:ext cx="583738" cy="731520"/>
+            <a:ext cx="586701" cy="731520"/>
           </a:xfrm>
           <a:prstGeom prst="rect">
             <a:avLst/>
@@ -13154,8 +13154,8 @@
         </p:nvSpPr>
         <p:spPr>
           <a:xfrm>
-            <a:off x="4323634" y="4023359"/>
-            <a:ext cx="3137869" cy="914400"/>
+            <a:off x="4326597" y="4023359"/>
+            <a:ext cx="3134906" cy="914400"/>
           </a:xfrm>
           <a:prstGeom prst="rect">
             <a:avLst/>
@@ -13319,7 +13319,7 @@
         <p:spPr>
           <a:xfrm>
             <a:off x="7790688" y="4023359"/>
-            <a:ext cx="587433" cy="731520"/>
+            <a:ext cx="583738" cy="731520"/>
           </a:xfrm>
           <a:prstGeom prst="rect">
             <a:avLst/>
@@ -13335,7 +13335,7 @@
         <p:spPr>
           <a:xfrm>
             <a:off x="7790688" y="4023359"/>
-            <a:ext cx="587432" cy="731520"/>
+            <a:ext cx="583738" cy="731520"/>
           </a:xfrm>
           <a:prstGeom prst="rect">
             <a:avLst/>
@@ -13378,8 +13378,8 @@
         </p:nvSpPr>
         <p:spPr>
           <a:xfrm>
-            <a:off x="8506136" y="4023359"/>
-            <a:ext cx="3134175" cy="914400"/>
+            <a:off x="8502442" y="4023359"/>
+            <a:ext cx="3137869" cy="914400"/>
           </a:xfrm>
           <a:prstGeom prst="rect">
             <a:avLst/>
@@ -14323,7 +14323,7 @@
         <p:spPr>
           <a:xfrm>
             <a:off x="3611880" y="1408176"/>
-            <a:ext cx="729673" cy="914400"/>
+            <a:ext cx="733377" cy="914400"/>
           </a:xfrm>
           <a:prstGeom prst="rect">
             <a:avLst/>
@@ -14339,7 +14339,7 @@
         <p:spPr>
           <a:xfrm>
             <a:off x="3611880" y="1408176"/>
-            <a:ext cx="729672" cy="914400"/>
+            <a:ext cx="733376" cy="914400"/>
           </a:xfrm>
           <a:prstGeom prst="rect">
             <a:avLst/>
@@ -14382,8 +14382,8 @@
         </p:nvSpPr>
         <p:spPr>
           <a:xfrm>
-            <a:off x="4506144" y="1408176"/>
-            <a:ext cx="7134167" cy="256032"/>
+            <a:off x="4509848" y="1408176"/>
+            <a:ext cx="7130463" cy="256032"/>
           </a:xfrm>
           <a:prstGeom prst="rect">
             <a:avLst/>
@@ -14416,8 +14416,8 @@
         </p:nvSpPr>
         <p:spPr>
           <a:xfrm>
-            <a:off x="4506144" y="1682495"/>
-            <a:ext cx="7134167" cy="347472"/>
+            <a:off x="4509848" y="1682495"/>
+            <a:ext cx="7130463" cy="347472"/>
           </a:xfrm>
           <a:prstGeom prst="rect">
             <a:avLst/>
@@ -14455,8 +14455,8 @@
         </p:nvSpPr>
         <p:spPr>
           <a:xfrm>
-            <a:off x="4506144" y="2048256"/>
-            <a:ext cx="7134167" cy="292608"/>
+            <a:off x="4509848" y="2048256"/>
+            <a:ext cx="7130463" cy="292608"/>
           </a:xfrm>
           <a:prstGeom prst="rect">
             <a:avLst/>
@@ -14861,7 +14861,7 @@
         <p:spPr>
           <a:xfrm>
             <a:off x="7790688" y="4023359"/>
-            <a:ext cx="583738" cy="731520"/>
+            <a:ext cx="586701" cy="731520"/>
           </a:xfrm>
           <a:prstGeom prst="rect">
             <a:avLst/>
@@ -14877,7 +14877,7 @@
         <p:spPr>
           <a:xfrm>
             <a:off x="7790688" y="4023359"/>
-            <a:ext cx="583738" cy="731520"/>
+            <a:ext cx="586701" cy="731520"/>
           </a:xfrm>
           <a:prstGeom prst="rect">
             <a:avLst/>
@@ -14920,8 +14920,8 @@
         </p:nvSpPr>
         <p:spPr>
           <a:xfrm>
-            <a:off x="8502442" y="4023359"/>
-            <a:ext cx="3137869" cy="914400"/>
+            <a:off x="8505405" y="4023359"/>
+            <a:ext cx="3134906" cy="914400"/>
           </a:xfrm>
           <a:prstGeom prst="rect">
             <a:avLst/>
@@ -17690,7 +17690,7 @@
       </p:sp>
       <p:pic>
         <p:nvPicPr>
-          <p:cNvPr id="24" name="Picture 23" descr="_ph-saudi-alqasabi.png"/>
+          <p:cNvPr id="24" name="Picture 23" descr="saudi-alqasabi.png"/>
           <p:cNvPicPr>
             <a:picLocks noChangeAspect="1"/>
           </p:cNvPicPr>
@@ -17929,7 +17929,7 @@
         <p:spPr>
           <a:xfrm>
             <a:off x="7790688" y="4023359"/>
-            <a:ext cx="583738" cy="731520"/>
+            <a:ext cx="586701" cy="731520"/>
           </a:xfrm>
           <a:prstGeom prst="rect">
             <a:avLst/>
@@ -17945,7 +17945,7 @@
         <p:spPr>
           <a:xfrm>
             <a:off x="7790688" y="4023359"/>
-            <a:ext cx="583738" cy="731520"/>
+            <a:ext cx="586701" cy="731520"/>
           </a:xfrm>
           <a:prstGeom prst="rect">
             <a:avLst/>
@@ -17988,8 +17988,8 @@
         </p:nvSpPr>
         <p:spPr>
           <a:xfrm>
-            <a:off x="8502442" y="4023359"/>
-            <a:ext cx="3137869" cy="914400"/>
+            <a:off x="8505405" y="4023359"/>
+            <a:ext cx="3134906" cy="914400"/>
           </a:xfrm>
           <a:prstGeom prst="rect">
             <a:avLst/>
@@ -19419,7 +19419,7 @@
         <p:spPr>
           <a:xfrm>
             <a:off x="3611880" y="1408176"/>
-            <a:ext cx="733530" cy="914400"/>
+            <a:ext cx="723481" cy="914400"/>
           </a:xfrm>
           <a:prstGeom prst="rect">
             <a:avLst/>
@@ -19435,7 +19435,7 @@
         <p:spPr>
           <a:xfrm>
             <a:off x="3611880" y="1408176"/>
-            <a:ext cx="733529" cy="914400"/>
+            <a:ext cx="723481" cy="914400"/>
           </a:xfrm>
           <a:prstGeom prst="rect">
             <a:avLst/>
@@ -19478,8 +19478,8 @@
         </p:nvSpPr>
         <p:spPr>
           <a:xfrm>
-            <a:off x="4510001" y="1408176"/>
-            <a:ext cx="7130310" cy="256032"/>
+            <a:off x="4499953" y="1408176"/>
+            <a:ext cx="7140358" cy="256032"/>
           </a:xfrm>
           <a:prstGeom prst="rect">
             <a:avLst/>
@@ -19512,8 +19512,8 @@
         </p:nvSpPr>
         <p:spPr>
           <a:xfrm>
-            <a:off x="4510001" y="1682495"/>
-            <a:ext cx="7130310" cy="347472"/>
+            <a:off x="4499953" y="1682495"/>
+            <a:ext cx="7140358" cy="347472"/>
           </a:xfrm>
           <a:prstGeom prst="rect">
             <a:avLst/>
@@ -19551,8 +19551,8 @@
         </p:nvSpPr>
         <p:spPr>
           <a:xfrm>
-            <a:off x="4510001" y="2048256"/>
-            <a:ext cx="7130310" cy="292608"/>
+            <a:off x="4499953" y="2048256"/>
+            <a:ext cx="7140358" cy="292608"/>
           </a:xfrm>
           <a:prstGeom prst="rect">
             <a:avLst/>
@@ -23809,7 +23809,7 @@
         <p:spPr>
           <a:xfrm>
             <a:off x="3611880" y="1389888"/>
-            <a:ext cx="586824" cy="731520"/>
+            <a:ext cx="578785" cy="731520"/>
           </a:xfrm>
           <a:prstGeom prst="rect">
             <a:avLst/>
@@ -23825,7 +23825,7 @@
         <p:spPr>
           <a:xfrm>
             <a:off x="3611880" y="1389888"/>
-            <a:ext cx="586823" cy="731520"/>
+            <a:ext cx="578785" cy="731520"/>
           </a:xfrm>
           <a:prstGeom prst="rect">
             <a:avLst/>
@@ -23868,8 +23868,8 @@
         </p:nvSpPr>
         <p:spPr>
           <a:xfrm>
-            <a:off x="4326719" y="1389888"/>
-            <a:ext cx="3134784" cy="914400"/>
+            <a:off x="4318681" y="1389888"/>
+            <a:ext cx="3142822" cy="914400"/>
           </a:xfrm>
           <a:prstGeom prst="rect">
             <a:avLst/>
@@ -25583,7 +25583,7 @@
       </p:sp>
       <p:pic>
         <p:nvPicPr>
-          <p:cNvPr id="17" name="Picture 16" descr="_ph-bloc-virkkunen.png"/>
+          <p:cNvPr id="17" name="Picture 16" descr="bloc-virkkunen.png"/>
           <p:cNvPicPr>
             <a:picLocks noChangeAspect="1"/>
           </p:cNvPicPr>
@@ -25881,7 +25881,7 @@
       </p:sp>
       <p:pic>
         <p:nvPicPr>
-          <p:cNvPr id="25" name="Picture 24" descr="_ph-bloc-sefcovic.png"/>
+          <p:cNvPr id="25" name="Picture 24" descr="bloc-sefcovic.png"/>
           <p:cNvPicPr>
             <a:picLocks noChangeAspect="1"/>
           </p:cNvPicPr>
@@ -26962,7 +26962,7 @@
       </p:sp>
       <p:pic>
         <p:nvPicPr>
-          <p:cNvPr id="18" name="Picture 17" descr="_ph-bloc-mataboge.png"/>
+          <p:cNvPr id="18" name="Picture 17" descr="bloc-mataboge.png"/>
           <p:cNvPicPr>
             <a:picLocks noChangeAspect="1"/>
           </p:cNvPicPr>
@@ -27260,7 +27260,7 @@
       </p:sp>
       <p:pic>
         <p:nvPicPr>
-          <p:cNvPr id="26" name="Picture 25" descr="_ph-bloc-belobe.png"/>
+          <p:cNvPr id="26" name="Picture 25" descr="bloc-belobe.png"/>
           <p:cNvPicPr>
             <a:picLocks noChangeAspect="1"/>
           </p:cNvPicPr>
@@ -33878,7 +33878,7 @@
       </p:sp>
       <p:pic>
         <p:nvPicPr>
-          <p:cNvPr id="16" name="Picture 15" descr="_ph-argentina-genua.png"/>
+          <p:cNvPr id="16" name="Picture 15" descr="argentina-genua.png"/>
           <p:cNvPicPr>
             <a:picLocks noChangeAspect="1"/>
           </p:cNvPicPr>
@@ -33893,7 +33893,7 @@
         <p:spPr>
           <a:xfrm>
             <a:off x="3611880" y="1408176"/>
-            <a:ext cx="731520" cy="914400"/>
+            <a:ext cx="730332" cy="914400"/>
           </a:xfrm>
           <a:prstGeom prst="rect">
             <a:avLst/>
@@ -33909,7 +33909,7 @@
         <p:spPr>
           <a:xfrm>
             <a:off x="3611880" y="1408176"/>
-            <a:ext cx="731520" cy="914400"/>
+            <a:ext cx="730332" cy="914400"/>
           </a:xfrm>
           <a:prstGeom prst="rect">
             <a:avLst/>
@@ -33952,8 +33952,8 @@
         </p:nvSpPr>
         <p:spPr>
           <a:xfrm>
-            <a:off x="4507992" y="1408176"/>
-            <a:ext cx="7132320" cy="256032"/>
+            <a:off x="4506804" y="1408176"/>
+            <a:ext cx="7133507" cy="256032"/>
           </a:xfrm>
           <a:prstGeom prst="rect">
             <a:avLst/>
@@ -33986,8 +33986,8 @@
         </p:nvSpPr>
         <p:spPr>
           <a:xfrm>
-            <a:off x="4507992" y="1682495"/>
-            <a:ext cx="7132320" cy="347472"/>
+            <a:off x="4506804" y="1682495"/>
+            <a:ext cx="7133507" cy="347472"/>
           </a:xfrm>
           <a:prstGeom prst="rect">
             <a:avLst/>
@@ -34025,8 +34025,8 @@
         </p:nvSpPr>
         <p:spPr>
           <a:xfrm>
-            <a:off x="4507992" y="2048256"/>
-            <a:ext cx="7132320" cy="292608"/>
+            <a:off x="4506804" y="2048256"/>
+            <a:ext cx="7133507" cy="292608"/>
           </a:xfrm>
           <a:prstGeom prst="rect">
             <a:avLst/>
@@ -34207,7 +34207,7 @@
         <p:spPr>
           <a:xfrm>
             <a:off x="3611880" y="4023359"/>
-            <a:ext cx="584481" cy="731520"/>
+            <a:ext cx="587433" cy="731520"/>
           </a:xfrm>
           <a:prstGeom prst="rect">
             <a:avLst/>
@@ -34223,7 +34223,7 @@
         <p:spPr>
           <a:xfrm>
             <a:off x="3611880" y="4023359"/>
-            <a:ext cx="584480" cy="731520"/>
+            <a:ext cx="587432" cy="731520"/>
           </a:xfrm>
           <a:prstGeom prst="rect">
             <a:avLst/>
@@ -34266,8 +34266,8 @@
         </p:nvSpPr>
         <p:spPr>
           <a:xfrm>
-            <a:off x="4324376" y="4023359"/>
-            <a:ext cx="3137127" cy="914400"/>
+            <a:off x="4327328" y="4023359"/>
+            <a:ext cx="3134175" cy="914400"/>
           </a:xfrm>
           <a:prstGeom prst="rect">
             <a:avLst/>
@@ -34416,7 +34416,7 @@
       </p:sp>
       <p:pic>
         <p:nvPicPr>
-          <p:cNvPr id="29" name="Picture 28" descr="_ph-argentina-lavigne.png"/>
+          <p:cNvPr id="29" name="Picture 28" descr="argentina-lavigne.png"/>
           <p:cNvPicPr>
             <a:picLocks noChangeAspect="1"/>
           </p:cNvPicPr>
@@ -34431,7 +34431,7 @@
         <p:spPr>
           <a:xfrm>
             <a:off x="7790688" y="4023359"/>
-            <a:ext cx="585216" cy="731520"/>
+            <a:ext cx="584082" cy="731520"/>
           </a:xfrm>
           <a:prstGeom prst="rect">
             <a:avLst/>
@@ -34447,7 +34447,7 @@
         <p:spPr>
           <a:xfrm>
             <a:off x="7790688" y="4023359"/>
-            <a:ext cx="585216" cy="731520"/>
+            <a:ext cx="584081" cy="731520"/>
           </a:xfrm>
           <a:prstGeom prst="rect">
             <a:avLst/>
@@ -34490,8 +34490,8 @@
         </p:nvSpPr>
         <p:spPr>
           <a:xfrm>
-            <a:off x="8503920" y="4023359"/>
-            <a:ext cx="3136391" cy="914400"/>
+            <a:off x="8502785" y="4023359"/>
+            <a:ext cx="3137526" cy="914400"/>
           </a:xfrm>
           <a:prstGeom prst="rect">
             <a:avLst/>
@@ -35444,7 +35444,7 @@
         <p:spPr>
           <a:xfrm>
             <a:off x="3611880" y="1389888"/>
-            <a:ext cx="586097" cy="731520"/>
+            <a:ext cx="581691" cy="731520"/>
           </a:xfrm>
           <a:prstGeom prst="rect">
             <a:avLst/>
@@ -35460,7 +35460,7 @@
         <p:spPr>
           <a:xfrm>
             <a:off x="3611880" y="1389888"/>
-            <a:ext cx="586097" cy="731520"/>
+            <a:ext cx="581690" cy="731520"/>
           </a:xfrm>
           <a:prstGeom prst="rect">
             <a:avLst/>
@@ -35503,8 +35503,8 @@
         </p:nvSpPr>
         <p:spPr>
           <a:xfrm>
-            <a:off x="4325993" y="1389888"/>
-            <a:ext cx="3135510" cy="914400"/>
+            <a:off x="4321586" y="1389888"/>
+            <a:ext cx="3139917" cy="914400"/>
           </a:xfrm>
           <a:prstGeom prst="rect">
             <a:avLst/>
@@ -35668,7 +35668,7 @@
         <p:spPr>
           <a:xfrm>
             <a:off x="7790688" y="1389888"/>
-            <a:ext cx="584481" cy="731520"/>
+            <a:ext cx="587433" cy="731520"/>
           </a:xfrm>
           <a:prstGeom prst="rect">
             <a:avLst/>
@@ -35684,7 +35684,7 @@
         <p:spPr>
           <a:xfrm>
             <a:off x="7790688" y="1389888"/>
-            <a:ext cx="584480" cy="731520"/>
+            <a:ext cx="587432" cy="731520"/>
           </a:xfrm>
           <a:prstGeom prst="rect">
             <a:avLst/>
@@ -35727,8 +35727,8 @@
         </p:nvSpPr>
         <p:spPr>
           <a:xfrm>
-            <a:off x="8503184" y="1389888"/>
-            <a:ext cx="3137127" cy="914400"/>
+            <a:off x="8506136" y="1389888"/>
+            <a:ext cx="3134175" cy="914400"/>
           </a:xfrm>
           <a:prstGeom prst="rect">
             <a:avLst/>
@@ -35962,7 +35962,7 @@
         <p:spPr>
           <a:xfrm>
             <a:off x="3611880" y="4041648"/>
-            <a:ext cx="733778" cy="914400"/>
+            <a:ext cx="730015" cy="914400"/>
           </a:xfrm>
           <a:prstGeom prst="rect">
             <a:avLst/>
@@ -35978,7 +35978,7 @@
         <p:spPr>
           <a:xfrm>
             <a:off x="3611880" y="4041648"/>
-            <a:ext cx="733777" cy="914400"/>
+            <a:ext cx="730014" cy="914400"/>
           </a:xfrm>
           <a:prstGeom prst="rect">
             <a:avLst/>
@@ -36021,8 +36021,8 @@
         </p:nvSpPr>
         <p:spPr>
           <a:xfrm>
-            <a:off x="4510249" y="4041648"/>
-            <a:ext cx="7130062" cy="256032"/>
+            <a:off x="4506486" y="4041648"/>
+            <a:ext cx="7133825" cy="256032"/>
           </a:xfrm>
           <a:prstGeom prst="rect">
             <a:avLst/>
@@ -36055,8 +36055,8 @@
         </p:nvSpPr>
         <p:spPr>
           <a:xfrm>
-            <a:off x="4510249" y="4315968"/>
-            <a:ext cx="7130062" cy="347472"/>
+            <a:off x="4506486" y="4315968"/>
+            <a:ext cx="7133825" cy="347472"/>
           </a:xfrm>
           <a:prstGeom prst="rect">
             <a:avLst/>
@@ -36094,8 +36094,8 @@
         </p:nvSpPr>
         <p:spPr>
           <a:xfrm>
-            <a:off x="4510249" y="4681727"/>
-            <a:ext cx="7130062" cy="292608"/>
+            <a:off x="4506486" y="4681727"/>
+            <a:ext cx="7133825" cy="292608"/>
           </a:xfrm>
           <a:prstGeom prst="rect">
             <a:avLst/>
@@ -36986,7 +36986,7 @@
         <p:spPr>
           <a:xfrm>
             <a:off x="3611880" y="1389888"/>
-            <a:ext cx="586740" cy="731520"/>
+            <a:ext cx="582930" cy="731520"/>
           </a:xfrm>
           <a:prstGeom prst="rect">
             <a:avLst/>
@@ -37002,7 +37002,7 @@
         <p:spPr>
           <a:xfrm>
             <a:off x="3611880" y="1389888"/>
-            <a:ext cx="586740" cy="731520"/>
+            <a:ext cx="582930" cy="731520"/>
           </a:xfrm>
           <a:prstGeom prst="rect">
             <a:avLst/>
@@ -37045,8 +37045,8 @@
         </p:nvSpPr>
         <p:spPr>
           <a:xfrm>
-            <a:off x="4326636" y="1389888"/>
-            <a:ext cx="3134868" cy="914400"/>
+            <a:off x="4322826" y="1389888"/>
+            <a:ext cx="3138677" cy="914400"/>
           </a:xfrm>
           <a:prstGeom prst="rect">
             <a:avLst/>
@@ -37210,7 +37210,7 @@
         <p:spPr>
           <a:xfrm>
             <a:off x="7790688" y="1389888"/>
-            <a:ext cx="582736" cy="731520"/>
+            <a:ext cx="585216" cy="731520"/>
           </a:xfrm>
           <a:prstGeom prst="rect">
             <a:avLst/>
@@ -37226,7 +37226,7 @@
         <p:spPr>
           <a:xfrm>
             <a:off x="7790688" y="1389888"/>
-            <a:ext cx="582736" cy="731520"/>
+            <a:ext cx="585216" cy="731520"/>
           </a:xfrm>
           <a:prstGeom prst="rect">
             <a:avLst/>
@@ -37269,8 +37269,8 @@
         </p:nvSpPr>
         <p:spPr>
           <a:xfrm>
-            <a:off x="8501440" y="1389888"/>
-            <a:ext cx="3138871" cy="914400"/>
+            <a:off x="8503920" y="1389888"/>
+            <a:ext cx="3136391" cy="914400"/>
           </a:xfrm>
           <a:prstGeom prst="rect">
             <a:avLst/>
@@ -37504,7 +37504,7 @@
         <p:spPr>
           <a:xfrm>
             <a:off x="3611880" y="4041648"/>
-            <a:ext cx="730601" cy="914400"/>
+            <a:ext cx="734291" cy="914400"/>
           </a:xfrm>
           <a:prstGeom prst="rect">
             <a:avLst/>
@@ -37520,7 +37520,7 @@
         <p:spPr>
           <a:xfrm>
             <a:off x="3611880" y="4041648"/>
-            <a:ext cx="730601" cy="914400"/>
+            <a:ext cx="734290" cy="914400"/>
           </a:xfrm>
           <a:prstGeom prst="rect">
             <a:avLst/>
@@ -37563,8 +37563,8 @@
         </p:nvSpPr>
         <p:spPr>
           <a:xfrm>
-            <a:off x="4507073" y="4041648"/>
-            <a:ext cx="7133238" cy="256032"/>
+            <a:off x="4510762" y="4041648"/>
+            <a:ext cx="7129549" cy="256032"/>
           </a:xfrm>
           <a:prstGeom prst="rect">
             <a:avLst/>
@@ -37597,8 +37597,8 @@
         </p:nvSpPr>
         <p:spPr>
           <a:xfrm>
-            <a:off x="4507073" y="4315968"/>
-            <a:ext cx="7133238" cy="347472"/>
+            <a:off x="4510762" y="4315968"/>
+            <a:ext cx="7129549" cy="347472"/>
           </a:xfrm>
           <a:prstGeom prst="rect">
             <a:avLst/>
@@ -37636,8 +37636,8 @@
         </p:nvSpPr>
         <p:spPr>
           <a:xfrm>
-            <a:off x="4507073" y="4681727"/>
-            <a:ext cx="7133238" cy="292608"/>
+            <a:off x="4510762" y="4681727"/>
+            <a:ext cx="7129549" cy="292608"/>
           </a:xfrm>
           <a:prstGeom prst="rect">
             <a:avLst/>
@@ -38512,7 +38512,7 @@
         <p:spPr>
           <a:xfrm>
             <a:off x="3611880" y="1408176"/>
-            <a:ext cx="727113" cy="914400"/>
+            <a:ext cx="731520" cy="914400"/>
           </a:xfrm>
           <a:prstGeom prst="rect">
             <a:avLst/>
@@ -38528,7 +38528,7 @@
         <p:spPr>
           <a:xfrm>
             <a:off x="3611880" y="1408176"/>
-            <a:ext cx="727113" cy="914400"/>
+            <a:ext cx="731520" cy="914400"/>
           </a:xfrm>
           <a:prstGeom prst="rect">
             <a:avLst/>
@@ -38571,8 +38571,8 @@
         </p:nvSpPr>
         <p:spPr>
           <a:xfrm>
-            <a:off x="4503585" y="1408176"/>
-            <a:ext cx="7136726" cy="256032"/>
+            <a:off x="4507992" y="1408176"/>
+            <a:ext cx="7132320" cy="256032"/>
           </a:xfrm>
           <a:prstGeom prst="rect">
             <a:avLst/>
@@ -38605,8 +38605,8 @@
         </p:nvSpPr>
         <p:spPr>
           <a:xfrm>
-            <a:off x="4503585" y="1682495"/>
-            <a:ext cx="7136726" cy="347472"/>
+            <a:off x="4507992" y="1682495"/>
+            <a:ext cx="7132320" cy="347472"/>
           </a:xfrm>
           <a:prstGeom prst="rect">
             <a:avLst/>
@@ -38644,8 +38644,8 @@
         </p:nvSpPr>
         <p:spPr>
           <a:xfrm>
-            <a:off x="4503585" y="2048256"/>
-            <a:ext cx="7136726" cy="292608"/>
+            <a:off x="4507992" y="2048256"/>
+            <a:ext cx="7132320" cy="292608"/>
           </a:xfrm>
           <a:prstGeom prst="rect">
             <a:avLst/>
@@ -39034,7 +39034,7 @@
         <p:spPr>
           <a:xfrm>
             <a:off x="7790688" y="4023359"/>
-            <a:ext cx="586097" cy="731520"/>
+            <a:ext cx="581691" cy="731520"/>
           </a:xfrm>
           <a:prstGeom prst="rect">
             <a:avLst/>
@@ -39050,7 +39050,7 @@
         <p:spPr>
           <a:xfrm>
             <a:off x="7790688" y="4023359"/>
-            <a:ext cx="586097" cy="731520"/>
+            <a:ext cx="581690" cy="731520"/>
           </a:xfrm>
           <a:prstGeom prst="rect">
             <a:avLst/>
@@ -39093,8 +39093,8 @@
         </p:nvSpPr>
         <p:spPr>
           <a:xfrm>
-            <a:off x="8504801" y="4023359"/>
-            <a:ext cx="3135510" cy="914400"/>
+            <a:off x="8500394" y="4023359"/>
+            <a:ext cx="3139917" cy="914400"/>
           </a:xfrm>
           <a:prstGeom prst="rect">
             <a:avLst/>
@@ -40038,7 +40038,7 @@
         <p:spPr>
           <a:xfrm>
             <a:off x="3611880" y="1389888"/>
-            <a:ext cx="582070" cy="731520"/>
+            <a:ext cx="585216" cy="731520"/>
           </a:xfrm>
           <a:prstGeom prst="rect">
             <a:avLst/>
@@ -40054,7 +40054,7 @@
         <p:spPr>
           <a:xfrm>
             <a:off x="3611880" y="1389888"/>
-            <a:ext cx="582069" cy="731520"/>
+            <a:ext cx="585216" cy="731520"/>
           </a:xfrm>
           <a:prstGeom prst="rect">
             <a:avLst/>
@@ -40097,8 +40097,8 @@
         </p:nvSpPr>
         <p:spPr>
           <a:xfrm>
-            <a:off x="4321965" y="1389888"/>
-            <a:ext cx="3139538" cy="914400"/>
+            <a:off x="4325112" y="1389888"/>
+            <a:ext cx="3136391" cy="914400"/>
           </a:xfrm>
           <a:prstGeom prst="rect">
             <a:avLst/>
@@ -40262,7 +40262,7 @@
         <p:spPr>
           <a:xfrm>
             <a:off x="7790688" y="1389888"/>
-            <a:ext cx="583617" cy="731520"/>
+            <a:ext cx="586824" cy="731520"/>
           </a:xfrm>
           <a:prstGeom prst="rect">
             <a:avLst/>
@@ -40278,7 +40278,7 @@
         <p:spPr>
           <a:xfrm>
             <a:off x="7790688" y="1389888"/>
-            <a:ext cx="583617" cy="731520"/>
+            <a:ext cx="586823" cy="731520"/>
           </a:xfrm>
           <a:prstGeom prst="rect">
             <a:avLst/>
@@ -40321,8 +40321,8 @@
         </p:nvSpPr>
         <p:spPr>
           <a:xfrm>
-            <a:off x="8502321" y="1389888"/>
-            <a:ext cx="3137990" cy="914400"/>
+            <a:off x="8505527" y="1389888"/>
+            <a:ext cx="3134784" cy="914400"/>
           </a:xfrm>
           <a:prstGeom prst="rect">
             <a:avLst/>
@@ -40556,7 +40556,7 @@
         <p:spPr>
           <a:xfrm>
             <a:off x="3611880" y="4023359"/>
-            <a:ext cx="583738" cy="731520"/>
+            <a:ext cx="586701" cy="731520"/>
           </a:xfrm>
           <a:prstGeom prst="rect">
             <a:avLst/>
@@ -40572,7 +40572,7 @@
         <p:spPr>
           <a:xfrm>
             <a:off x="3611880" y="4023359"/>
-            <a:ext cx="583738" cy="731520"/>
+            <a:ext cx="586701" cy="731520"/>
           </a:xfrm>
           <a:prstGeom prst="rect">
             <a:avLst/>
@@ -40615,8 +40615,8 @@
         </p:nvSpPr>
         <p:spPr>
           <a:xfrm>
-            <a:off x="4323634" y="4023359"/>
-            <a:ext cx="3137869" cy="914400"/>
+            <a:off x="4326597" y="4023359"/>
+            <a:ext cx="3134906" cy="914400"/>
           </a:xfrm>
           <a:prstGeom prst="rect">
             <a:avLst/>
@@ -40780,7 +40780,7 @@
         <p:spPr>
           <a:xfrm>
             <a:off x="7790688" y="4023359"/>
-            <a:ext cx="587433" cy="731520"/>
+            <a:ext cx="583738" cy="731520"/>
           </a:xfrm>
           <a:prstGeom prst="rect">
             <a:avLst/>
@@ -40796,7 +40796,7 @@
         <p:spPr>
           <a:xfrm>
             <a:off x="7790688" y="4023359"/>
-            <a:ext cx="587432" cy="731520"/>
+            <a:ext cx="583738" cy="731520"/>
           </a:xfrm>
           <a:prstGeom prst="rect">
             <a:avLst/>
@@ -40839,8 +40839,8 @@
         </p:nvSpPr>
         <p:spPr>
           <a:xfrm>
-            <a:off x="8506136" y="4023359"/>
-            <a:ext cx="3134175" cy="914400"/>
+            <a:off x="8502442" y="4023359"/>
+            <a:ext cx="3137869" cy="914400"/>
           </a:xfrm>
           <a:prstGeom prst="rect">
             <a:avLst/>

</xml_diff>